<commit_message>
course(metrics deck): author's hand-edit pass
Hand edits made directly in PowerPoint, committed separately so they are
preserved and attributable before the next agent revision.

Co-Authored-By: Claude Opus 4.8 (1M context) <noreply@anthropic.com>
</commit_message>
<xml_diff>
--- a/course/lectures/act-1-foundations/09-engineering-decision-making-and-metrics/1-9-Engineering-Decision-Making-and-Metrics.pptx
+++ b/course/lectures/act-1-foundations/09-engineering-decision-making-and-metrics/1-9-Engineering-Decision-Making-and-Metrics.pptx
@@ -5,38 +5,38 @@
     <p:sldMasterId id="2147483708" r:id="rId1"/>
   </p:sldMasterIdLst>
   <p:notesMasterIdLst>
-    <p:notesMasterId r:id="rId38"/>
+    <p:notesMasterId r:id="rId31"/>
   </p:notesMasterIdLst>
   <p:sldIdLst>
     <p:sldId id="701" r:id="rId2"/>
     <p:sldId id="702" r:id="rId3"/>
     <p:sldId id="703" r:id="rId4"/>
     <p:sldId id="704" r:id="rId5"/>
-    <p:sldId id="706" r:id="rId7"/>
-    <p:sldId id="707" r:id="rId8"/>
-    <p:sldId id="708" r:id="rId9"/>
-    <p:sldId id="709" r:id="rId10"/>
-    <p:sldId id="710" r:id="rId11"/>
-    <p:sldId id="711" r:id="rId12"/>
-    <p:sldId id="712" r:id="rId13"/>
-    <p:sldId id="713" r:id="rId14"/>
-    <p:sldId id="714" r:id="rId15"/>
-    <p:sldId id="715" r:id="rId16"/>
-    <p:sldId id="716" r:id="rId17"/>
-    <p:sldId id="717" r:id="rId18"/>
-    <p:sldId id="718" r:id="rId19"/>
-    <p:sldId id="719" r:id="rId20"/>
-    <p:sldId id="720" r:id="rId21"/>
-    <p:sldId id="721" r:id="rId22"/>
-    <p:sldId id="722" r:id="rId23"/>
-    <p:sldId id="723" r:id="rId24"/>
-    <p:sldId id="724" r:id="rId25"/>
-    <p:sldId id="725" r:id="rId26"/>
-    <p:sldId id="726" r:id="rId27"/>
-    <p:sldId id="727" r:id="rId28"/>
-    <p:sldId id="728" r:id="rId29"/>
-    <p:sldId id="729" r:id="rId30"/>
-    <p:sldId id="730" r:id="rId31"/>
+    <p:sldId id="706" r:id="rId6"/>
+    <p:sldId id="707" r:id="rId7"/>
+    <p:sldId id="708" r:id="rId8"/>
+    <p:sldId id="709" r:id="rId9"/>
+    <p:sldId id="710" r:id="rId10"/>
+    <p:sldId id="711" r:id="rId11"/>
+    <p:sldId id="712" r:id="rId12"/>
+    <p:sldId id="713" r:id="rId13"/>
+    <p:sldId id="714" r:id="rId14"/>
+    <p:sldId id="715" r:id="rId15"/>
+    <p:sldId id="716" r:id="rId16"/>
+    <p:sldId id="717" r:id="rId17"/>
+    <p:sldId id="718" r:id="rId18"/>
+    <p:sldId id="719" r:id="rId19"/>
+    <p:sldId id="720" r:id="rId20"/>
+    <p:sldId id="721" r:id="rId21"/>
+    <p:sldId id="722" r:id="rId22"/>
+    <p:sldId id="723" r:id="rId23"/>
+    <p:sldId id="724" r:id="rId24"/>
+    <p:sldId id="725" r:id="rId25"/>
+    <p:sldId id="726" r:id="rId26"/>
+    <p:sldId id="727" r:id="rId27"/>
+    <p:sldId id="728" r:id="rId28"/>
+    <p:sldId id="729" r:id="rId29"/>
+    <p:sldId id="730" r:id="rId30"/>
   </p:sldIdLst>
   <p:sldSz cx="9144000" cy="6858000" type="screen4x3"/>
   <p:notesSz cx="6858000" cy="9144000"/>
@@ -227,7 +227,7 @@
           </a:lstStyle>
           <a:p>
             <a:fld id="{27E8B4C4-0720-F64E-9EEE-9472CF165DC6}" type="datetimeFigureOut">
-              <a:t>9/18/26</a:t>
+              <a:t>9/21/26</a:t>
             </a:fld>
             <a:endParaRPr lang="en-US"/>
           </a:p>
@@ -527,7 +527,7 @@
           <a:p>
             <a:r>
               <a:rPr dirty="0"/>
-              <a:t xml:space="preserve">0.5 minutes — </a:t>
+              <a:t>0.5 minutes — </a:t>
             </a:r>
             <a:r>
               <a:rPr i="1" dirty="0"/>
@@ -553,6 +553,9 @@
       </p:sp>
     </p:spTree>
   </p:cSld>
+  <p:clrMapOvr>
+    <a:masterClrMapping/>
+  </p:clrMapOvr>
 </p:notes>
 </file>
 
@@ -589,34 +592,30 @@
           <a:lstStyle/>
           <a:p>
             <a:r>
-              <a:t>2 minutes — Evidence gets selected because it distinguishes the alternatives.</a:t>
-            </a:r>
-          </a:p>
-          <a:p/>
-          <a:p>
-            <a:r>
-              <a:t>- Don't begin with 'what can I measure?' Begin with the uncertainty preventing the decision. If learning the answer wouldn't change what you choose, the measurement may have little decision value.</a:t>
-            </a:r>
-          </a:p>
-          <a:p>
-            <a:r>
-              <a:t>- Walk the model: both strategies fit the memory budget (KNOWN); what separates them is whether the larger cache materially improves latency under the expected workload (UNCERTAIN).</a:t>
-            </a:r>
-          </a:p>
-          <a:p>
-            <a:r>
-              <a:t>- Ask the room what evidence would actually change the choice; only then click to reveal: run both mechanisms under a representative workload and compare the latency distributions.</a:t>
-            </a:r>
-          </a:p>
-          <a:p>
-            <a:r>
-              <a:t>- Design callback, and the handbook's buy-information framing: measurement is bought to remove the uncertainty that blocks the decision.</a:t>
+              <a:rPr dirty="0"/>
+              <a:t>0.3 minutes — </a:t>
+            </a:r>
+            <a:r>
+              <a:rPr i="1" dirty="0"/>
+              <a:t>Name Section 2. The centre of the lecture begins here.</a:t>
+            </a:r>
+          </a:p>
+          <a:p>
+            <a:endParaRPr dirty="0"/>
+          </a:p>
+          <a:p>
+            <a:r>
+              <a:rPr dirty="0"/>
+              <a:t>- Do NOT title or gloss this as 'measurement is a model' — the metric holds the modeling choice.</a:t>
             </a:r>
           </a:p>
         </p:txBody>
       </p:sp>
     </p:spTree>
   </p:cSld>
+  <p:clrMapOvr>
+    <a:masterClrMapping/>
+  </p:clrMapOvr>
 </p:notes>
 </file>
 
@@ -654,11 +653,7 @@
           <a:p>
             <a:r>
               <a:rPr dirty="0"/>
-              <a:t xml:space="preserve">0.3 minutes — </a:t>
-            </a:r>
-            <a:r>
-              <a:rPr i="1" dirty="0"/>
-              <a:t>Name Section 2. The centre of the lecture begins here.</a:t>
+              <a:t>3 minutes — The canonical quantitative chain, unpacked carefully. Terminology must be exact.</a:t>
             </a:r>
           </a:p>
           <a:p>
@@ -667,13 +662,34 @@
           <a:p>
             <a:r>
               <a:rPr dirty="0"/>
-              <a:t>- Do NOT title or gloss this as 'measurement is a model' — the metric holds the modeling choice.</a:t>
+              <a:t>- Property: what we care about. Metric: a model connecting the property to observations we can obtain. Measurement: an observation from applying the metric under conditions. Evidence: what that measurement supports about the property.</a:t>
+            </a:r>
+          </a:p>
+          <a:p>
+            <a:r>
+              <a:rPr dirty="0"/>
+              <a:t>- NEVER say 'measurement is a model.' The metric contains the modeling choice; the measurement supplies values.</a:t>
+            </a:r>
+          </a:p>
+          <a:p>
+            <a:r>
+              <a:rPr dirty="0"/>
+              <a:t>- Deliberate Validation callback — same boxes, same verbs as its evidence-strength slide.</a:t>
+            </a:r>
+          </a:p>
+          <a:p>
+            <a:r>
+              <a:rPr dirty="0"/>
+              <a:t>- (from slide) You met this chain in Validation. Today we unpack each link.</a:t>
             </a:r>
           </a:p>
         </p:txBody>
       </p:sp>
     </p:spTree>
   </p:cSld>
+  <p:clrMapOvr>
+    <a:masterClrMapping/>
+  </p:clrMapOvr>
 </p:notes>
 </file>
 
@@ -710,34 +726,46 @@
           <a:lstStyle/>
           <a:p>
             <a:r>
-              <a:t>3 minutes — The canonical quantitative chain, unpacked carefully. Terminology must be exact.</a:t>
-            </a:r>
-          </a:p>
-          <a:p/>
-          <a:p>
-            <a:r>
-              <a:t>- Property: what we care about. Metric: a model connecting the property to observations we can obtain. Measurement: an observation from applying the metric under conditions. Evidence: what that measurement supports about the property.</a:t>
-            </a:r>
-          </a:p>
-          <a:p>
-            <a:r>
-              <a:t>- NEVER say 'measurement is a model.' The metric contains the modeling choice; the measurement supplies values.</a:t>
-            </a:r>
-          </a:p>
-          <a:p>
-            <a:r>
-              <a:t>- Deliberate Validation callback — same boxes, same verbs as its evidence-strength slide.</a:t>
-            </a:r>
-          </a:p>
-          <a:p>
-            <a:r>
-              <a:t>- (from slide) You met this chain in Validation. Today we unpack each link.</a:t>
+              <a:rPr dirty="0"/>
+              <a:t>3 minutes — Work one operationalization end to end; define the word once.</a:t>
+            </a:r>
+          </a:p>
+          <a:p>
+            <a:endParaRPr dirty="0"/>
+          </a:p>
+          <a:p>
+            <a:r>
+              <a:rPr dirty="0"/>
+              <a:t>- Responsiveness is abstract; p99-under-workload-W is the chosen observable aspect; 420 </a:t>
+            </a:r>
+            <a:r>
+              <a:rPr dirty="0" err="1"/>
+              <a:t>ms</a:t>
+            </a:r>
+            <a:r>
+              <a:rPr dirty="0"/>
+              <a:t> is what applying it produced.</a:t>
+            </a:r>
+          </a:p>
+          <a:p>
+            <a:r>
+              <a:rPr dirty="0"/>
+              <a:t>- Dwell on the right-hand point: the metric is a representation, not the property. Other metrics would represent other aspects.</a:t>
+            </a:r>
+          </a:p>
+          <a:p>
+            <a:r>
+              <a:rPr dirty="0"/>
+              <a:t>- (from slide) The metric chooses which aspect of the property becomes observable.</a:t>
             </a:r>
           </a:p>
         </p:txBody>
       </p:sp>
     </p:spTree>
   </p:cSld>
+  <p:clrMapOvr>
+    <a:masterClrMapping/>
+  </p:clrMapOvr>
 </p:notes>
 </file>
 
@@ -774,29 +802,42 @@
           <a:lstStyle/>
           <a:p>
             <a:r>
-              <a:t>3 minutes — Work one operationalization end to end; define the word once.</a:t>
-            </a:r>
-          </a:p>
-          <a:p/>
-          <a:p>
-            <a:r>
-              <a:t>- Responsiveness is abstract; p99-under-workload-W is the chosen observable aspect; 420 ms is what applying it produced.</a:t>
-            </a:r>
-          </a:p>
-          <a:p>
-            <a:r>
-              <a:t>- Dwell on the right-hand point: the metric is a representation, not the property. Other metrics would represent other aspects.</a:t>
-            </a:r>
-          </a:p>
-          <a:p>
-            <a:r>
-              <a:t>- (from slide) The metric chooses which aspect of the property becomes observable.</a:t>
+              <a:rPr dirty="0"/>
+              <a:t>3 minutes — </a:t>
+            </a:r>
+            <a:r>
+              <a:rPr i="1" dirty="0"/>
+              <a:t>Measurement in service of a model: it fills parameters and it tests predictions.</a:t>
+            </a:r>
+          </a:p>
+          <a:p>
+            <a:endParaRPr dirty="0"/>
+          </a:p>
+          <a:p>
+            <a:r>
+              <a:rPr dirty="0"/>
+              <a:t>- This is Architecture's quantitative-model language — the latency budget students composed there.</a:t>
+            </a:r>
+          </a:p>
+          <a:p>
+            <a:r>
+              <a:rPr dirty="0"/>
+              <a:t>- Build: opens with the model and its estimates (BEFORE OBSERVATION). Click 1 — use 1: measurement PARAMETERIZES the model (the observed values and line 1). Click 2 — use 2: measurement TESTS the model’s prediction against reality (line 2 and the footer). Keep the two uses distinct; they are different operations.</a:t>
+            </a:r>
+          </a:p>
+          <a:p>
+            <a:r>
+              <a:rPr dirty="0"/>
+              <a:t>- The footer corrects any older phrasing: the metric embodies the modeling choice; the measurement supplies observations. Do not soften it.</a:t>
             </a:r>
           </a:p>
         </p:txBody>
       </p:sp>
     </p:spTree>
   </p:cSld>
+  <p:clrMapOvr>
+    <a:masterClrMapping/>
+  </p:clrMapOvr>
 </p:notes>
 </file>
 
@@ -834,11 +875,15 @@
           <a:p>
             <a:r>
               <a:rPr dirty="0"/>
-              <a:t xml:space="preserve">3 minutes — </a:t>
-            </a:r>
-            <a:r>
-              <a:rPr i="1" dirty="0"/>
-              <a:t>Measurement in service of a model: it fills parameters and it tests predictions.</a:t>
+              <a:t>3 minutes — TPS: students generate the conditions that give 420 </a:t>
+            </a:r>
+            <a:r>
+              <a:rPr dirty="0" err="1"/>
+              <a:t>ms</a:t>
+            </a:r>
+            <a:r>
+              <a:rPr dirty="0"/>
+              <a:t> meaning.</a:t>
             </a:r>
           </a:p>
           <a:p>
@@ -847,25 +892,66 @@
           <a:p>
             <a:r>
               <a:rPr dirty="0"/>
-              <a:t>- This is Architecture's quantitative-model language — the latency budget students composed there.</a:t>
-            </a:r>
-          </a:p>
-          <a:p>
+              <a:t>- Let '420 </a:t>
+            </a:r>
+            <a:r>
+              <a:rPr dirty="0" err="1"/>
+              <a:t>ms'</a:t>
+            </a:r>
             <a:r>
               <a:rPr dirty="0"/>
-              <a:t>- Build: opens with the model and its estimates (BEFORE OBSERVATION). Click 1 — use 1: measurement PARAMETERIZES the model (the observed values and line 1). Click 2 — use 2: measurement TESTS the model’s prediction against reality (line 2 and the footer). Keep the two uses distinct; they are different operations.</a:t>
+              <a:t> sit alone for a beat; run the think-pair-share on the prompt before revealing anything.</a:t>
             </a:r>
           </a:p>
           <a:p>
             <a:r>
               <a:rPr dirty="0"/>
-              <a:t>- The footer corrects any older phrasing: the metric embodies the modeling choice; the measurement supplies observations. Do not soften it.</a:t>
+              <a:t>- Animate the six questions up as the room produces them (percentile, measured where, workload, configuration, interval, request population) — do not read them out first.</a:t>
+            </a:r>
+          </a:p>
+          <a:p>
+            <a:r>
+              <a:rPr dirty="0"/>
+              <a:t>- The final click is the deliverable form: p99 = 420 </a:t>
+            </a:r>
+            <a:r>
+              <a:rPr dirty="0" err="1"/>
+              <a:t>ms</a:t>
+            </a:r>
+            <a:r>
+              <a:rPr dirty="0"/>
+              <a:t> · end-to-end · workload W · configuration C · interval T.</a:t>
+            </a:r>
+          </a:p>
+          <a:p>
+            <a:r>
+              <a:rPr dirty="0"/>
+              <a:t>- Then stop. The students should experience the move from '420 </a:t>
+            </a:r>
+            <a:r>
+              <a:rPr dirty="0" err="1"/>
+              <a:t>ms</a:t>
+            </a:r>
+            <a:r>
+              <a:rPr dirty="0"/>
+              <a:t> is a fact' to '420 </a:t>
+            </a:r>
+            <a:r>
+              <a:rPr dirty="0" err="1"/>
+              <a:t>ms</a:t>
+            </a:r>
+            <a:r>
+              <a:rPr dirty="0"/>
+              <a:t> is an observation parameterized by conditions.'</a:t>
             </a:r>
           </a:p>
         </p:txBody>
       </p:sp>
     </p:spTree>
   </p:cSld>
+  <p:clrMapOvr>
+    <a:masterClrMapping/>
+  </p:clrMapOvr>
 </p:notes>
 </file>
 
@@ -902,34 +988,36 @@
           <a:lstStyle/>
           <a:p>
             <a:r>
-              <a:t>3 minutes — TPS: students generate the conditions that give 420 ms meaning.</a:t>
-            </a:r>
-          </a:p>
-          <a:p/>
-          <a:p>
-            <a:r>
-              <a:t>- Let '420 ms' sit alone for a beat; run the think-pair-share on the prompt before revealing anything.</a:t>
-            </a:r>
-          </a:p>
-          <a:p>
-            <a:r>
-              <a:t>- Animate the six questions up as the room produces them (percentile, measured where, workload, configuration, interval, request population) — do not read them out first.</a:t>
-            </a:r>
-          </a:p>
-          <a:p>
-            <a:r>
-              <a:t>- The final click is the deliverable form: p99 = 420 ms · end-to-end · workload W · configuration C · interval T.</a:t>
-            </a:r>
-          </a:p>
-          <a:p>
-            <a:r>
-              <a:t>- Then stop. The students should experience the move from '420 ms is a fact' to '420 ms is an observation parameterized by conditions.'</a:t>
+              <a:rPr dirty="0"/>
+              <a:t>2.5 minutes — </a:t>
+            </a:r>
+            <a:r>
+              <a:rPr i="1" dirty="0"/>
+              <a:t>The scope principle, deliberately drawn like Validation's composition slide.</a:t>
+            </a:r>
+          </a:p>
+          <a:p>
+            <a:endParaRPr dirty="0"/>
+          </a:p>
+          <a:p>
+            <a:r>
+              <a:rPr dirty="0"/>
+              <a:t>- Each component meets its local check; the composed path still fails. Students saw this shape in Validation — say so.</a:t>
+            </a:r>
+          </a:p>
+          <a:p>
+            <a:r>
+              <a:rPr dirty="0"/>
+              <a:t>- Same reasoning as the latency-budget example: 90+80+140+110+100 components can compose past the budget.</a:t>
             </a:r>
           </a:p>
         </p:txBody>
       </p:sp>
     </p:spTree>
   </p:cSld>
+  <p:clrMapOvr>
+    <a:masterClrMapping/>
+  </p:clrMapOvr>
 </p:notes>
 </file>
 
@@ -967,11 +1055,11 @@
           <a:p>
             <a:r>
               <a:rPr dirty="0"/>
-              <a:t xml:space="preserve">2.5 minutes — </a:t>
+              <a:t>2.5 minutes — </a:t>
             </a:r>
             <a:r>
               <a:rPr i="1" dirty="0"/>
-              <a:t>The scope principle, deliberately drawn like Validation's composition slide.</a:t>
+              <a:t>Direct versus proxy measurement; the proxy's metric carries a bigger modeling burden.</a:t>
             </a:r>
           </a:p>
           <a:p>
@@ -980,19 +1068,22 @@
           <a:p>
             <a:r>
               <a:rPr dirty="0"/>
-              <a:t>- Each component meets its local check; the composed path still fails. Students saw this shape in Validation — say so.</a:t>
+              <a:t>- 'Relatively direct' is deliberate: no binary distinction exists in nature.</a:t>
             </a:r>
           </a:p>
           <a:p>
             <a:r>
               <a:rPr dirty="0"/>
-              <a:t>- Same reasoning as the latency-budget example: 90+80+140+110+100 components can compose past the budget.</a:t>
+              <a:t>- Usability needs several observables, none of which IS usability — the metric models how each bears on it.</a:t>
             </a:r>
           </a:p>
         </p:txBody>
       </p:sp>
     </p:spTree>
   </p:cSld>
+  <p:clrMapOvr>
+    <a:masterClrMapping/>
+  </p:clrMapOvr>
 </p:notes>
 </file>
 
@@ -1030,11 +1121,7 @@
           <a:p>
             <a:r>
               <a:rPr dirty="0"/>
-              <a:t xml:space="preserve">2.5 minutes — </a:t>
-            </a:r>
-            <a:r>
-              <a:rPr i="1" dirty="0"/>
-              <a:t>Direct versus proxy measurement; the proxy's metric carries a bigger modeling burden.</a:t>
+              <a:t>3 minutes — Every metric omits; the omission is the price of usability, not a scandal.</a:t>
             </a:r>
           </a:p>
           <a:p>
@@ -1043,19 +1130,28 @@
           <a:p>
             <a:r>
               <a:rPr dirty="0"/>
-              <a:t>- 'Relatively direct' is deliberate: no binary distinction exists in nature.</a:t>
+              <a:t>- Do not frame as anti-metrics. Reduction is why metrics are useful; it is also why interpretation is required.</a:t>
             </a:r>
           </a:p>
           <a:p>
             <a:r>
               <a:rPr dirty="0"/>
-              <a:t>- Usability needs several observables, none of which IS usability — the metric models how each bears on it.</a:t>
+              <a:t>- The defect-count row previews context-dependence: what counts, and what gets found, are both choices.</a:t>
+            </a:r>
+          </a:p>
+          <a:p>
+            <a:r>
+              <a:rPr dirty="0"/>
+              <a:t>- (from slide) Know what the metric represents — and what it leaves unresolved.</a:t>
             </a:r>
           </a:p>
         </p:txBody>
       </p:sp>
     </p:spTree>
   </p:cSld>
+  <p:clrMapOvr>
+    <a:masterClrMapping/>
+  </p:clrMapOvr>
 </p:notes>
 </file>
 
@@ -1092,29 +1188,30 @@
           <a:lstStyle/>
           <a:p>
             <a:r>
-              <a:t>3 minutes — Every metric omits; the omission is the price of usability, not a scandal.</a:t>
-            </a:r>
-          </a:p>
-          <a:p/>
-          <a:p>
-            <a:r>
-              <a:t>- Do not frame as anti-metrics. Reduction is why metrics are useful; it is also why interpretation is required.</a:t>
-            </a:r>
-          </a:p>
-          <a:p>
-            <a:r>
-              <a:t>- The defect-count row previews context-dependence: what counts, and what gets found, are both choices.</a:t>
-            </a:r>
-          </a:p>
-          <a:p>
-            <a:r>
-              <a:t>- (from slide) Know what the metric represents — and what it leaves unresolved.</a:t>
+              <a:rPr dirty="0"/>
+              <a:t>0.3 minutes — </a:t>
+            </a:r>
+            <a:r>
+              <a:rPr i="1" dirty="0"/>
+              <a:t>Name Section 3.</a:t>
+            </a:r>
+          </a:p>
+          <a:p>
+            <a:endParaRPr dirty="0"/>
+          </a:p>
+          <a:p>
+            <a:r>
+              <a:rPr dirty="0"/>
+              <a:t>- The failure modes ahead are failures of the relationship between observable and property — not arithmetic errors.</a:t>
             </a:r>
           </a:p>
         </p:txBody>
       </p:sp>
     </p:spTree>
   </p:cSld>
+  <p:clrMapOvr>
+    <a:masterClrMapping/>
+  </p:clrMapOvr>
 </p:notes>
 </file>
 
@@ -1152,11 +1249,11 @@
           <a:p>
             <a:r>
               <a:rPr dirty="0"/>
-              <a:t xml:space="preserve">0.3 minutes — </a:t>
+              <a:t>4 minutes — </a:t>
             </a:r>
             <a:r>
               <a:rPr i="1" dirty="0"/>
-              <a:t>Name Section 3.</a:t>
+              <a:t>TPS on the enormous claim; let students generate the missing context.</a:t>
             </a:r>
           </a:p>
           <a:p>
@@ -1165,13 +1262,22 @@
           <a:p>
             <a:r>
               <a:rPr dirty="0"/>
-              <a:t>- The failure modes ahead are failures of the relationship between observable and property — not arithmetic errors.</a:t>
+              <a:t>- Expect: what does productivity mean? what metric? what conditions, population, period? compared with what? what changed? what was omitted?</a:t>
+            </a:r>
+          </a:p>
+          <a:p>
+            <a:r>
+              <a:rPr dirty="0"/>
+              <a:t>- Reveal the metric, then do NOT immediately call it bad — ask what inference is being made. The next slide does the real work.</a:t>
             </a:r>
           </a:p>
         </p:txBody>
       </p:sp>
     </p:spTree>
   </p:cSld>
+  <p:clrMapOvr>
+    <a:masterClrMapping/>
+  </p:clrMapOvr>
 </p:notes>
 </file>
 
@@ -1208,35 +1314,49 @@
           <a:lstStyle/>
           <a:p>
             <a:r>
+              <a:rPr dirty="0"/>
               <a:t>2 minutes — Establish that engineering activity repeatedly terminates in a decision. This slide now also carries old slide 5's work.</a:t>
             </a:r>
           </a:p>
-          <a:p/>
-          <a:p>
-            <a:r>
+          <a:p>
+            <a:endParaRPr dirty="0"/>
+          </a:p>
+          <a:p>
+            <a:r>
+              <a:rPr dirty="0"/>
               <a:t>We have treated these as different engineering activities because they concern different objects. Requirements decides whether to make a commitment. Specification decides where responsibility belongs and which distinctions must be constrained. Architecture decides how responsibilities and interactions should be organized. Design chooses mechanisms. Validation decides whether the available evidence justifies delivery.</a:t>
             </a:r>
           </a:p>
-          <a:p/>
-          <a:p>
-            <a:r>
+          <a:p>
+            <a:endParaRPr dirty="0"/>
+          </a:p>
+          <a:p>
+            <a:r>
+              <a:rPr dirty="0"/>
               <a:t>But notice the repeated structure. Each activity eventually reaches a consequential choice. At that point the engineer has to ask the same question: given what we know, what should we do?</a:t>
             </a:r>
           </a:p>
-          <a:p/>
-          <a:p>
-            <a:r>
+          <a:p>
+            <a:endParaRPr dirty="0"/>
+          </a:p>
+          <a:p>
+            <a:r>
+              <a:rPr dirty="0"/>
               <a:t>Today we step outside the individual activities and study that reasoning itself. What do we need to know? What evidence would actually help? When does measurement provide that evidence? And how should what we learn affect the decision?</a:t>
             </a:r>
           </a:p>
-          <a:p/>
-          <a:p>
-            <a:r>
+          <a:p>
+            <a:endParaRPr dirty="0"/>
+          </a:p>
+          <a:p>
+            <a:r>
+              <a:rPr dirty="0"/>
               <a:t>- Do not explain the five examples yet; students met each decision in its own unit.</a:t>
             </a:r>
           </a:p>
           <a:p>
             <a:r>
+              <a:rPr dirty="0"/>
               <a:t>- The next slide then explains why this recurring decision problem is hard.</a:t>
             </a:r>
           </a:p>
@@ -1244,6 +1364,9 @@
       </p:sp>
     </p:spTree>
   </p:cSld>
+  <p:clrMapOvr>
+    <a:masterClrMapping/>
+  </p:clrMapOvr>
 </p:notes>
 </file>
 
@@ -1281,11 +1404,11 @@
           <a:p>
             <a:r>
               <a:rPr dirty="0"/>
-              <a:t xml:space="preserve">4 minutes — </a:t>
+              <a:t>3 minutes — </a:t>
             </a:r>
             <a:r>
               <a:rPr i="1" dirty="0"/>
-              <a:t>TPS on the enormous claim; let students generate the missing context.</a:t>
+              <a:t>The deeper lesson than 'commit counts are dumb': the assumed relationship is the object of engineering scrutiny.</a:t>
             </a:r>
           </a:p>
           <a:p>
@@ -1294,19 +1417,28 @@
           <a:p>
             <a:r>
               <a:rPr dirty="0"/>
-              <a:t>- Expect: what does productivity mean? what metric? what conditions, population, period? compared with what? what changed? what was omitted?</a:t>
+              <a:t>- Many important properties can only be reached through proxies; that is normal, not a failure.</a:t>
             </a:r>
           </a:p>
           <a:p>
             <a:r>
               <a:rPr dirty="0"/>
-              <a:t>- Reveal the metric, then do NOT immediately call it bad — ask what inference is being made. The next slide does the real work.</a:t>
+              <a:t>- Discuss what would make the relationship valid: uniform work items? stable practices? no incentive pressure?</a:t>
+            </a:r>
+          </a:p>
+          <a:p>
+            <a:r>
+              <a:rPr dirty="0"/>
+              <a:t>- Teamwork already warned about commits and tickets — use it as a callback, not a novel claim.</a:t>
             </a:r>
           </a:p>
         </p:txBody>
       </p:sp>
     </p:spTree>
   </p:cSld>
+  <p:clrMapOvr>
+    <a:masterClrMapping/>
+  </p:clrMapOvr>
 </p:notes>
 </file>
 
@@ -1344,11 +1476,11 @@
           <a:p>
             <a:r>
               <a:rPr dirty="0"/>
-              <a:t xml:space="preserve">3 minutes — </a:t>
+              <a:t>3 minutes — </a:t>
             </a:r>
             <a:r>
               <a:rPr i="1" dirty="0"/>
-              <a:t>The deeper lesson than 'commit counts are dumb': the assumed relationship is the object of engineering scrutiny.</a:t>
+              <a:t>Goodhart as relationship-destruction, not merely cheating.</a:t>
             </a:r>
           </a:p>
           <a:p>
@@ -1357,25 +1489,34 @@
           <a:p>
             <a:r>
               <a:rPr dirty="0"/>
-              <a:t>- Many important properties can only be reached through proxies; that is normal, not a failure.</a:t>
+              <a:t>- The interesting mechanism: optimizing the observable changes the practice that made the observable informative.</a:t>
             </a:r>
           </a:p>
           <a:p>
             <a:r>
               <a:rPr dirty="0"/>
-              <a:t>- Discuss what would make the relationship valid: uniform work items? stable practices? no incentive pressure?</a:t>
+              <a:t>- Connect to the surrogation reading: the metric is visible, the property is not, so attention migrates — nobody needs to act in bad faith.</a:t>
             </a:r>
           </a:p>
           <a:p>
             <a:r>
               <a:rPr dirty="0"/>
-              <a:t>- Teamwork already warned about commits and tickets — use it as a callback, not a novel claim.</a:t>
+              <a:t>- In industry, you will hear this whole family of problems called Goodhart’s Law. That’s useful vernacular. Harris and Tayler give us another distinction worth having: surrogation can happen even before anyone deliberately games or optimizes the metric.</a:t>
+            </a:r>
+          </a:p>
+          <a:p>
+            <a:r>
+              <a:rPr dirty="0"/>
+              <a:t>- State the law once, briefly; do not build a slogan slide.</a:t>
             </a:r>
           </a:p>
         </p:txBody>
       </p:sp>
     </p:spTree>
   </p:cSld>
+  <p:clrMapOvr>
+    <a:masterClrMapping/>
+  </p:clrMapOvr>
 </p:notes>
 </file>
 
@@ -1412,45 +1553,34 @@
           <a:lstStyle/>
           <a:p>
             <a:r>
-              <a:rPr dirty="0"/>
-              <a:t xml:space="preserve">3 minutes — </a:t>
-            </a:r>
-            <a:r>
-              <a:rPr i="1" dirty="0"/>
-              <a:t>Goodhart as relationship-destruction, not merely cheating.</a:t>
-            </a:r>
-          </a:p>
-          <a:p>
-            <a:endParaRPr dirty="0"/>
-          </a:p>
-          <a:p>
-            <a:r>
-              <a:rPr dirty="0"/>
-              <a:t>- The interesting mechanism: optimizing the observable changes the practice that made the observable informative.</a:t>
-            </a:r>
-          </a:p>
-          <a:p>
-            <a:r>
-              <a:rPr dirty="0"/>
-              <a:t>- Connect to the surrogation reading: the metric is visible, the property is not, so attention migrates — nobody needs to act in bad faith.</a:t>
-            </a:r>
-          </a:p>
-          <a:p>
-            <a:r>
-              <a:rPr dirty="0"/>
-              <a:t>- In industry, you will hear this whole family of problems called Goodhart’s Law. That’s useful vernacular. Harris and Tayler give us another distinction worth having: surrogation can happen even before anyone deliberately games or optimizes the metric.</a:t>
-            </a:r>
-          </a:p>
-          <a:p>
-            <a:r>
-              <a:rPr dirty="0"/>
-              <a:t>- State the law once, briefly; do not build a slogan slide.</a:t>
+              <a:t>2 minutes — Context determines evidentiary weight; two quick examples, no new machinery.</a:t>
+            </a:r>
+          </a:p>
+          <a:p>
+            <a:endParaRPr/>
+          </a:p>
+          <a:p>
+            <a:r>
+              <a:t>- Requirements churn is the Process callback: high change rate can be productive learning or weak requirements work — the question is whether the process still fits the work.</a:t>
+            </a:r>
+          </a:p>
+          <a:p>
+            <a:r>
+              <a:t>- Accelerating out of the hazards section; keep this brisk.</a:t>
+            </a:r>
+          </a:p>
+          <a:p>
+            <a:r>
+              <a:t>- (from slide) The same metric can be strong evidence in one context and weak in another.</a:t>
             </a:r>
           </a:p>
         </p:txBody>
       </p:sp>
     </p:spTree>
   </p:cSld>
+  <p:clrMapOvr>
+    <a:masterClrMapping/>
+  </p:clrMapOvr>
 </p:notes>
 </file>
 
@@ -1487,29 +1617,30 @@
           <a:lstStyle/>
           <a:p>
             <a:r>
-              <a:t>2 minutes — Context determines evidentiary weight; two quick examples, no new machinery.</a:t>
-            </a:r>
-          </a:p>
-          <a:p/>
-          <a:p>
-            <a:r>
-              <a:t>- Requirements churn is the Process callback: high change rate can be productive learning or weak requirements work — the question is whether the process still fits the work.</a:t>
-            </a:r>
-          </a:p>
-          <a:p>
-            <a:r>
-              <a:t>- Accelerating out of the hazards section; keep this brisk.</a:t>
-            </a:r>
-          </a:p>
-          <a:p>
-            <a:r>
-              <a:t>- (from slide) The same metric can be strong evidence in one context and weak in another.</a:t>
+              <a:rPr dirty="0"/>
+              <a:t>1.5 minutes — </a:t>
+            </a:r>
+            <a:r>
+              <a:rPr i="1" dirty="0"/>
+              <a:t>The usable residue of the metrics centre: four questions, no framework.</a:t>
+            </a:r>
+          </a:p>
+          <a:p>
+            <a:endParaRPr dirty="0"/>
+          </a:p>
+          <a:p>
+            <a:r>
+              <a:rPr dirty="0"/>
+              <a:t>- Resist expansion; the value of this list is that students will actually remember it.</a:t>
             </a:r>
           </a:p>
         </p:txBody>
       </p:sp>
     </p:spTree>
   </p:cSld>
+  <p:clrMapOvr>
+    <a:masterClrMapping/>
+  </p:clrMapOvr>
 </p:notes>
 </file>
 
@@ -1547,26 +1678,23 @@
           <a:p>
             <a:r>
               <a:rPr dirty="0"/>
-              <a:t xml:space="preserve">1.5 minutes — </a:t>
+              <a:t>0.3 minutes — </a:t>
             </a:r>
             <a:r>
               <a:rPr i="1" dirty="0"/>
-              <a:t>The usable residue of the metrics centre: four questions, no framework.</a:t>
+              <a:t>Name Section 4. Accelerate: Validation taught much of the judgment material.</a:t>
             </a:r>
           </a:p>
           <a:p>
             <a:endParaRPr dirty="0"/>
-          </a:p>
-          <a:p>
-            <a:r>
-              <a:rPr dirty="0"/>
-              <a:t>- Resist expansion; the value of this list is that students will actually remember it.</a:t>
-            </a:r>
           </a:p>
         </p:txBody>
       </p:sp>
     </p:spTree>
   </p:cSld>
+  <p:clrMapOvr>
+    <a:masterClrMapping/>
+  </p:clrMapOvr>
 </p:notes>
 </file>
 
@@ -1603,21 +1731,39 @@
           <a:lstStyle/>
           <a:p>
             <a:r>
-              <a:rPr dirty="0"/>
-              <a:t xml:space="preserve">0.3 minutes — </a:t>
-            </a:r>
-            <a:r>
-              <a:rPr i="1" dirty="0"/>
-              <a:t>Name Section 4. Accelerate: Validation taught much of the judgment material.</a:t>
-            </a:r>
-          </a:p>
-          <a:p>
-            <a:endParaRPr dirty="0"/>
+              <a:t>2.5 minutes — Extend the chain to judgment and action, then teach the Act I generalization fresh — do NOT present it as recall; the lectures did not make the per-unit measurement sections prominent.</a:t>
+            </a:r>
+          </a:p>
+          <a:p>
+            <a:endParaRPr/>
+          </a:p>
+          <a:p>
+            <a:r>
+              <a:t>- Build: table first — header and first three rows, then the remaining rows, then the closing claim line. Students should recognise that every previous unit created a claim BEFORE the chain appears. Only then the chain — the same structure spans all of them — and finally “A number does not decide what to do.”</a:t>
+            </a:r>
+          </a:p>
+          <a:p>
+            <a:r>
+              <a:t>- The metric and its conditions give the number evidentiary meaning; engineering judgment connects that evidence to action.</a:t>
+            </a:r>
+          </a:p>
+          <a:p>
+            <a:r>
+              <a:t>- Here's why this matters beyond metrics. Every engineering activity we've studied makes claims about reality. Once we act, reality starts producing evidence about those claims. Process assumes something about how the work behaves. Specification makes assumptions about the environment. Architecture predicts properties of composition. Design predicts consequences of mechanisms. We can observe those things.</a:t>
+            </a:r>
+          </a:p>
+          <a:p>
+            <a:r>
+              <a:t>- This sets up the closing loop slide: outcomes produce new evidence that can update the models.</a:t>
+            </a:r>
           </a:p>
         </p:txBody>
       </p:sp>
     </p:spTree>
   </p:cSld>
+  <p:clrMapOvr>
+    <a:masterClrMapping/>
+  </p:clrMapOvr>
 </p:notes>
 </file>
 
@@ -1654,34 +1800,34 @@
           <a:lstStyle/>
           <a:p>
             <a:r>
-              <a:t>2.5 minutes — Extend the chain to judgment and action, then teach the Act I generalization fresh — do NOT present it as recall; the lectures did not make the per-unit measurement sections prominent.</a:t>
-            </a:r>
-          </a:p>
-          <a:p/>
-          <a:p>
-            <a:r>
-              <a:t>- Build: table first — header and first three rows, then the remaining rows, then the closing claim line. Students should recognise that every previous unit created a claim BEFORE the chain appears. Only then the chain — the same structure spans all of them — and finally “A number does not decide what to do.”</a:t>
-            </a:r>
-          </a:p>
-          <a:p>
-            <a:r>
-              <a:t>- The metric and its conditions give the number evidentiary meaning; engineering judgment connects that evidence to action.</a:t>
-            </a:r>
-          </a:p>
-          <a:p>
-            <a:r>
-              <a:t>- Here's why this matters beyond metrics. Every engineering activity we've studied makes claims about reality. Once we act, reality starts producing evidence about those claims. Process assumes something about how the work behaves. Specification makes assumptions about the environment. Architecture predicts properties of composition. Design predicts consequences of mechanisms. We can observe those things.</a:t>
-            </a:r>
-          </a:p>
-          <a:p>
-            <a:r>
-              <a:t>- This sets up the closing loop slide: outcomes produce new evidence that can update the models.</a:t>
+              <a:t>2 minutes — Same evidence, different rational actions; a Validation callback, not a re-teach.</a:t>
+            </a:r>
+          </a:p>
+          <a:p>
+            <a:endParaRPr/>
+          </a:p>
+          <a:p>
+            <a:r>
+              <a:t>- Two engineers with the same 420-ms measurement can rationally decide differently — consequence, uncertainty, and reversibility differ.</a:t>
+            </a:r>
+          </a:p>
+          <a:p>
+            <a:r>
+              <a:t>- Compress here under time pressure, never the metrics centre.</a:t>
+            </a:r>
+          </a:p>
+          <a:p>
+            <a:r>
+              <a:t>- (from slide) Validation asked when evidence is enough; this is that judgment, generalized.</a:t>
             </a:r>
           </a:p>
         </p:txBody>
       </p:sp>
     </p:spTree>
   </p:cSld>
+  <p:clrMapOvr>
+    <a:masterClrMapping/>
+  </p:clrMapOvr>
 </p:notes>
 </file>
 
@@ -1718,29 +1864,34 @@
           <a:lstStyle/>
           <a:p>
             <a:r>
-              <a:t>2 minutes — Same evidence, different rational actions; a Validation callback, not a re-teach.</a:t>
-            </a:r>
-          </a:p>
-          <a:p/>
-          <a:p>
-            <a:r>
-              <a:t>- Two engineers with the same 420-ms measurement can rationally decide differently — consequence, uncertainty, and reversibility differ.</a:t>
-            </a:r>
-          </a:p>
-          <a:p>
-            <a:r>
-              <a:t>- Compress here under time pressure, never the metrics centre.</a:t>
-            </a:r>
-          </a:p>
-          <a:p>
-            <a:r>
-              <a:t>- (from slide) Validation asked when evidence is enough; this is that judgment, generalized.</a:t>
+              <a:t>1.5 minutes — Return to slide 2's question with the machinery now in hand.</a:t>
+            </a:r>
+          </a:p>
+          <a:p>
+            <a:endParaRPr/>
+          </a:p>
+          <a:p>
+            <a:r>
+              <a:t>- The visual echo of slide 2 is deliberate; students should feel the loop close.</a:t>
+            </a:r>
+          </a:p>
+          <a:p>
+            <a:r>
+              <a:t>- Do not present the six actions as exhaustive or as always-available peers.</a:t>
+            </a:r>
+          </a:p>
+          <a:p>
+            <a:r>
+              <a:t>- (from slide) This is the question from the second slide, now with a theory of evidence behind it; the middle of the lecture existed to support it.</a:t>
             </a:r>
           </a:p>
         </p:txBody>
       </p:sp>
     </p:spTree>
   </p:cSld>
+  <p:clrMapOvr>
+    <a:masterClrMapping/>
+  </p:clrMapOvr>
 </p:notes>
 </file>
 
@@ -1777,29 +1928,36 @@
           <a:lstStyle/>
           <a:p>
             <a:r>
-              <a:t>1.5 minutes — Return to slide 2's question with the machinery now in hand.</a:t>
-            </a:r>
-          </a:p>
-          <a:p/>
-          <a:p>
-            <a:r>
-              <a:t>- The visual echo of slide 2 is deliberate; students should feel the loop close.</a:t>
-            </a:r>
-          </a:p>
-          <a:p>
-            <a:r>
-              <a:t>- Do not present the six actions as exhaustive or as always-available peers.</a:t>
-            </a:r>
-          </a:p>
-          <a:p>
-            <a:r>
-              <a:t>- (from slide) This is the question from the second slide, now with a theory of evidence behind it; the middle of the lecture existed to support it.</a:t>
+              <a:rPr dirty="0"/>
+              <a:t>2 minutes — </a:t>
+            </a:r>
+            <a:r>
+              <a:rPr i="1" dirty="0"/>
+              <a:t>The two questions joined into the recurring loop; the loop is the main visual.</a:t>
+            </a:r>
+          </a:p>
+          <a:p>
+            <a:endParaRPr dirty="0"/>
+          </a:p>
+          <a:p>
+            <a:r>
+              <a:rPr dirty="0"/>
+              <a:t>- The AFTER question is how experience improves the models and judgment behind future decisions.</a:t>
+            </a:r>
+          </a:p>
+          <a:p>
+            <a:r>
+              <a:rPr dirty="0"/>
+              <a:t>- The italic line quietly foreshadows Failure-Aware Engineering (reality arrives uninvited; which model should change?). Do NOT teach that lecture here.</a:t>
             </a:r>
           </a:p>
         </p:txBody>
       </p:sp>
     </p:spTree>
   </p:cSld>
+  <p:clrMapOvr>
+    <a:masterClrMapping/>
+  </p:clrMapOvr>
 </p:notes>
 </file>
 
@@ -1837,11 +1995,11 @@
           <a:p>
             <a:r>
               <a:rPr dirty="0"/>
-              <a:t xml:space="preserve">2 minutes — </a:t>
+              <a:t>1.5 minutes — </a:t>
             </a:r>
             <a:r>
               <a:rPr i="1" dirty="0"/>
-              <a:t>The two questions joined into the recurring loop; the loop is the main visual.</a:t>
+              <a:t>Close on the Day 1 definition and the course argument in one chain. End there.</a:t>
             </a:r>
           </a:p>
           <a:p>
@@ -1850,19 +2008,22 @@
           <a:p>
             <a:r>
               <a:rPr dirty="0"/>
-              <a:t>- The AFTER question is how experience improves the models and judgment behind future decisions.</a:t>
+              <a:t>- The definition is verbatim from Day 1 — do not paraphrase it.</a:t>
             </a:r>
           </a:p>
           <a:p>
             <a:r>
               <a:rPr dirty="0"/>
-              <a:t>- The italic line quietly foreshadows Failure-Aware Engineering (reality arrives uninvited; which model should change?). Do NOT teach that lecture here.</a:t>
+              <a:t>- MODEL, OBSERVE, JUDGE, ACT, LEARN. Do not add another aphorism after the chain; let it end the act.</a:t>
             </a:r>
           </a:p>
         </p:txBody>
       </p:sp>
     </p:spTree>
   </p:cSld>
+  <p:clrMapOvr>
+    <a:masterClrMapping/>
+  </p:clrMapOvr>
 </p:notes>
 </file>
 
@@ -1900,7 +2061,7 @@
           <a:p>
             <a:r>
               <a:rPr dirty="0"/>
-              <a:t xml:space="preserve">1 minute — </a:t>
+              <a:t>1 minute — </a:t>
             </a:r>
             <a:r>
               <a:rPr i="1" dirty="0"/>
@@ -1926,69 +2087,9 @@
       </p:sp>
     </p:spTree>
   </p:cSld>
-</p:notes>
-</file>
-
-<file path=ppt/notesSlides/notesSlide30.xml><?xml version="1.0" encoding="utf-8"?>
-<p:notes xmlns:a="http://schemas.openxmlformats.org/drawingml/2006/main" xmlns:r="http://schemas.openxmlformats.org/officeDocument/2006/relationships" xmlns:p="http://schemas.openxmlformats.org/presentationml/2006/main">
-  <p:cSld>
-    <p:spTree>
-      <p:nvGrpSpPr>
-        <p:cNvPr id="1" name=""/>
-        <p:cNvGrpSpPr/>
-        <p:nvPr/>
-      </p:nvGrpSpPr>
-      <p:grpSpPr>
-        <a:xfrm>
-          <a:off x="0" y="0"/>
-          <a:ext cx="0" cy="0"/>
-          <a:chOff x="0" y="0"/>
-          <a:chExt cx="0" cy="0"/>
-        </a:xfrm>
-      </p:grpSpPr>
-      <p:sp>
-        <p:nvSpPr>
-          <p:cNvPr id="2" name="Notes Placeholder 1"/>
-          <p:cNvSpPr>
-            <a:spLocks noGrp="1"/>
-          </p:cNvSpPr>
-          <p:nvPr>
-            <p:ph type="body" idx="1"/>
-          </p:nvPr>
-        </p:nvSpPr>
-        <p:spPr/>
-        <p:txBody>
-          <a:bodyPr/>
-          <a:lstStyle/>
-          <a:p>
-            <a:r>
-              <a:rPr dirty="0"/>
-              <a:t xml:space="preserve">1.5 minutes — </a:t>
-            </a:r>
-            <a:r>
-              <a:rPr i="1" dirty="0"/>
-              <a:t>Close on the Day 1 definition and the course argument in one chain. End there.</a:t>
-            </a:r>
-          </a:p>
-          <a:p>
-            <a:endParaRPr dirty="0"/>
-          </a:p>
-          <a:p>
-            <a:r>
-              <a:rPr dirty="0"/>
-              <a:t>- The definition is verbatim from Day 1 — do not paraphrase it.</a:t>
-            </a:r>
-          </a:p>
-          <a:p>
-            <a:r>
-              <a:rPr dirty="0"/>
-              <a:t>- MODEL, OBSERVE, JUDGE, ACT, LEARN. Do not add another aphorism after the chain; let it end the act.</a:t>
-            </a:r>
-          </a:p>
-        </p:txBody>
-      </p:sp>
-    </p:spTree>
-  </p:cSld>
+  <p:clrMapOvr>
+    <a:masterClrMapping/>
+  </p:clrMapOvr>
 </p:notes>
 </file>
 
@@ -2026,7 +2127,7 @@
           <a:p>
             <a:r>
               <a:rPr dirty="0"/>
-              <a:t xml:space="preserve">2 minutes — </a:t>
+              <a:t>2 minutes — </a:t>
             </a:r>
             <a:r>
               <a:rPr i="1" dirty="0"/>
@@ -2058,6 +2159,69 @@
       </p:sp>
     </p:spTree>
   </p:cSld>
+  <p:clrMapOvr>
+    <a:masterClrMapping/>
+  </p:clrMapOvr>
+</p:notes>
+</file>
+
+<file path=ppt/notesSlides/notesSlide5.xml><?xml version="1.0" encoding="utf-8"?>
+<p:notes xmlns:a="http://schemas.openxmlformats.org/drawingml/2006/main" xmlns:r="http://schemas.openxmlformats.org/officeDocument/2006/relationships" xmlns:p="http://schemas.openxmlformats.org/presentationml/2006/main">
+  <p:cSld>
+    <p:spTree>
+      <p:nvGrpSpPr>
+        <p:cNvPr id="1" name=""/>
+        <p:cNvGrpSpPr/>
+        <p:nvPr/>
+      </p:nvGrpSpPr>
+      <p:grpSpPr>
+        <a:xfrm>
+          <a:off x="0" y="0"/>
+          <a:ext cx="0" cy="0"/>
+          <a:chOff x="0" y="0"/>
+          <a:chExt cx="0" cy="0"/>
+        </a:xfrm>
+      </p:grpSpPr>
+      <p:sp>
+        <p:nvSpPr>
+          <p:cNvPr id="2" name="Notes Placeholder 1"/>
+          <p:cNvSpPr>
+            <a:spLocks noGrp="1"/>
+          </p:cNvSpPr>
+          <p:nvPr>
+            <p:ph type="body" idx="1"/>
+          </p:nvPr>
+        </p:nvSpPr>
+        <p:spPr/>
+        <p:txBody>
+          <a:bodyPr/>
+          <a:lstStyle/>
+          <a:p>
+            <a:r>
+              <a:rPr dirty="0"/>
+              <a:t>0.3 minutes — </a:t>
+            </a:r>
+            <a:r>
+              <a:rPr i="1" dirty="0"/>
+              <a:t>Name Section 1.</a:t>
+            </a:r>
+          </a:p>
+          <a:p>
+            <a:endParaRPr dirty="0"/>
+          </a:p>
+          <a:p>
+            <a:r>
+              <a:rPr dirty="0"/>
+              <a:t>- 15-20 seconds only.</a:t>
+            </a:r>
+          </a:p>
+        </p:txBody>
+      </p:sp>
+    </p:spTree>
+  </p:cSld>
+  <p:clrMapOvr>
+    <a:masterClrMapping/>
+  </p:clrMapOvr>
 </p:notes>
 </file>
 
@@ -2095,11 +2259,11 @@
           <a:p>
             <a:r>
               <a:rPr dirty="0"/>
-              <a:t xml:space="preserve">0.3 minutes — </a:t>
+              <a:t>1.5 minutes — </a:t>
             </a:r>
             <a:r>
               <a:rPr i="1" dirty="0"/>
-              <a:t>Name Section 1.</a:t>
+              <a:t>Three callbacks, one takeaway: models let us reason before consequences can be observed.</a:t>
             </a:r>
           </a:p>
           <a:p>
@@ -2108,13 +2272,28 @@
           <a:p>
             <a:r>
               <a:rPr dirty="0"/>
-              <a:t>- 15-20 seconds only.</a:t>
+              <a:t>- Pure callback material — Specification, Architecture, Design each built exactly these models. Do not re-teach them.</a:t>
+            </a:r>
+          </a:p>
+          <a:p>
+            <a:r>
+              <a:rPr dirty="0"/>
+              <a:t>- Guard the claim: the model identifies what matters; it does not decide.</a:t>
+            </a:r>
+          </a:p>
+          <a:p>
+            <a:r>
+              <a:rPr dirty="0"/>
+              <a:t>- Compress here if time pressure demands — never in the metrics centre (12-18, 20-24).</a:t>
             </a:r>
           </a:p>
         </p:txBody>
       </p:sp>
     </p:spTree>
   </p:cSld>
+  <p:clrMapOvr>
+    <a:masterClrMapping/>
+  </p:clrMapOvr>
 </p:notes>
 </file>
 
@@ -2152,11 +2331,7 @@
           <a:p>
             <a:r>
               <a:rPr dirty="0"/>
-              <a:t xml:space="preserve">1.5 minutes — </a:t>
-            </a:r>
-            <a:r>
-              <a:rPr i="1" dirty="0"/>
-              <a:t>Three callbacks, one takeaway: models let us reason before consequences can be observed.</a:t>
+              <a:t>2 minutes — Construct the organizing chain live, one element per click: decision, model, consequential property, evidence, judgment, action.</a:t>
             </a:r>
           </a:p>
           <a:p>
@@ -2165,25 +2340,40 @@
           <a:p>
             <a:r>
               <a:rPr dirty="0"/>
-              <a:t>- Pure callback material — Specification, Architecture, Design each built exactly these models. Do not re-teach them.</a:t>
+              <a:t>- Each click adds one element and its gloss; give each element one sentence, in the words on screen.</a:t>
             </a:r>
           </a:p>
           <a:p>
             <a:r>
               <a:rPr dirty="0"/>
-              <a:t>- Guard the claim: the model identifies what matters; it does not decide.</a:t>
+              <a:t>- DECISION: what are we choosing? MODEL: what relationships do we believe matter? CONSEQUENTIAL PROPERTY: what differs among alternatives in a way that matters? EVIDENCE: what do we know about that property? JUDGMENT: is that evidence sufficient given uncertainty and consequence? ACTION comes last — it follows from judgment, not from the evidence alone.</a:t>
             </a:r>
           </a:p>
           <a:p>
             <a:r>
               <a:rPr dirty="0"/>
-              <a:t>- Compress here if time pressure demands — never in the metrics centre (12-18, 20-24).</a:t>
+              <a:t>- This should feel like the instructor constructing a model, not revealing a finished flowchart.</a:t>
+            </a:r>
+          </a:p>
+          <a:p>
+            <a:r>
+              <a:rPr dirty="0"/>
+              <a:t>- This is the organizing model for the rest of the lecture; the closing slides return to it.</a:t>
+            </a:r>
+          </a:p>
+          <a:p>
+            <a:r>
+              <a:rPr dirty="0"/>
+              <a:t>- The next section is a deliberate zoom-in: we open up one part of this chain — how measurement can become evidence.</a:t>
             </a:r>
           </a:p>
         </p:txBody>
       </p:sp>
     </p:spTree>
   </p:cSld>
+  <p:clrMapOvr>
+    <a:masterClrMapping/>
+  </p:clrMapOvr>
 </p:notes>
 </file>
 
@@ -2220,39 +2410,52 @@
           <a:lstStyle/>
           <a:p>
             <a:r>
-              <a:t>2 minutes — Construct the organizing chain live, one element per click: decision, model, consequential property, evidence, judgment, action.</a:t>
-            </a:r>
-          </a:p>
-          <a:p/>
-          <a:p>
-            <a:r>
-              <a:t>- Each click adds one element and its gloss; give each element one sentence, in the words on screen.</a:t>
-            </a:r>
-          </a:p>
-          <a:p>
-            <a:r>
-              <a:t>- DECISION: what are we choosing? MODEL: what relationships do we believe matter? CONSEQUENTIAL PROPERTY: what differs among alternatives in a way that matters? EVIDENCE: what do we know about that property? JUDGMENT: is that evidence sufficient given uncertainty and consequence? ACTION comes last — it follows from judgment, not from the evidence alone.</a:t>
-            </a:r>
-          </a:p>
-          <a:p>
-            <a:r>
-              <a:t>- This should feel like the instructor constructing a model, not revealing a finished flowchart.</a:t>
-            </a:r>
-          </a:p>
-          <a:p>
-            <a:r>
-              <a:t>- This is the organizing model for the rest of the lecture; the closing slides return to it.</a:t>
-            </a:r>
-          </a:p>
-          <a:p>
-            <a:r>
-              <a:t>- The next section is a deliberate zoom-in: we open up one part of this chain — how measurement can become evidence.</a:t>
+              <a:rPr dirty="0"/>
+              <a:t>1 minute — Evidence is broader than measurement; the fan classifies forms of evidence, it does not sequence them.</a:t>
+            </a:r>
+          </a:p>
+          <a:p>
+            <a:endParaRPr dirty="0"/>
+          </a:p>
+          <a:p>
+            <a:r>
+              <a:rPr dirty="0"/>
+              <a:t>- Evidence is broader than measurement. Review, analysis, prototypes, tests, experiments, operational observation, and measurements can all bear on an engineering decision. We are about to concentrate on measurement because metrics require their own reasoning machinery. Do not mistake that focus for a claim that engineering evidence must be numerical.</a:t>
+            </a:r>
+          </a:p>
+          <a:p>
+            <a:r>
+              <a:rPr dirty="0"/>
+              <a:t>- A prototype can demonstrate feasibility; a counterexample can invalidate an assumption; a review can catch the wrong requirement.</a:t>
+            </a:r>
+          </a:p>
+          <a:p>
+            <a:r>
+              <a:rPr dirty="0"/>
+              <a:t>- The purpose of evidence is to reduce uncertainty that matters to a decision.</a:t>
+            </a:r>
+          </a:p>
+          <a:p>
+            <a:r>
+              <a:rPr dirty="0"/>
+              <a:t>- Transition on the highlighted box: measurement is the quantitative path — the </a:t>
+            </a:r>
+            <a:r>
+              <a:rPr dirty="0" err="1"/>
+              <a:t>centre</a:t>
+            </a:r>
+            <a:r>
+              <a:rPr dirty="0"/>
+              <a:t> of this lecture.</a:t>
             </a:r>
           </a:p>
         </p:txBody>
       </p:sp>
     </p:spTree>
   </p:cSld>
+  <p:clrMapOvr>
+    <a:masterClrMapping/>
+  </p:clrMapOvr>
 </p:notes>
 </file>
 
@@ -2289,34 +2492,44 @@
           <a:lstStyle/>
           <a:p>
             <a:r>
-              <a:t>1 minute — Evidence is broader than measurement; the fan classifies forms of evidence, it does not sequence them.</a:t>
-            </a:r>
-          </a:p>
-          <a:p/>
-          <a:p>
-            <a:r>
-              <a:t>- Evidence is broader than measurement. Review, analysis, prototypes, tests, experiments, operational observation, and measurements can all bear on an engineering decision. We are about to concentrate on measurement because metrics require their own reasoning machinery. Do not mistake that focus for a claim that engineering evidence must be numerical.</a:t>
-            </a:r>
-          </a:p>
-          <a:p>
-            <a:r>
-              <a:t>- A prototype can demonstrate feasibility; a counterexample can invalidate an assumption; a review can catch the wrong requirement.</a:t>
-            </a:r>
-          </a:p>
-          <a:p>
-            <a:r>
-              <a:t>- The purpose of evidence is to reduce uncertainty that matters to a decision.</a:t>
-            </a:r>
-          </a:p>
-          <a:p>
-            <a:r>
-              <a:t>- Transition on the highlighted box: measurement is the quantitative path — the centre of this lecture.</a:t>
+              <a:rPr dirty="0"/>
+              <a:t>2 minutes — Evidence gets selected because it distinguishes the alternatives.</a:t>
+            </a:r>
+          </a:p>
+          <a:p>
+            <a:endParaRPr dirty="0"/>
+          </a:p>
+          <a:p>
+            <a:r>
+              <a:rPr dirty="0"/>
+              <a:t>- Don't begin with 'what can I measure?' Begin with the uncertainty preventing the decision. If learning the answer wouldn't change what you choose, the measurement may have little decision value.</a:t>
+            </a:r>
+          </a:p>
+          <a:p>
+            <a:r>
+              <a:rPr dirty="0"/>
+              <a:t>- Walk the model: both strategies fit the memory budget (KNOWN); what separates them is whether the larger cache materially improves latency under the expected workload (UNCERTAIN).</a:t>
+            </a:r>
+          </a:p>
+          <a:p>
+            <a:r>
+              <a:rPr dirty="0"/>
+              <a:t>- Ask the room what evidence would actually change the choice; only then click to reveal: run both mechanisms under a representative workload and compare the latency distributions.</a:t>
+            </a:r>
+          </a:p>
+          <a:p>
+            <a:r>
+              <a:rPr dirty="0"/>
+              <a:t>- Design callback, and the handbook's buy-information framing: measurement is bought to remove the uncertainty that blocks the decision.</a:t>
             </a:r>
           </a:p>
         </p:txBody>
       </p:sp>
     </p:spTree>
   </p:cSld>
+  <p:clrMapOvr>
+    <a:masterClrMapping/>
+  </p:clrMapOvr>
 </p:notes>
 </file>
 
@@ -4885,7 +5098,7 @@
             </a:r>
             <a:r>
               <a:rPr lang="en-US" b="1" u="none" dirty="0"/>
-              <a:t xml:space="preserve">		Details</a:t>
+              <a:t>		Details</a:t>
             </a:r>
           </a:p>
           <a:p>
@@ -5062,7 +5275,7 @@
             </a:r>
             <a:r>
               <a:rPr lang="en-US" b="1" u="none" dirty="0"/>
-              <a:t xml:space="preserve">		Details</a:t>
+              <a:t>		Details</a:t>
             </a:r>
           </a:p>
           <a:p>
@@ -6098,7 +6311,7 @@
           </a:fontRef>
         </p:style>
         <p:txBody>
-          <a:bodyPr rtlCol="0" anchor="ctr" wrap="square" lIns="27432" tIns="22860" rIns="27432" bIns="22860"/>
+          <a:bodyPr wrap="square" lIns="27432" tIns="22860" rIns="27432" bIns="22860" rtlCol="0" anchor="ctr"/>
           <a:lstStyle/>
           <a:p>
             <a:pPr algn="ctr"/>
@@ -6189,7 +6402,7 @@
           </a:fontRef>
         </p:style>
         <p:txBody>
-          <a:bodyPr rtlCol="0" anchor="ctr" wrap="square" lIns="27432" tIns="22860" rIns="27432" bIns="22860"/>
+          <a:bodyPr wrap="square" lIns="27432" tIns="22860" rIns="27432" bIns="22860" rtlCol="0" anchor="ctr"/>
           <a:lstStyle/>
           <a:p>
             <a:pPr algn="ctr"/>
@@ -6280,7 +6493,7 @@
           </a:fontRef>
         </p:style>
         <p:txBody>
-          <a:bodyPr rtlCol="0" anchor="ctr" wrap="square" lIns="27432" tIns="22860" rIns="27432" bIns="22860"/>
+          <a:bodyPr wrap="square" lIns="27432" tIns="22860" rIns="27432" bIns="22860" rtlCol="0" anchor="ctr"/>
           <a:lstStyle/>
           <a:p>
             <a:pPr algn="ctr"/>
@@ -6371,7 +6584,7 @@
           </a:fontRef>
         </p:style>
         <p:txBody>
-          <a:bodyPr rtlCol="0" anchor="ctr" wrap="square" lIns="27432" tIns="22860" rIns="27432" bIns="22860"/>
+          <a:bodyPr wrap="square" lIns="27432" tIns="22860" rIns="27432" bIns="22860" rtlCol="0" anchor="ctr"/>
           <a:lstStyle/>
           <a:p>
             <a:pPr algn="ctr"/>
@@ -6502,7 +6715,7 @@
           <a:p>
             <a:fld id="{B7EB45DA-9A0D-DC49-8E02-F30A5DDC21C3}" type="slidenum">
               <a:rPr lang="en-US" smtClean="0"/>
-              <a:t>11</a:t>
+              <a:t>10</a:t>
             </a:fld>
             <a:endParaRPr lang="en-US"/>
           </a:p>
@@ -6616,7 +6829,7 @@
           <a:p>
             <a:fld id="{B7EB45DA-9A0D-DC49-8E02-F30A5DDC21C3}" type="slidenum">
               <a:rPr lang="en-US" smtClean="0"/>
-              <a:t>12</a:t>
+              <a:t>11</a:t>
             </a:fld>
             <a:endParaRPr lang="en-US"/>
           </a:p>
@@ -6741,7 +6954,7 @@
           </a:fontRef>
         </p:style>
         <p:txBody>
-          <a:bodyPr rtlCol="0" anchor="ctr" wrap="square" lIns="27432" tIns="22860" rIns="27432" bIns="22860"/>
+          <a:bodyPr wrap="square" lIns="27432" tIns="22860" rIns="27432" bIns="22860" rtlCol="0" anchor="ctr"/>
           <a:lstStyle/>
           <a:p>
             <a:pPr algn="ctr"/>
@@ -6795,7 +7008,7 @@
           </a:fontRef>
         </p:style>
         <p:txBody>
-          <a:bodyPr rtlCol="0" anchor="ctr" wrap="square" lIns="27432" tIns="22860" rIns="27432" bIns="22860"/>
+          <a:bodyPr wrap="square" lIns="27432" tIns="22860" rIns="27432" bIns="22860" rtlCol="0" anchor="ctr"/>
           <a:lstStyle/>
           <a:p>
             <a:pPr algn="ctr"/>
@@ -6849,7 +7062,7 @@
           </a:fontRef>
         </p:style>
         <p:txBody>
-          <a:bodyPr rtlCol="0" anchor="ctr" wrap="square" lIns="27432" tIns="22860" rIns="27432" bIns="22860"/>
+          <a:bodyPr wrap="square" lIns="27432" tIns="22860" rIns="27432" bIns="22860" rtlCol="0" anchor="ctr"/>
           <a:lstStyle/>
           <a:p>
             <a:pPr algn="ctr"/>
@@ -6903,7 +7116,7 @@
           </a:fontRef>
         </p:style>
         <p:txBody>
-          <a:bodyPr rtlCol="0" anchor="ctr" wrap="square" lIns="27432" tIns="22860" rIns="27432" bIns="22860"/>
+          <a:bodyPr wrap="square" lIns="27432" tIns="22860" rIns="27432" bIns="22860" rtlCol="0" anchor="ctr"/>
           <a:lstStyle/>
           <a:p>
             <a:pPr algn="ctr"/>
@@ -7170,7 +7383,7 @@
           </a:fontRef>
         </p:style>
         <p:txBody>
-          <a:bodyPr rtlCol="0" anchor="t" wrap="square" lIns="45720" rIns="45720"/>
+          <a:bodyPr wrap="square" lIns="45720" rIns="45720" rtlCol="0" anchor="t"/>
           <a:lstStyle/>
           <a:p>
             <a:pPr algn="ctr"/>
@@ -7224,7 +7437,7 @@
           </a:fontRef>
         </p:style>
         <p:txBody>
-          <a:bodyPr rtlCol="0" anchor="t" wrap="square" lIns="45720" rIns="45720"/>
+          <a:bodyPr wrap="square" lIns="45720" rIns="45720" rtlCol="0" anchor="t"/>
           <a:lstStyle/>
           <a:p>
             <a:pPr algn="ctr"/>
@@ -7289,7 +7502,7 @@
           </a:fontRef>
         </p:style>
         <p:txBody>
-          <a:bodyPr rtlCol="0" anchor="t" wrap="square" lIns="45720" rIns="45720"/>
+          <a:bodyPr wrap="square" lIns="45720" rIns="45720" rtlCol="0" anchor="t"/>
           <a:lstStyle/>
           <a:p>
             <a:pPr algn="ctr"/>
@@ -7343,7 +7556,7 @@
           </a:fontRef>
         </p:style>
         <p:txBody>
-          <a:bodyPr rtlCol="0" anchor="t" wrap="square" lIns="45720" rIns="45720"/>
+          <a:bodyPr wrap="square" lIns="45720" rIns="45720" rtlCol="0" anchor="t"/>
           <a:lstStyle/>
           <a:p>
             <a:pPr algn="ctr"/>
@@ -7437,7 +7650,7 @@
           <a:p>
             <a:fld id="{B7EB45DA-9A0D-DC49-8E02-F30A5DDC21C3}" type="slidenum">
               <a:rPr lang="en-US" smtClean="0"/>
-              <a:t>13</a:t>
+              <a:t>12</a:t>
             </a:fld>
             <a:endParaRPr lang="en-US"/>
           </a:p>
@@ -7847,7 +8060,7 @@
           <a:p>
             <a:fld id="{B7EB45DA-9A0D-DC49-8E02-F30A5DDC21C3}" type="slidenum">
               <a:rPr lang="en-US" smtClean="0"/>
-              <a:t>14</a:t>
+              <a:t>13</a:t>
             </a:fld>
             <a:endParaRPr lang="en-US"/>
           </a:p>
@@ -8099,7 +8312,7 @@
                   <a:srgbClr val="5C4826"/>
                 </a:solidFill>
               </a:rPr>
-              <a:t xml:space="preserve">service = 180 ms </a:t>
+              <a:t>service = 180 ms </a:t>
             </a:r>
             <a:r>
               <a:rPr lang="en-US" sz="2000" b="0" i="1" dirty="0">
@@ -8123,7 +8336,7 @@
                   <a:srgbClr val="5C4826"/>
                 </a:solidFill>
               </a:rPr>
-              <a:t xml:space="preserve">queueing = 130 ms </a:t>
+              <a:t>queueing = 130 ms </a:t>
             </a:r>
             <a:r>
               <a:rPr lang="en-US" sz="2000" b="0" i="1" dirty="0">
@@ -8147,7 +8360,7 @@
                   <a:srgbClr val="5C4826"/>
                 </a:solidFill>
               </a:rPr>
-              <a:t xml:space="preserve">communication = 90 ms </a:t>
+              <a:t>communication = 90 ms </a:t>
             </a:r>
             <a:r>
               <a:rPr lang="en-US" sz="2000" b="0" i="1" dirty="0">
@@ -8192,7 +8405,7 @@
                   <a:srgbClr val="5C4826"/>
                 </a:solidFill>
               </a:rPr>
-              <a:t xml:space="preserve">1   </a:t>
+              <a:t>1   </a:t>
             </a:r>
             <a:r>
               <a:rPr lang="en-US" sz="2000" b="0" i="0" dirty="0">
@@ -8216,7 +8429,7 @@
                   <a:srgbClr val="5C4826"/>
                 </a:solidFill>
               </a:rPr>
-              <a:t xml:space="preserve">2   </a:t>
+              <a:t>2   </a:t>
             </a:r>
             <a:r>
               <a:rPr lang="en-US" sz="2000" b="0" i="0" dirty="0">
@@ -8294,7 +8507,7 @@
                             </p:stCondLst>
                             <p:childTnLst>
                               <p:par>
-                                <p:cTn id="5" presetID="10" presetClass="entr" presetSubtype="0" fill="hold" grpId="0" nodeType="clickEffect">
+                                <p:cTn id="5" presetID="10" presetClass="entr" presetSubtype="0" fill="hold" nodeType="clickEffect">
                                   <p:stCondLst>
                                     <p:cond delay="0"/>
                                   </p:stCondLst>
@@ -8329,7 +8542,7 @@
                                 </p:cTn>
                               </p:par>
                               <p:par>
-                                <p:cTn id="8" presetID="10" presetClass="entr" presetSubtype="0" fill="hold" grpId="0" nodeType="withEffect">
+                                <p:cTn id="8" presetID="10" presetClass="entr" presetSubtype="0" fill="hold" nodeType="withEffect">
                                   <p:stCondLst>
                                     <p:cond delay="0"/>
                                   </p:stCondLst>
@@ -8468,7 +8681,7 @@
                                 </p:cTn>
                               </p:par>
                               <p:par>
-                                <p:cTn id="19" presetID="10" presetClass="entr" presetSubtype="0" fill="hold" grpId="0" nodeType="withEffect">
+                                <p:cTn id="19" presetID="10" presetClass="entr" presetSubtype="0" fill="hold" nodeType="withEffect">
                                   <p:stCondLst>
                                     <p:cond delay="0"/>
                                   </p:stCondLst>
@@ -8607,7 +8820,7 @@
           <a:p>
             <a:fld id="{B7EB45DA-9A0D-DC49-8E02-F30A5DDC21C3}" type="slidenum">
               <a:rPr lang="en-US" smtClean="0"/>
-              <a:t>15</a:t>
+              <a:t>14</a:t>
             </a:fld>
             <a:endParaRPr lang="en-US"/>
           </a:p>
@@ -8652,7 +8865,7 @@
           </a:fontRef>
         </p:style>
         <p:txBody>
-          <a:bodyPr rtlCol="0" anchor="ctr" wrap="square"/>
+          <a:bodyPr wrap="square" rtlCol="0" anchor="ctr"/>
           <a:lstStyle/>
           <a:p>
             <a:pPr algn="ctr"/>
@@ -8804,7 +9017,7 @@
           </a:fontRef>
         </p:style>
         <p:txBody>
-          <a:bodyPr rtlCol="0" anchor="ctr" wrap="square" lIns="45720" tIns="22860" rIns="45720" bIns="22860"/>
+          <a:bodyPr wrap="square" lIns="45720" tIns="22860" rIns="45720" bIns="22860" rtlCol="0" anchor="ctr"/>
           <a:lstStyle/>
           <a:p>
             <a:pPr algn="ctr"/>
@@ -8858,7 +9071,7 @@
           </a:fontRef>
         </p:style>
         <p:txBody>
-          <a:bodyPr rtlCol="0" anchor="ctr" wrap="square" lIns="45720" tIns="22860" rIns="45720" bIns="22860"/>
+          <a:bodyPr wrap="square" lIns="45720" tIns="22860" rIns="45720" bIns="22860" rtlCol="0" anchor="ctr"/>
           <a:lstStyle/>
           <a:p>
             <a:pPr algn="ctr"/>
@@ -8912,7 +9125,7 @@
           </a:fontRef>
         </p:style>
         <p:txBody>
-          <a:bodyPr rtlCol="0" anchor="ctr" wrap="square" lIns="45720" tIns="22860" rIns="45720" bIns="22860"/>
+          <a:bodyPr wrap="square" lIns="45720" tIns="22860" rIns="45720" bIns="22860" rtlCol="0" anchor="ctr"/>
           <a:lstStyle/>
           <a:p>
             <a:pPr algn="ctr"/>
@@ -8966,7 +9179,7 @@
           </a:fontRef>
         </p:style>
         <p:txBody>
-          <a:bodyPr rtlCol="0" anchor="ctr" wrap="square" lIns="45720" tIns="22860" rIns="45720" bIns="22860"/>
+          <a:bodyPr wrap="square" lIns="45720" tIns="22860" rIns="45720" bIns="22860" rtlCol="0" anchor="ctr"/>
           <a:lstStyle/>
           <a:p>
             <a:pPr algn="ctr"/>
@@ -9020,7 +9233,7 @@
           </a:fontRef>
         </p:style>
         <p:txBody>
-          <a:bodyPr rtlCol="0" anchor="ctr" wrap="square" lIns="45720" tIns="22860" rIns="45720" bIns="22860"/>
+          <a:bodyPr wrap="square" lIns="45720" tIns="22860" rIns="45720" bIns="22860" rtlCol="0" anchor="ctr"/>
           <a:lstStyle/>
           <a:p>
             <a:pPr algn="ctr"/>
@@ -9074,7 +9287,7 @@
           </a:fontRef>
         </p:style>
         <p:txBody>
-          <a:bodyPr rtlCol="0" anchor="ctr" wrap="square" lIns="45720" tIns="22860" rIns="45720" bIns="22860"/>
+          <a:bodyPr wrap="square" lIns="45720" tIns="22860" rIns="45720" bIns="22860" rtlCol="0" anchor="ctr"/>
           <a:lstStyle/>
           <a:p>
             <a:pPr algn="ctr"/>
@@ -9128,7 +9341,7 @@
           </a:fontRef>
         </p:style>
         <p:txBody>
-          <a:bodyPr rtlCol="0" anchor="ctr" wrap="square"/>
+          <a:bodyPr wrap="square" rtlCol="0" anchor="ctr"/>
           <a:lstStyle/>
           <a:p>
             <a:pPr algn="ctr"/>
@@ -9169,7 +9382,7 @@
                             </p:stCondLst>
                             <p:childTnLst>
                               <p:par>
-                                <p:cTn id="5" presetID="10" presetClass="entr" presetSubtype="0" fill="hold" grpId="0" nodeType="clickEffect">
+                                <p:cTn id="5" presetID="10" presetClass="entr" presetSubtype="0" fill="hold" nodeType="clickEffect">
                                   <p:stCondLst>
                                     <p:cond delay="0"/>
                                   </p:stCondLst>
@@ -9222,7 +9435,7 @@
                             </p:stCondLst>
                             <p:childTnLst>
                               <p:par>
-                                <p:cTn id="10" presetID="10" presetClass="entr" presetSubtype="0" fill="hold" grpId="0" nodeType="clickEffect">
+                                <p:cTn id="10" presetID="10" presetClass="entr" presetSubtype="0" fill="hold" nodeType="clickEffect">
                                   <p:stCondLst>
                                     <p:cond delay="0"/>
                                   </p:stCondLst>
@@ -9275,7 +9488,7 @@
                             </p:stCondLst>
                             <p:childTnLst>
                               <p:par>
-                                <p:cTn id="15" presetID="10" presetClass="entr" presetSubtype="0" fill="hold" grpId="0" nodeType="clickEffect">
+                                <p:cTn id="15" presetID="10" presetClass="entr" presetSubtype="0" fill="hold" nodeType="clickEffect">
                                   <p:stCondLst>
                                     <p:cond delay="0"/>
                                   </p:stCondLst>
@@ -9328,7 +9541,7 @@
                             </p:stCondLst>
                             <p:childTnLst>
                               <p:par>
-                                <p:cTn id="20" presetID="10" presetClass="entr" presetSubtype="0" fill="hold" grpId="0" nodeType="clickEffect">
+                                <p:cTn id="20" presetID="10" presetClass="entr" presetSubtype="0" fill="hold" nodeType="clickEffect">
                                   <p:stCondLst>
                                     <p:cond delay="0"/>
                                   </p:stCondLst>
@@ -9381,7 +9594,7 @@
                             </p:stCondLst>
                             <p:childTnLst>
                               <p:par>
-                                <p:cTn id="25" presetID="10" presetClass="entr" presetSubtype="0" fill="hold" grpId="0" nodeType="clickEffect">
+                                <p:cTn id="25" presetID="10" presetClass="entr" presetSubtype="0" fill="hold" nodeType="clickEffect">
                                   <p:stCondLst>
                                     <p:cond delay="0"/>
                                   </p:stCondLst>
@@ -9434,7 +9647,7 @@
                             </p:stCondLst>
                             <p:childTnLst>
                               <p:par>
-                                <p:cTn id="30" presetID="10" presetClass="entr" presetSubtype="0" fill="hold" grpId="0" nodeType="clickEffect">
+                                <p:cTn id="30" presetID="10" presetClass="entr" presetSubtype="0" fill="hold" nodeType="clickEffect">
                                   <p:stCondLst>
                                     <p:cond delay="0"/>
                                   </p:stCondLst>
@@ -9487,7 +9700,7 @@
                             </p:stCondLst>
                             <p:childTnLst>
                               <p:par>
-                                <p:cTn id="35" presetID="10" presetClass="entr" presetSubtype="0" fill="hold" grpId="0" nodeType="clickEffect">
+                                <p:cTn id="35" presetID="10" presetClass="entr" presetSubtype="0" fill="hold" nodeType="clickEffect">
                                   <p:stCondLst>
                                     <p:cond delay="0"/>
                                   </p:stCondLst>
@@ -9623,7 +9836,7 @@
           <a:p>
             <a:fld id="{B7EB45DA-9A0D-DC49-8E02-F30A5DDC21C3}" type="slidenum">
               <a:rPr lang="en-US" smtClean="0"/>
-              <a:t>16</a:t>
+              <a:t>15</a:t>
             </a:fld>
             <a:endParaRPr lang="en-US"/>
           </a:p>
@@ -9707,7 +9920,7 @@
           </a:fontRef>
         </p:style>
         <p:txBody>
-          <a:bodyPr rtlCol="0" anchor="ctr" wrap="square"/>
+          <a:bodyPr wrap="square" rtlCol="0" anchor="ctr"/>
           <a:lstStyle/>
           <a:p>
             <a:pPr algn="ctr"/>
@@ -9832,7 +10045,7 @@
           </a:fontRef>
         </p:style>
         <p:txBody>
-          <a:bodyPr rtlCol="0" anchor="ctr" wrap="square"/>
+          <a:bodyPr wrap="square" rtlCol="0" anchor="ctr"/>
           <a:lstStyle/>
           <a:p>
             <a:pPr algn="ctr"/>
@@ -9957,7 +10170,7 @@
           </a:fontRef>
         </p:style>
         <p:txBody>
-          <a:bodyPr rtlCol="0" anchor="ctr" wrap="square"/>
+          <a:bodyPr wrap="square" rtlCol="0" anchor="ctr"/>
           <a:lstStyle/>
           <a:p>
             <a:pPr algn="ctr"/>
@@ -10082,7 +10295,7 @@
           </a:fontRef>
         </p:style>
         <p:txBody>
-          <a:bodyPr rtlCol="0" anchor="ctr" wrap="square"/>
+          <a:bodyPr wrap="square" rtlCol="0" anchor="ctr"/>
           <a:lstStyle/>
           <a:p>
             <a:pPr algn="ctr"/>
@@ -10359,7 +10572,7 @@
           <a:p>
             <a:fld id="{B7EB45DA-9A0D-DC49-8E02-F30A5DDC21C3}" type="slidenum">
               <a:rPr lang="en-US" smtClean="0"/>
-              <a:t>17</a:t>
+              <a:t>16</a:t>
             </a:fld>
             <a:endParaRPr lang="en-US"/>
           </a:p>
@@ -10762,7 +10975,7 @@
                   <a:srgbClr val="FFFFFF"/>
                 </a:solidFill>
               </a:rPr>
-              <a:t>Directness is a matter of degree — not a binary found in nature.</a:t>
+              <a:t>Directness is a matter of degree.</a:t>
             </a:r>
           </a:p>
         </p:txBody>
@@ -10846,7 +11059,7 @@
           <a:p>
             <a:fld id="{B7EB45DA-9A0D-DC49-8E02-F30A5DDC21C3}" type="slidenum">
               <a:rPr lang="en-US" smtClean="0"/>
-              <a:t>18</a:t>
+              <a:t>17</a:t>
             </a:fld>
             <a:endParaRPr lang="en-US"/>
           </a:p>
@@ -11372,7 +11585,7 @@
           <a:p>
             <a:fld id="{B7EB45DA-9A0D-DC49-8E02-F30A5DDC21C3}" type="slidenum">
               <a:rPr lang="en-US" smtClean="0"/>
-              <a:t>19</a:t>
+              <a:t>18</a:t>
             </a:fld>
             <a:endParaRPr lang="en-US"/>
           </a:p>
@@ -11500,7 +11713,7 @@
           <a:p>
             <a:fld id="{B7EB45DA-9A0D-DC49-8E02-F30A5DDC21C3}" type="slidenum">
               <a:rPr lang="en-US" smtClean="0"/>
-              <a:t>20</a:t>
+              <a:t>19</a:t>
             </a:fld>
             <a:endParaRPr lang="en-US"/>
           </a:p>
@@ -11579,7 +11792,7 @@
                   <a:srgbClr val="9A9A9A"/>
                 </a:solidFill>
               </a:rPr>
-              <a:t xml:space="preserve">  ·  </a:t>
+              <a:t>  ·  </a:t>
             </a:r>
             <a:r>
               <a:rPr lang="en-US" sz="2000" b="1" i="0" dirty="0">
@@ -11595,7 +11808,7 @@
                   <a:srgbClr val="9A9A9A"/>
                 </a:solidFill>
               </a:rPr>
-              <a:t xml:space="preserve">  ·  </a:t>
+              <a:t>  ·  </a:t>
             </a:r>
             <a:r>
               <a:rPr lang="en-US" sz="2000" b="1" i="0" dirty="0">
@@ -11935,7 +12148,7 @@
           </a:fontRef>
         </p:style>
         <p:txBody>
-          <a:bodyPr rtlCol="0" anchor="ctr" wrap="square" lIns="45720" tIns="22860" rIns="45720" bIns="22860"/>
+          <a:bodyPr wrap="square" lIns="45720" tIns="22860" rIns="45720" bIns="22860" rtlCol="0" anchor="ctr"/>
           <a:lstStyle/>
           <a:p>
             <a:pPr algn="ctr"/>
@@ -11989,7 +12202,7 @@
           </a:fontRef>
         </p:style>
         <p:txBody>
-          <a:bodyPr rtlCol="0" anchor="ctr" wrap="square" lIns="45720" tIns="22860" rIns="45720" bIns="22860"/>
+          <a:bodyPr wrap="square" lIns="45720" tIns="22860" rIns="45720" bIns="22860" rtlCol="0" anchor="ctr"/>
           <a:lstStyle/>
           <a:p>
             <a:pPr algn="ctr"/>
@@ -12043,7 +12256,7 @@
           </a:fontRef>
         </p:style>
         <p:txBody>
-          <a:bodyPr rtlCol="0" anchor="ctr" wrap="square" lIns="45720" tIns="22860" rIns="45720" bIns="22860"/>
+          <a:bodyPr wrap="square" lIns="45720" tIns="22860" rIns="45720" bIns="22860" rtlCol="0" anchor="ctr"/>
           <a:lstStyle/>
           <a:p>
             <a:pPr algn="ctr"/>
@@ -12097,7 +12310,7 @@
           </a:fontRef>
         </p:style>
         <p:txBody>
-          <a:bodyPr rtlCol="0" anchor="ctr" wrap="square" lIns="45720" tIns="22860" rIns="45720" bIns="22860"/>
+          <a:bodyPr wrap="square" lIns="45720" tIns="22860" rIns="45720" bIns="22860" rtlCol="0" anchor="ctr"/>
           <a:lstStyle/>
           <a:p>
             <a:pPr algn="ctr"/>
@@ -12151,7 +12364,7 @@
           </a:fontRef>
         </p:style>
         <p:txBody>
-          <a:bodyPr rtlCol="0" anchor="ctr" wrap="square" lIns="45720" tIns="22860" rIns="45720" bIns="22860"/>
+          <a:bodyPr wrap="square" lIns="45720" tIns="22860" rIns="45720" bIns="22860" rtlCol="0" anchor="ctr"/>
           <a:lstStyle/>
           <a:p>
             <a:pPr algn="ctr"/>
@@ -12205,7 +12418,7 @@
           </a:fontRef>
         </p:style>
         <p:txBody>
-          <a:bodyPr rtlCol="0" anchor="ctr" wrap="square" lIns="45720" tIns="22860" rIns="45720" bIns="22860"/>
+          <a:bodyPr wrap="square" lIns="45720" tIns="22860" rIns="45720" bIns="22860" rtlCol="0" anchor="ctr"/>
           <a:lstStyle/>
           <a:p>
             <a:pPr algn="ctr"/>
@@ -12259,7 +12472,7 @@
           </a:fontRef>
         </p:style>
         <p:txBody>
-          <a:bodyPr rtlCol="0" anchor="ctr" wrap="square" lIns="45720" tIns="22860" rIns="45720" bIns="22860"/>
+          <a:bodyPr wrap="square" lIns="45720" tIns="22860" rIns="45720" bIns="22860" rtlCol="0" anchor="ctr"/>
           <a:lstStyle/>
           <a:p>
             <a:pPr algn="ctr"/>
@@ -12313,7 +12526,7 @@
           </a:fontRef>
         </p:style>
         <p:txBody>
-          <a:bodyPr rtlCol="0" anchor="ctr" wrap="square" lIns="45720" tIns="22860" rIns="45720" bIns="22860"/>
+          <a:bodyPr wrap="square" lIns="45720" tIns="22860" rIns="45720" bIns="22860" rtlCol="0" anchor="ctr"/>
           <a:lstStyle/>
           <a:p>
             <a:pPr algn="ctr"/>
@@ -12367,7 +12580,7 @@
           </a:fontRef>
         </p:style>
         <p:txBody>
-          <a:bodyPr rtlCol="0" anchor="ctr" wrap="square" lIns="45720" tIns="22860" rIns="45720" bIns="22860"/>
+          <a:bodyPr wrap="square" lIns="45720" tIns="22860" rIns="45720" bIns="22860" rtlCol="0" anchor="ctr"/>
           <a:lstStyle/>
           <a:p>
             <a:pPr algn="ctr"/>
@@ -12421,7 +12634,7 @@
           </a:fontRef>
         </p:style>
         <p:txBody>
-          <a:bodyPr rtlCol="0" anchor="ctr" wrap="square" lIns="45720" tIns="22860" rIns="45720" bIns="22860"/>
+          <a:bodyPr wrap="square" lIns="45720" tIns="22860" rIns="45720" bIns="22860" rtlCol="0" anchor="ctr"/>
           <a:lstStyle/>
           <a:p>
             <a:pPr algn="ctr"/>
@@ -12515,7 +12728,7 @@
           <a:p>
             <a:fld id="{B7EB45DA-9A0D-DC49-8E02-F30A5DDC21C3}" type="slidenum">
               <a:rPr lang="en-US" smtClean="0"/>
-              <a:t>21</a:t>
+              <a:t>20</a:t>
             </a:fld>
             <a:endParaRPr lang="en-US"/>
           </a:p>
@@ -12862,7 +13075,7 @@
           <a:p>
             <a:fld id="{B7EB45DA-9A0D-DC49-8E02-F30A5DDC21C3}" type="slidenum">
               <a:rPr lang="en-US" smtClean="0"/>
-              <a:t>22</a:t>
+              <a:t>21</a:t>
             </a:fld>
             <a:endParaRPr lang="en-US"/>
           </a:p>
@@ -12973,7 +13186,7 @@
                   <a:srgbClr val="555960"/>
                 </a:solidFill>
               </a:rPr>
-              <a:t xml:space="preserve">Surrogation: </a:t>
+              <a:t>Surrogation: </a:t>
             </a:r>
             <a:r>
               <a:rPr lang="en-US" sz="2000" b="0" i="1" dirty="0">
@@ -12981,7 +13194,7 @@
                   <a:srgbClr val="555960"/>
                 </a:solidFill>
               </a:rPr>
-              <a:t xml:space="preserve">we begin treating commits as though they </a:t>
+              <a:t>we begin treating commits as though they </a:t>
             </a:r>
             <a:r>
               <a:rPr lang="en-US" sz="2000" b="1" i="1" dirty="0">
@@ -12997,7 +13210,7 @@
                   <a:srgbClr val="555960"/>
                 </a:solidFill>
               </a:rPr>
-              <a:t xml:space="preserve"> useful output</a:t>
+              <a:t> useful output</a:t>
             </a:r>
           </a:p>
         </p:txBody>
@@ -13097,7 +13310,7 @@
                   <a:srgbClr val="555960"/>
                 </a:solidFill>
               </a:rPr>
-              <a:t xml:space="preserve">Goodhart: </a:t>
+              <a:t>Goodhart: </a:t>
             </a:r>
             <a:r>
               <a:rPr lang="en-US" sz="2000" b="0" i="1" dirty="0">
@@ -13146,7 +13359,7 @@
                   <a:srgbClr val="5C4826"/>
                 </a:solidFill>
               </a:rPr>
-              <a:t xml:space="preserve">Surrogation: </a:t>
+              <a:t>Surrogation: </a:t>
             </a:r>
             <a:r>
               <a:rPr lang="en-US" sz="2000" b="0" i="0" dirty="0">
@@ -13170,7 +13383,7 @@
                   <a:srgbClr val="5C4826"/>
                 </a:solidFill>
               </a:rPr>
-              <a:t xml:space="preserve">Goodhart’s Law: </a:t>
+              <a:t>Goodhart’s Law: </a:t>
             </a:r>
             <a:r>
               <a:rPr lang="en-US" sz="2000" b="0" i="0" dirty="0">
@@ -13262,7 +13475,7 @@
           <a:p>
             <a:fld id="{B7EB45DA-9A0D-DC49-8E02-F30A5DDC21C3}" type="slidenum">
               <a:rPr lang="en-US" smtClean="0"/>
-              <a:t>23</a:t>
+              <a:t>22</a:t>
             </a:fld>
             <a:endParaRPr lang="en-US"/>
           </a:p>
@@ -13668,7 +13881,7 @@
           <a:p>
             <a:fld id="{B7EB45DA-9A0D-DC49-8E02-F30A5DDC21C3}" type="slidenum">
               <a:rPr lang="en-US" smtClean="0"/>
-              <a:t>24</a:t>
+              <a:t>23</a:t>
             </a:fld>
             <a:endParaRPr lang="en-US"/>
           </a:p>
@@ -13710,7 +13923,7 @@
                   <a:srgbClr val="8E6F3E"/>
                 </a:solidFill>
               </a:rPr>
-              <a:t xml:space="preserve">1    </a:t>
+              <a:t>1    </a:t>
             </a:r>
             <a:r>
               <a:rPr lang="en-US" sz="2400" b="0" i="0" dirty="0">
@@ -13759,7 +13972,7 @@
                   <a:srgbClr val="8E6F3E"/>
                 </a:solidFill>
               </a:rPr>
-              <a:t xml:space="preserve">2    </a:t>
+              <a:t>2    </a:t>
             </a:r>
             <a:r>
               <a:rPr lang="en-US" sz="2400" b="0" i="0" dirty="0">
@@ -13808,7 +14021,7 @@
                   <a:srgbClr val="8E6F3E"/>
                 </a:solidFill>
               </a:rPr>
-              <a:t xml:space="preserve">3    </a:t>
+              <a:t>3    </a:t>
             </a:r>
             <a:r>
               <a:rPr lang="en-US" sz="2400" b="0" i="0" dirty="0">
@@ -13857,7 +14070,7 @@
                   <a:srgbClr val="8E6F3E"/>
                 </a:solidFill>
               </a:rPr>
-              <a:t xml:space="preserve">4    </a:t>
+              <a:t>4    </a:t>
             </a:r>
             <a:r>
               <a:rPr lang="en-US" sz="2400" b="0" i="0" dirty="0">
@@ -13986,7 +14199,7 @@
           <a:p>
             <a:fld id="{B7EB45DA-9A0D-DC49-8E02-F30A5DDC21C3}" type="slidenum">
               <a:rPr lang="en-US" smtClean="0"/>
-              <a:t>25</a:t>
+              <a:t>24</a:t>
             </a:fld>
             <a:endParaRPr lang="en-US"/>
           </a:p>
@@ -14100,7 +14313,7 @@
           <a:p>
             <a:fld id="{B7EB45DA-9A0D-DC49-8E02-F30A5DDC21C3}" type="slidenum">
               <a:rPr lang="en-US" smtClean="0"/>
-              <a:t>26</a:t>
+              <a:t>25</a:t>
             </a:fld>
             <a:endParaRPr lang="en-US"/>
           </a:p>
@@ -14247,7 +14460,7 @@
           </a:fontRef>
         </p:style>
         <p:txBody>
-          <a:bodyPr rtlCol="0" anchor="ctr" wrap="square" tIns="22860" bIns="22860"/>
+          <a:bodyPr wrap="square" tIns="22860" bIns="22860" rtlCol="0" anchor="ctr"/>
           <a:lstStyle/>
           <a:p>
             <a:pPr algn="l"/>
@@ -14301,7 +14514,7 @@
           </a:fontRef>
         </p:style>
         <p:txBody>
-          <a:bodyPr rtlCol="0" anchor="ctr" wrap="square" tIns="22860" bIns="22860" lIns="45720" rIns="45720"/>
+          <a:bodyPr wrap="square" lIns="45720" tIns="22860" rIns="45720" bIns="22860" rtlCol="0" anchor="ctr"/>
           <a:lstStyle/>
           <a:p>
             <a:pPr algn="l"/>
@@ -14355,7 +14568,7 @@
           </a:fontRef>
         </p:style>
         <p:txBody>
-          <a:bodyPr rtlCol="0" anchor="ctr" wrap="square" tIns="22860" bIns="22860"/>
+          <a:bodyPr wrap="square" tIns="22860" bIns="22860" rtlCol="0" anchor="ctr"/>
           <a:lstStyle/>
           <a:p>
             <a:pPr algn="l"/>
@@ -14409,7 +14622,7 @@
           </a:fontRef>
         </p:style>
         <p:txBody>
-          <a:bodyPr rtlCol="0" anchor="ctr" wrap="square" tIns="22860" bIns="22860" lIns="45720" rIns="45720"/>
+          <a:bodyPr wrap="square" lIns="45720" tIns="22860" rIns="45720" bIns="22860" rtlCol="0" anchor="ctr"/>
           <a:lstStyle/>
           <a:p>
             <a:pPr algn="l"/>
@@ -14463,7 +14676,7 @@
           </a:fontRef>
         </p:style>
         <p:txBody>
-          <a:bodyPr rtlCol="0" anchor="ctr" wrap="square" tIns="22860" bIns="22860"/>
+          <a:bodyPr wrap="square" tIns="22860" bIns="22860" rtlCol="0" anchor="ctr"/>
           <a:lstStyle/>
           <a:p>
             <a:pPr algn="l"/>
@@ -14517,7 +14730,7 @@
           </a:fontRef>
         </p:style>
         <p:txBody>
-          <a:bodyPr rtlCol="0" anchor="ctr" wrap="square" tIns="22860" bIns="22860" lIns="45720" rIns="45720"/>
+          <a:bodyPr wrap="square" lIns="45720" tIns="22860" rIns="45720" bIns="22860" rtlCol="0" anchor="ctr"/>
           <a:lstStyle/>
           <a:p>
             <a:pPr algn="l"/>
@@ -14571,7 +14784,7 @@
           </a:fontRef>
         </p:style>
         <p:txBody>
-          <a:bodyPr rtlCol="0" anchor="ctr" wrap="square" tIns="22860" bIns="22860"/>
+          <a:bodyPr wrap="square" tIns="22860" bIns="22860" rtlCol="0" anchor="ctr"/>
           <a:lstStyle/>
           <a:p>
             <a:pPr algn="l"/>
@@ -14625,7 +14838,7 @@
           </a:fontRef>
         </p:style>
         <p:txBody>
-          <a:bodyPr rtlCol="0" anchor="ctr" wrap="square" tIns="22860" bIns="22860" lIns="45720" rIns="45720"/>
+          <a:bodyPr wrap="square" lIns="45720" tIns="22860" rIns="45720" bIns="22860" rtlCol="0" anchor="ctr"/>
           <a:lstStyle/>
           <a:p>
             <a:pPr algn="l"/>
@@ -14679,7 +14892,7 @@
           </a:fontRef>
         </p:style>
         <p:txBody>
-          <a:bodyPr rtlCol="0" anchor="ctr" wrap="square" tIns="22860" bIns="22860"/>
+          <a:bodyPr wrap="square" tIns="22860" bIns="22860" rtlCol="0" anchor="ctr"/>
           <a:lstStyle/>
           <a:p>
             <a:pPr algn="l"/>
@@ -14733,7 +14946,7 @@
           </a:fontRef>
         </p:style>
         <p:txBody>
-          <a:bodyPr rtlCol="0" anchor="ctr" wrap="square" tIns="22860" bIns="22860" lIns="45720" rIns="45720"/>
+          <a:bodyPr wrap="square" lIns="45720" tIns="22860" rIns="45720" bIns="22860" rtlCol="0" anchor="ctr"/>
           <a:lstStyle/>
           <a:p>
             <a:pPr algn="l"/>
@@ -14787,7 +15000,7 @@
           </a:fontRef>
         </p:style>
         <p:txBody>
-          <a:bodyPr rtlCol="0" anchor="ctr" wrap="square" tIns="22860" bIns="22860"/>
+          <a:bodyPr wrap="square" tIns="22860" bIns="22860" rtlCol="0" anchor="ctr"/>
           <a:lstStyle/>
           <a:p>
             <a:pPr algn="l"/>
@@ -14841,7 +15054,7 @@
           </a:fontRef>
         </p:style>
         <p:txBody>
-          <a:bodyPr rtlCol="0" anchor="ctr" wrap="square" tIns="22860" bIns="22860" lIns="45720" rIns="45720"/>
+          <a:bodyPr wrap="square" lIns="45720" tIns="22860" rIns="45720" bIns="22860" rtlCol="0" anchor="ctr"/>
           <a:lstStyle/>
           <a:p>
             <a:pPr algn="l"/>
@@ -14893,7 +15106,7 @@
           </a:fontRef>
         </p:style>
         <p:txBody>
-          <a:bodyPr rtlCol="0" anchor="ctr" wrap="square"/>
+          <a:bodyPr wrap="square" rtlCol="0" anchor="ctr"/>
           <a:lstStyle/>
           <a:p>
             <a:pPr algn="ctr"/>
@@ -14947,7 +15160,7 @@
           </a:fontRef>
         </p:style>
         <p:txBody>
-          <a:bodyPr rtlCol="0" anchor="ctr" wrap="square" lIns="27432" tIns="22860" rIns="27432" bIns="22860"/>
+          <a:bodyPr wrap="square" lIns="27432" tIns="22860" rIns="27432" bIns="22860" rtlCol="0" anchor="ctr"/>
           <a:lstStyle/>
           <a:p>
             <a:pPr algn="ctr"/>
@@ -15038,7 +15251,7 @@
           </a:fontRef>
         </p:style>
         <p:txBody>
-          <a:bodyPr rtlCol="0" anchor="ctr" wrap="square" lIns="27432" tIns="22860" rIns="27432" bIns="22860"/>
+          <a:bodyPr wrap="square" lIns="27432" tIns="22860" rIns="27432" bIns="22860" rtlCol="0" anchor="ctr"/>
           <a:lstStyle/>
           <a:p>
             <a:pPr algn="ctr"/>
@@ -15129,7 +15342,7 @@
           </a:fontRef>
         </p:style>
         <p:txBody>
-          <a:bodyPr rtlCol="0" anchor="ctr" wrap="square" lIns="27432" tIns="22860" rIns="27432" bIns="22860"/>
+          <a:bodyPr wrap="square" lIns="27432" tIns="22860" rIns="27432" bIns="22860" rtlCol="0" anchor="ctr"/>
           <a:lstStyle/>
           <a:p>
             <a:pPr algn="ctr"/>
@@ -15220,7 +15433,7 @@
           </a:fontRef>
         </p:style>
         <p:txBody>
-          <a:bodyPr rtlCol="0" anchor="ctr" wrap="square" lIns="27432" tIns="22860" rIns="27432" bIns="22860"/>
+          <a:bodyPr wrap="square" lIns="27432" tIns="22860" rIns="27432" bIns="22860" rtlCol="0" anchor="ctr"/>
           <a:lstStyle/>
           <a:p>
             <a:pPr algn="ctr"/>
@@ -15311,7 +15524,7 @@
           </a:fontRef>
         </p:style>
         <p:txBody>
-          <a:bodyPr rtlCol="0" anchor="ctr" wrap="square" lIns="27432" tIns="22860" rIns="27432" bIns="22860"/>
+          <a:bodyPr wrap="square" lIns="27432" tIns="22860" rIns="27432" bIns="22860" rtlCol="0" anchor="ctr"/>
           <a:lstStyle/>
           <a:p>
             <a:pPr algn="ctr"/>
@@ -15402,7 +15615,7 @@
           </a:fontRef>
         </p:style>
         <p:txBody>
-          <a:bodyPr rtlCol="0" anchor="ctr" wrap="square" lIns="27432" tIns="22860" rIns="27432" bIns="22860"/>
+          <a:bodyPr wrap="square" lIns="27432" tIns="22860" rIns="27432" bIns="22860" rtlCol="0" anchor="ctr"/>
           <a:lstStyle/>
           <a:p>
             <a:pPr algn="ctr"/>
@@ -15431,26 +15644,26 @@
               <p:cTn id="2" dur="indefinite" nodeType="mainSeq">
                 <p:childTnLst>
                   <p:par>
-                    <p:cTn id="43" fill="hold">
+                    <p:cTn id="3" fill="hold">
                       <p:stCondLst>
                         <p:cond delay="indefinite"/>
                       </p:stCondLst>
                       <p:childTnLst>
                         <p:par>
-                          <p:cTn id="44" fill="hold">
+                          <p:cTn id="4" fill="hold">
                             <p:stCondLst>
                               <p:cond delay="0"/>
                             </p:stCondLst>
                             <p:childTnLst>
                               <p:par>
-                                <p:cTn id="45" presetID="10" presetClass="entr" presetSubtype="0" fill="hold" grpId="0" nodeType="clickEffect">
+                                <p:cTn id="5" presetID="10" presetClass="entr" presetSubtype="0" fill="hold" nodeType="clickEffect">
                                   <p:stCondLst>
                                     <p:cond delay="0"/>
                                   </p:stCondLst>
                                   <p:childTnLst>
                                     <p:set>
                                       <p:cBhvr>
-                                        <p:cTn id="46" dur="1" fill="hold">
+                                        <p:cTn id="6" dur="1" fill="hold">
                                           <p:stCondLst>
                                             <p:cond delay="0"/>
                                           </p:stCondLst>
@@ -15468,7 +15681,7 @@
                                     </p:set>
                                     <p:animEffect transition="in" filter="fade">
                                       <p:cBhvr>
-                                        <p:cTn id="47" dur="500"/>
+                                        <p:cTn id="7" dur="500"/>
                                         <p:tgtEl>
                                           <p:spTgt spid="16"/>
                                         </p:tgtEl>
@@ -15478,14 +15691,14 @@
                                 </p:cTn>
                               </p:par>
                               <p:par>
-                                <p:cTn id="48" presetID="10" presetClass="entr" presetSubtype="0" fill="hold" grpId="0" nodeType="withEffect">
+                                <p:cTn id="8" presetID="10" presetClass="entr" presetSubtype="0" fill="hold" nodeType="withEffect">
                                   <p:stCondLst>
                                     <p:cond delay="0"/>
                                   </p:stCondLst>
                                   <p:childTnLst>
                                     <p:set>
                                       <p:cBhvr>
-                                        <p:cTn id="49" dur="1" fill="hold">
+                                        <p:cTn id="9" dur="1" fill="hold">
                                           <p:stCondLst>
                                             <p:cond delay="0"/>
                                           </p:stCondLst>
@@ -15503,7 +15716,7 @@
                                     </p:set>
                                     <p:animEffect transition="in" filter="fade">
                                       <p:cBhvr>
-                                        <p:cTn id="50" dur="500"/>
+                                        <p:cTn id="10" dur="500"/>
                                         <p:tgtEl>
                                           <p:spTgt spid="17"/>
                                         </p:tgtEl>
@@ -15513,14 +15726,14 @@
                                 </p:cTn>
                               </p:par>
                               <p:par>
-                                <p:cTn id="51" presetID="10" presetClass="entr" presetSubtype="0" fill="hold" grpId="0" nodeType="withEffect">
+                                <p:cTn id="11" presetID="10" presetClass="entr" presetSubtype="0" fill="hold" nodeType="withEffect">
                                   <p:stCondLst>
                                     <p:cond delay="0"/>
                                   </p:stCondLst>
                                   <p:childTnLst>
                                     <p:set>
                                       <p:cBhvr>
-                                        <p:cTn id="52" dur="1" fill="hold">
+                                        <p:cTn id="12" dur="1" fill="hold">
                                           <p:stCondLst>
                                             <p:cond delay="0"/>
                                           </p:stCondLst>
@@ -15538,7 +15751,7 @@
                                     </p:set>
                                     <p:animEffect transition="in" filter="fade">
                                       <p:cBhvr>
-                                        <p:cTn id="53" dur="500"/>
+                                        <p:cTn id="13" dur="500"/>
                                         <p:tgtEl>
                                           <p:spTgt spid="18"/>
                                         </p:tgtEl>
@@ -15548,14 +15761,14 @@
                                 </p:cTn>
                               </p:par>
                               <p:par>
-                                <p:cTn id="54" presetID="10" presetClass="entr" presetSubtype="0" fill="hold" grpId="0" nodeType="withEffect">
+                                <p:cTn id="14" presetID="10" presetClass="entr" presetSubtype="0" fill="hold" nodeType="withEffect">
                                   <p:stCondLst>
                                     <p:cond delay="0"/>
                                   </p:stCondLst>
                                   <p:childTnLst>
                                     <p:set>
                                       <p:cBhvr>
-                                        <p:cTn id="55" dur="1" fill="hold">
+                                        <p:cTn id="15" dur="1" fill="hold">
                                           <p:stCondLst>
                                             <p:cond delay="0"/>
                                           </p:stCondLst>
@@ -15573,7 +15786,7 @@
                                     </p:set>
                                     <p:animEffect transition="in" filter="fade">
                                       <p:cBhvr>
-                                        <p:cTn id="56" dur="500"/>
+                                        <p:cTn id="16" dur="500"/>
                                         <p:tgtEl>
                                           <p:spTgt spid="19"/>
                                         </p:tgtEl>
@@ -15583,14 +15796,14 @@
                                 </p:cTn>
                               </p:par>
                               <p:par>
-                                <p:cTn id="57" presetID="10" presetClass="entr" presetSubtype="0" fill="hold" grpId="0" nodeType="withEffect">
+                                <p:cTn id="17" presetID="10" presetClass="entr" presetSubtype="0" fill="hold" nodeType="withEffect">
                                   <p:stCondLst>
                                     <p:cond delay="0"/>
                                   </p:stCondLst>
                                   <p:childTnLst>
                                     <p:set>
                                       <p:cBhvr>
-                                        <p:cTn id="58" dur="1" fill="hold">
+                                        <p:cTn id="18" dur="1" fill="hold">
                                           <p:stCondLst>
                                             <p:cond delay="0"/>
                                           </p:stCondLst>
@@ -15608,7 +15821,7 @@
                                     </p:set>
                                     <p:animEffect transition="in" filter="fade">
                                       <p:cBhvr>
-                                        <p:cTn id="59" dur="500"/>
+                                        <p:cTn id="19" dur="500"/>
                                         <p:tgtEl>
                                           <p:spTgt spid="20"/>
                                         </p:tgtEl>
@@ -15618,14 +15831,14 @@
                                 </p:cTn>
                               </p:par>
                               <p:par>
-                                <p:cTn id="60" presetID="10" presetClass="entr" presetSubtype="0" fill="hold" grpId="0" nodeType="withEffect">
+                                <p:cTn id="20" presetID="10" presetClass="entr" presetSubtype="0" fill="hold" nodeType="withEffect">
                                   <p:stCondLst>
                                     <p:cond delay="0"/>
                                   </p:stCondLst>
                                   <p:childTnLst>
                                     <p:set>
                                       <p:cBhvr>
-                                        <p:cTn id="61" dur="1" fill="hold">
+                                        <p:cTn id="21" dur="1" fill="hold">
                                           <p:stCondLst>
                                             <p:cond delay="0"/>
                                           </p:stCondLst>
@@ -15643,7 +15856,7 @@
                                     </p:set>
                                     <p:animEffect transition="in" filter="fade">
                                       <p:cBhvr>
-                                        <p:cTn id="62" dur="500"/>
+                                        <p:cTn id="22" dur="500"/>
                                         <p:tgtEl>
                                           <p:spTgt spid="21"/>
                                         </p:tgtEl>
@@ -15653,14 +15866,14 @@
                                 </p:cTn>
                               </p:par>
                               <p:par>
-                                <p:cTn id="63" presetID="10" presetClass="entr" presetSubtype="0" fill="hold" grpId="0" nodeType="withEffect">
+                                <p:cTn id="23" presetID="10" presetClass="entr" presetSubtype="0" fill="hold" nodeType="withEffect">
                                   <p:stCondLst>
                                     <p:cond delay="0"/>
                                   </p:stCondLst>
                                   <p:childTnLst>
                                     <p:set>
                                       <p:cBhvr>
-                                        <p:cTn id="64" dur="1" fill="hold">
+                                        <p:cTn id="24" dur="1" fill="hold">
                                           <p:stCondLst>
                                             <p:cond delay="0"/>
                                           </p:stCondLst>
@@ -15678,7 +15891,7 @@
                                     </p:set>
                                     <p:animEffect transition="in" filter="fade">
                                       <p:cBhvr>
-                                        <p:cTn id="65" dur="500"/>
+                                        <p:cTn id="25" dur="500"/>
                                         <p:tgtEl>
                                           <p:spTgt spid="22"/>
                                         </p:tgtEl>
@@ -15688,14 +15901,14 @@
                                 </p:cTn>
                               </p:par>
                               <p:par>
-                                <p:cTn id="66" presetID="10" presetClass="entr" presetSubtype="0" fill="hold" grpId="0" nodeType="withEffect">
+                                <p:cTn id="26" presetID="10" presetClass="entr" presetSubtype="0" fill="hold" nodeType="withEffect">
                                   <p:stCondLst>
                                     <p:cond delay="0"/>
                                   </p:stCondLst>
                                   <p:childTnLst>
                                     <p:set>
                                       <p:cBhvr>
-                                        <p:cTn id="67" dur="1" fill="hold">
+                                        <p:cTn id="27" dur="1" fill="hold">
                                           <p:stCondLst>
                                             <p:cond delay="0"/>
                                           </p:stCondLst>
@@ -15713,7 +15926,7 @@
                                     </p:set>
                                     <p:animEffect transition="in" filter="fade">
                                       <p:cBhvr>
-                                        <p:cTn id="68" dur="500"/>
+                                        <p:cTn id="28" dur="500"/>
                                         <p:tgtEl>
                                           <p:spTgt spid="23"/>
                                         </p:tgtEl>
@@ -15729,26 +15942,26 @@
                     </p:cTn>
                   </p:par>
                   <p:par>
-                    <p:cTn id="69" fill="hold">
+                    <p:cTn id="29" fill="hold">
                       <p:stCondLst>
                         <p:cond delay="indefinite"/>
                       </p:stCondLst>
                       <p:childTnLst>
                         <p:par>
-                          <p:cTn id="70" fill="hold">
+                          <p:cTn id="30" fill="hold">
                             <p:stCondLst>
                               <p:cond delay="0"/>
                             </p:stCondLst>
                             <p:childTnLst>
                               <p:par>
-                                <p:cTn id="71" presetID="10" presetClass="entr" presetSubtype="0" fill="hold" grpId="0" nodeType="clickEffect">
+                                <p:cTn id="31" presetID="10" presetClass="entr" presetSubtype="0" fill="hold" nodeType="clickEffect">
                                   <p:stCondLst>
                                     <p:cond delay="0"/>
                                   </p:stCondLst>
                                   <p:childTnLst>
                                     <p:set>
                                       <p:cBhvr>
-                                        <p:cTn id="72" dur="1" fill="hold">
+                                        <p:cTn id="32" dur="1" fill="hold">
                                           <p:stCondLst>
                                             <p:cond delay="0"/>
                                           </p:stCondLst>
@@ -15766,7 +15979,7 @@
                                     </p:set>
                                     <p:animEffect transition="in" filter="fade">
                                       <p:cBhvr>
-                                        <p:cTn id="73" dur="500"/>
+                                        <p:cTn id="33" dur="500"/>
                                         <p:tgtEl>
                                           <p:spTgt spid="24"/>
                                         </p:tgtEl>
@@ -15776,14 +15989,14 @@
                                 </p:cTn>
                               </p:par>
                               <p:par>
-                                <p:cTn id="74" presetID="10" presetClass="entr" presetSubtype="0" fill="hold" grpId="0" nodeType="withEffect">
+                                <p:cTn id="34" presetID="10" presetClass="entr" presetSubtype="0" fill="hold" nodeType="withEffect">
                                   <p:stCondLst>
                                     <p:cond delay="0"/>
                                   </p:stCondLst>
                                   <p:childTnLst>
                                     <p:set>
                                       <p:cBhvr>
-                                        <p:cTn id="75" dur="1" fill="hold">
+                                        <p:cTn id="35" dur="1" fill="hold">
                                           <p:stCondLst>
                                             <p:cond delay="0"/>
                                           </p:stCondLst>
@@ -15801,7 +16014,7 @@
                                     </p:set>
                                     <p:animEffect transition="in" filter="fade">
                                       <p:cBhvr>
-                                        <p:cTn id="76" dur="500"/>
+                                        <p:cTn id="36" dur="500"/>
                                         <p:tgtEl>
                                           <p:spTgt spid="25"/>
                                         </p:tgtEl>
@@ -15811,14 +16024,14 @@
                                 </p:cTn>
                               </p:par>
                               <p:par>
-                                <p:cTn id="77" presetID="10" presetClass="entr" presetSubtype="0" fill="hold" grpId="0" nodeType="withEffect">
+                                <p:cTn id="37" presetID="10" presetClass="entr" presetSubtype="0" fill="hold" nodeType="withEffect">
                                   <p:stCondLst>
                                     <p:cond delay="0"/>
                                   </p:stCondLst>
                                   <p:childTnLst>
                                     <p:set>
                                       <p:cBhvr>
-                                        <p:cTn id="78" dur="1" fill="hold">
+                                        <p:cTn id="38" dur="1" fill="hold">
                                           <p:stCondLst>
                                             <p:cond delay="0"/>
                                           </p:stCondLst>
@@ -15836,7 +16049,7 @@
                                     </p:set>
                                     <p:animEffect transition="in" filter="fade">
                                       <p:cBhvr>
-                                        <p:cTn id="79" dur="500"/>
+                                        <p:cTn id="39" dur="500"/>
                                         <p:tgtEl>
                                           <p:spTgt spid="26"/>
                                         </p:tgtEl>
@@ -15846,14 +16059,14 @@
                                 </p:cTn>
                               </p:par>
                               <p:par>
-                                <p:cTn id="80" presetID="10" presetClass="entr" presetSubtype="0" fill="hold" grpId="0" nodeType="withEffect">
+                                <p:cTn id="40" presetID="10" presetClass="entr" presetSubtype="0" fill="hold" nodeType="withEffect">
                                   <p:stCondLst>
                                     <p:cond delay="0"/>
                                   </p:stCondLst>
                                   <p:childTnLst>
                                     <p:set>
                                       <p:cBhvr>
-                                        <p:cTn id="81" dur="1" fill="hold">
+                                        <p:cTn id="41" dur="1" fill="hold">
                                           <p:stCondLst>
                                             <p:cond delay="0"/>
                                           </p:stCondLst>
@@ -15871,7 +16084,7 @@
                                     </p:set>
                                     <p:animEffect transition="in" filter="fade">
                                       <p:cBhvr>
-                                        <p:cTn id="82" dur="500"/>
+                                        <p:cTn id="42" dur="500"/>
                                         <p:tgtEl>
                                           <p:spTgt spid="27"/>
                                         </p:tgtEl>
@@ -15881,14 +16094,14 @@
                                 </p:cTn>
                               </p:par>
                               <p:par>
-                                <p:cTn id="83" presetID="10" presetClass="entr" presetSubtype="0" fill="hold" grpId="0" nodeType="withEffect">
+                                <p:cTn id="43" presetID="10" presetClass="entr" presetSubtype="0" fill="hold" nodeType="withEffect">
                                   <p:stCondLst>
                                     <p:cond delay="0"/>
                                   </p:stCondLst>
                                   <p:childTnLst>
                                     <p:set>
                                       <p:cBhvr>
-                                        <p:cTn id="84" dur="1" fill="hold">
+                                        <p:cTn id="44" dur="1" fill="hold">
                                           <p:stCondLst>
                                             <p:cond delay="0"/>
                                           </p:stCondLst>
@@ -15906,7 +16119,7 @@
                                     </p:set>
                                     <p:animEffect transition="in" filter="fade">
                                       <p:cBhvr>
-                                        <p:cTn id="85" dur="500"/>
+                                        <p:cTn id="45" dur="500"/>
                                         <p:tgtEl>
                                           <p:spTgt spid="28"/>
                                         </p:tgtEl>
@@ -15916,14 +16129,14 @@
                                 </p:cTn>
                               </p:par>
                               <p:par>
-                                <p:cTn id="86" presetID="10" presetClass="entr" presetSubtype="0" fill="hold" grpId="0" nodeType="withEffect">
+                                <p:cTn id="46" presetID="10" presetClass="entr" presetSubtype="0" fill="hold" nodeType="withEffect">
                                   <p:stCondLst>
                                     <p:cond delay="0"/>
                                   </p:stCondLst>
                                   <p:childTnLst>
                                     <p:set>
                                       <p:cBhvr>
-                                        <p:cTn id="87" dur="1" fill="hold">
+                                        <p:cTn id="47" dur="1" fill="hold">
                                           <p:stCondLst>
                                             <p:cond delay="0"/>
                                           </p:stCondLst>
@@ -15941,9 +16154,465 @@
                                     </p:set>
                                     <p:animEffect transition="in" filter="fade">
                                       <p:cBhvr>
+                                        <p:cTn id="48" dur="500"/>
+                                        <p:tgtEl>
+                                          <p:spTgt spid="29"/>
+                                        </p:tgtEl>
+                                      </p:cBhvr>
+                                    </p:animEffect>
+                                  </p:childTnLst>
+                                </p:cTn>
+                              </p:par>
+                            </p:childTnLst>
+                          </p:cTn>
+                        </p:par>
+                      </p:childTnLst>
+                    </p:cTn>
+                  </p:par>
+                  <p:par>
+                    <p:cTn id="49" fill="hold">
+                      <p:stCondLst>
+                        <p:cond delay="indefinite"/>
+                      </p:stCondLst>
+                      <p:childTnLst>
+                        <p:par>
+                          <p:cTn id="50" fill="hold">
+                            <p:stCondLst>
+                              <p:cond delay="0"/>
+                            </p:stCondLst>
+                            <p:childTnLst>
+                              <p:par>
+                                <p:cTn id="51" presetID="10" presetClass="entr" presetSubtype="0" fill="hold" nodeType="clickEffect">
+                                  <p:stCondLst>
+                                    <p:cond delay="0"/>
+                                  </p:stCondLst>
+                                  <p:childTnLst>
+                                    <p:set>
+                                      <p:cBhvr>
+                                        <p:cTn id="52" dur="1" fill="hold">
+                                          <p:stCondLst>
+                                            <p:cond delay="0"/>
+                                          </p:stCondLst>
+                                        </p:cTn>
+                                        <p:tgtEl>
+                                          <p:spTgt spid="30"/>
+                                        </p:tgtEl>
+                                        <p:attrNameLst>
+                                          <p:attrName>style.visibility</p:attrName>
+                                        </p:attrNameLst>
+                                      </p:cBhvr>
+                                      <p:to>
+                                        <p:strVal val="visible"/>
+                                      </p:to>
+                                    </p:set>
+                                    <p:animEffect transition="in" filter="fade">
+                                      <p:cBhvr>
+                                        <p:cTn id="53" dur="500"/>
+                                        <p:tgtEl>
+                                          <p:spTgt spid="30"/>
+                                        </p:tgtEl>
+                                      </p:cBhvr>
+                                    </p:animEffect>
+                                  </p:childTnLst>
+                                </p:cTn>
+                              </p:par>
+                            </p:childTnLst>
+                          </p:cTn>
+                        </p:par>
+                      </p:childTnLst>
+                    </p:cTn>
+                  </p:par>
+                  <p:par>
+                    <p:cTn id="54" fill="hold">
+                      <p:stCondLst>
+                        <p:cond delay="indefinite"/>
+                      </p:stCondLst>
+                      <p:childTnLst>
+                        <p:par>
+                          <p:cTn id="55" fill="hold">
+                            <p:stCondLst>
+                              <p:cond delay="0"/>
+                            </p:stCondLst>
+                            <p:childTnLst>
+                              <p:par>
+                                <p:cTn id="56" presetID="10" presetClass="entr" presetSubtype="0" fill="hold" nodeType="clickEffect">
+                                  <p:stCondLst>
+                                    <p:cond delay="0"/>
+                                  </p:stCondLst>
+                                  <p:childTnLst>
+                                    <p:set>
+                                      <p:cBhvr>
+                                        <p:cTn id="57" dur="1" fill="hold">
+                                          <p:stCondLst>
+                                            <p:cond delay="0"/>
+                                          </p:stCondLst>
+                                        </p:cTn>
+                                        <p:tgtEl>
+                                          <p:spTgt spid="94"/>
+                                        </p:tgtEl>
+                                        <p:attrNameLst>
+                                          <p:attrName>style.visibility</p:attrName>
+                                        </p:attrNameLst>
+                                      </p:cBhvr>
+                                      <p:to>
+                                        <p:strVal val="visible"/>
+                                      </p:to>
+                                    </p:set>
+                                    <p:animEffect transition="in" filter="fade">
+                                      <p:cBhvr>
+                                        <p:cTn id="58" dur="500"/>
+                                        <p:tgtEl>
+                                          <p:spTgt spid="94"/>
+                                        </p:tgtEl>
+                                      </p:cBhvr>
+                                    </p:animEffect>
+                                  </p:childTnLst>
+                                </p:cTn>
+                              </p:par>
+                              <p:par>
+                                <p:cTn id="59" presetID="10" presetClass="entr" presetSubtype="0" fill="hold" nodeType="withEffect">
+                                  <p:stCondLst>
+                                    <p:cond delay="0"/>
+                                  </p:stCondLst>
+                                  <p:childTnLst>
+                                    <p:set>
+                                      <p:cBhvr>
+                                        <p:cTn id="60" dur="1" fill="hold">
+                                          <p:stCondLst>
+                                            <p:cond delay="0"/>
+                                          </p:stCondLst>
+                                        </p:cTn>
+                                        <p:tgtEl>
+                                          <p:spTgt spid="95"/>
+                                        </p:tgtEl>
+                                        <p:attrNameLst>
+                                          <p:attrName>style.visibility</p:attrName>
+                                        </p:attrNameLst>
+                                      </p:cBhvr>
+                                      <p:to>
+                                        <p:strVal val="visible"/>
+                                      </p:to>
+                                    </p:set>
+                                    <p:animEffect transition="in" filter="fade">
+                                      <p:cBhvr>
+                                        <p:cTn id="61" dur="500"/>
+                                        <p:tgtEl>
+                                          <p:spTgt spid="95"/>
+                                        </p:tgtEl>
+                                      </p:cBhvr>
+                                    </p:animEffect>
+                                  </p:childTnLst>
+                                </p:cTn>
+                              </p:par>
+                              <p:par>
+                                <p:cTn id="62" presetID="10" presetClass="entr" presetSubtype="0" fill="hold" nodeType="withEffect">
+                                  <p:stCondLst>
+                                    <p:cond delay="0"/>
+                                  </p:stCondLst>
+                                  <p:childTnLst>
+                                    <p:set>
+                                      <p:cBhvr>
+                                        <p:cTn id="63" dur="1" fill="hold">
+                                          <p:stCondLst>
+                                            <p:cond delay="0"/>
+                                          </p:stCondLst>
+                                        </p:cTn>
+                                        <p:tgtEl>
+                                          <p:spTgt spid="96"/>
+                                        </p:tgtEl>
+                                        <p:attrNameLst>
+                                          <p:attrName>style.visibility</p:attrName>
+                                        </p:attrNameLst>
+                                      </p:cBhvr>
+                                      <p:to>
+                                        <p:strVal val="visible"/>
+                                      </p:to>
+                                    </p:set>
+                                    <p:animEffect transition="in" filter="fade">
+                                      <p:cBhvr>
+                                        <p:cTn id="64" dur="500"/>
+                                        <p:tgtEl>
+                                          <p:spTgt spid="96"/>
+                                        </p:tgtEl>
+                                      </p:cBhvr>
+                                    </p:animEffect>
+                                  </p:childTnLst>
+                                </p:cTn>
+                              </p:par>
+                              <p:par>
+                                <p:cTn id="65" presetID="10" presetClass="entr" presetSubtype="0" fill="hold" nodeType="withEffect">
+                                  <p:stCondLst>
+                                    <p:cond delay="0"/>
+                                  </p:stCondLst>
+                                  <p:childTnLst>
+                                    <p:set>
+                                      <p:cBhvr>
+                                        <p:cTn id="66" dur="1" fill="hold">
+                                          <p:stCondLst>
+                                            <p:cond delay="0"/>
+                                          </p:stCondLst>
+                                        </p:cTn>
+                                        <p:tgtEl>
+                                          <p:spTgt spid="97"/>
+                                        </p:tgtEl>
+                                        <p:attrNameLst>
+                                          <p:attrName>style.visibility</p:attrName>
+                                        </p:attrNameLst>
+                                      </p:cBhvr>
+                                      <p:to>
+                                        <p:strVal val="visible"/>
+                                      </p:to>
+                                    </p:set>
+                                    <p:animEffect transition="in" filter="fade">
+                                      <p:cBhvr>
+                                        <p:cTn id="67" dur="500"/>
+                                        <p:tgtEl>
+                                          <p:spTgt spid="97"/>
+                                        </p:tgtEl>
+                                      </p:cBhvr>
+                                    </p:animEffect>
+                                  </p:childTnLst>
+                                </p:cTn>
+                              </p:par>
+                              <p:par>
+                                <p:cTn id="68" presetID="10" presetClass="entr" presetSubtype="0" fill="hold" nodeType="withEffect">
+                                  <p:stCondLst>
+                                    <p:cond delay="0"/>
+                                  </p:stCondLst>
+                                  <p:childTnLst>
+                                    <p:set>
+                                      <p:cBhvr>
+                                        <p:cTn id="69" dur="1" fill="hold">
+                                          <p:stCondLst>
+                                            <p:cond delay="0"/>
+                                          </p:stCondLst>
+                                        </p:cTn>
+                                        <p:tgtEl>
+                                          <p:spTgt spid="98"/>
+                                        </p:tgtEl>
+                                        <p:attrNameLst>
+                                          <p:attrName>style.visibility</p:attrName>
+                                        </p:attrNameLst>
+                                      </p:cBhvr>
+                                      <p:to>
+                                        <p:strVal val="visible"/>
+                                      </p:to>
+                                    </p:set>
+                                    <p:animEffect transition="in" filter="fade">
+                                      <p:cBhvr>
+                                        <p:cTn id="70" dur="500"/>
+                                        <p:tgtEl>
+                                          <p:spTgt spid="98"/>
+                                        </p:tgtEl>
+                                      </p:cBhvr>
+                                    </p:animEffect>
+                                  </p:childTnLst>
+                                </p:cTn>
+                              </p:par>
+                              <p:par>
+                                <p:cTn id="71" presetID="10" presetClass="entr" presetSubtype="0" fill="hold" nodeType="withEffect">
+                                  <p:stCondLst>
+                                    <p:cond delay="0"/>
+                                  </p:stCondLst>
+                                  <p:childTnLst>
+                                    <p:set>
+                                      <p:cBhvr>
+                                        <p:cTn id="72" dur="1" fill="hold">
+                                          <p:stCondLst>
+                                            <p:cond delay="0"/>
+                                          </p:stCondLst>
+                                        </p:cTn>
+                                        <p:tgtEl>
+                                          <p:spTgt spid="99"/>
+                                        </p:tgtEl>
+                                        <p:attrNameLst>
+                                          <p:attrName>style.visibility</p:attrName>
+                                        </p:attrNameLst>
+                                      </p:cBhvr>
+                                      <p:to>
+                                        <p:strVal val="visible"/>
+                                      </p:to>
+                                    </p:set>
+                                    <p:animEffect transition="in" filter="fade">
+                                      <p:cBhvr>
+                                        <p:cTn id="73" dur="500"/>
+                                        <p:tgtEl>
+                                          <p:spTgt spid="99"/>
+                                        </p:tgtEl>
+                                      </p:cBhvr>
+                                    </p:animEffect>
+                                  </p:childTnLst>
+                                </p:cTn>
+                              </p:par>
+                              <p:par>
+                                <p:cTn id="74" presetID="10" presetClass="entr" presetSubtype="0" fill="hold" nodeType="withEffect">
+                                  <p:stCondLst>
+                                    <p:cond delay="0"/>
+                                  </p:stCondLst>
+                                  <p:childTnLst>
+                                    <p:set>
+                                      <p:cBhvr>
+                                        <p:cTn id="75" dur="1" fill="hold">
+                                          <p:stCondLst>
+                                            <p:cond delay="0"/>
+                                          </p:stCondLst>
+                                        </p:cTn>
+                                        <p:tgtEl>
+                                          <p:spTgt spid="100"/>
+                                        </p:tgtEl>
+                                        <p:attrNameLst>
+                                          <p:attrName>style.visibility</p:attrName>
+                                        </p:attrNameLst>
+                                      </p:cBhvr>
+                                      <p:to>
+                                        <p:strVal val="visible"/>
+                                      </p:to>
+                                    </p:set>
+                                    <p:animEffect transition="in" filter="fade">
+                                      <p:cBhvr>
+                                        <p:cTn id="76" dur="500"/>
+                                        <p:tgtEl>
+                                          <p:spTgt spid="100"/>
+                                        </p:tgtEl>
+                                      </p:cBhvr>
+                                    </p:animEffect>
+                                  </p:childTnLst>
+                                </p:cTn>
+                              </p:par>
+                              <p:par>
+                                <p:cTn id="77" presetID="10" presetClass="entr" presetSubtype="0" fill="hold" nodeType="withEffect">
+                                  <p:stCondLst>
+                                    <p:cond delay="0"/>
+                                  </p:stCondLst>
+                                  <p:childTnLst>
+                                    <p:set>
+                                      <p:cBhvr>
+                                        <p:cTn id="78" dur="1" fill="hold">
+                                          <p:stCondLst>
+                                            <p:cond delay="0"/>
+                                          </p:stCondLst>
+                                        </p:cTn>
+                                        <p:tgtEl>
+                                          <p:spTgt spid="101"/>
+                                        </p:tgtEl>
+                                        <p:attrNameLst>
+                                          <p:attrName>style.visibility</p:attrName>
+                                        </p:attrNameLst>
+                                      </p:cBhvr>
+                                      <p:to>
+                                        <p:strVal val="visible"/>
+                                      </p:to>
+                                    </p:set>
+                                    <p:animEffect transition="in" filter="fade">
+                                      <p:cBhvr>
+                                        <p:cTn id="79" dur="500"/>
+                                        <p:tgtEl>
+                                          <p:spTgt spid="101"/>
+                                        </p:tgtEl>
+                                      </p:cBhvr>
+                                    </p:animEffect>
+                                  </p:childTnLst>
+                                </p:cTn>
+                              </p:par>
+                              <p:par>
+                                <p:cTn id="80" presetID="10" presetClass="entr" presetSubtype="0" fill="hold" nodeType="withEffect">
+                                  <p:stCondLst>
+                                    <p:cond delay="0"/>
+                                  </p:stCondLst>
+                                  <p:childTnLst>
+                                    <p:set>
+                                      <p:cBhvr>
+                                        <p:cTn id="81" dur="1" fill="hold">
+                                          <p:stCondLst>
+                                            <p:cond delay="0"/>
+                                          </p:stCondLst>
+                                        </p:cTn>
+                                        <p:tgtEl>
+                                          <p:spTgt spid="102"/>
+                                        </p:tgtEl>
+                                        <p:attrNameLst>
+                                          <p:attrName>style.visibility</p:attrName>
+                                        </p:attrNameLst>
+                                      </p:cBhvr>
+                                      <p:to>
+                                        <p:strVal val="visible"/>
+                                      </p:to>
+                                    </p:set>
+                                    <p:animEffect transition="in" filter="fade">
+                                      <p:cBhvr>
+                                        <p:cTn id="82" dur="500"/>
+                                        <p:tgtEl>
+                                          <p:spTgt spid="102"/>
+                                        </p:tgtEl>
+                                      </p:cBhvr>
+                                    </p:animEffect>
+                                  </p:childTnLst>
+                                </p:cTn>
+                              </p:par>
+                              <p:par>
+                                <p:cTn id="83" presetID="10" presetClass="entr" presetSubtype="0" fill="hold" nodeType="withEffect">
+                                  <p:stCondLst>
+                                    <p:cond delay="0"/>
+                                  </p:stCondLst>
+                                  <p:childTnLst>
+                                    <p:set>
+                                      <p:cBhvr>
+                                        <p:cTn id="84" dur="1" fill="hold">
+                                          <p:stCondLst>
+                                            <p:cond delay="0"/>
+                                          </p:stCondLst>
+                                        </p:cTn>
+                                        <p:tgtEl>
+                                          <p:spTgt spid="103"/>
+                                        </p:tgtEl>
+                                        <p:attrNameLst>
+                                          <p:attrName>style.visibility</p:attrName>
+                                        </p:attrNameLst>
+                                      </p:cBhvr>
+                                      <p:to>
+                                        <p:strVal val="visible"/>
+                                      </p:to>
+                                    </p:set>
+                                    <p:animEffect transition="in" filter="fade">
+                                      <p:cBhvr>
+                                        <p:cTn id="85" dur="500"/>
+                                        <p:tgtEl>
+                                          <p:spTgt spid="103"/>
+                                        </p:tgtEl>
+                                      </p:cBhvr>
+                                    </p:animEffect>
+                                  </p:childTnLst>
+                                </p:cTn>
+                              </p:par>
+                              <p:par>
+                                <p:cTn id="86" presetID="10" presetClass="entr" presetSubtype="0" fill="hold" nodeType="withEffect">
+                                  <p:stCondLst>
+                                    <p:cond delay="0"/>
+                                  </p:stCondLst>
+                                  <p:childTnLst>
+                                    <p:set>
+                                      <p:cBhvr>
+                                        <p:cTn id="87" dur="1" fill="hold">
+                                          <p:stCondLst>
+                                            <p:cond delay="0"/>
+                                          </p:stCondLst>
+                                        </p:cTn>
+                                        <p:tgtEl>
+                                          <p:spTgt spid="104"/>
+                                        </p:tgtEl>
+                                        <p:attrNameLst>
+                                          <p:attrName>style.visibility</p:attrName>
+                                        </p:attrNameLst>
+                                      </p:cBhvr>
+                                      <p:to>
+                                        <p:strVal val="visible"/>
+                                      </p:to>
+                                    </p:set>
+                                    <p:animEffect transition="in" filter="fade">
+                                      <p:cBhvr>
                                         <p:cTn id="88" dur="500"/>
                                         <p:tgtEl>
-                                          <p:spTgt spid="29"/>
+                                          <p:spTgt spid="104"/>
                                         </p:tgtEl>
                                       </p:cBhvr>
                                     </p:animEffect>
@@ -15969,7 +16638,7 @@
                             </p:stCondLst>
                             <p:childTnLst>
                               <p:par>
-                                <p:cTn id="91" presetID="10" presetClass="entr" presetSubtype="0" fill="hold" grpId="0" nodeType="clickEffect">
+                                <p:cTn id="91" presetID="10" presetClass="entr" presetSubtype="0" fill="hold" nodeType="clickEffect">
                                   <p:stCondLst>
                                     <p:cond delay="0"/>
                                   </p:stCondLst>
@@ -15977,462 +16646,6 @@
                                     <p:set>
                                       <p:cBhvr>
                                         <p:cTn id="92" dur="1" fill="hold">
-                                          <p:stCondLst>
-                                            <p:cond delay="0"/>
-                                          </p:stCondLst>
-                                        </p:cTn>
-                                        <p:tgtEl>
-                                          <p:spTgt spid="30"/>
-                                        </p:tgtEl>
-                                        <p:attrNameLst>
-                                          <p:attrName>style.visibility</p:attrName>
-                                        </p:attrNameLst>
-                                      </p:cBhvr>
-                                      <p:to>
-                                        <p:strVal val="visible"/>
-                                      </p:to>
-                                    </p:set>
-                                    <p:animEffect transition="in" filter="fade">
-                                      <p:cBhvr>
-                                        <p:cTn id="93" dur="500"/>
-                                        <p:tgtEl>
-                                          <p:spTgt spid="30"/>
-                                        </p:tgtEl>
-                                      </p:cBhvr>
-                                    </p:animEffect>
-                                  </p:childTnLst>
-                                </p:cTn>
-                              </p:par>
-                            </p:childTnLst>
-                          </p:cTn>
-                        </p:par>
-                      </p:childTnLst>
-                    </p:cTn>
-                  </p:par>
-                  <p:par>
-                    <p:cTn id="3" fill="hold">
-                      <p:stCondLst>
-                        <p:cond delay="indefinite"/>
-                      </p:stCondLst>
-                      <p:childTnLst>
-                        <p:par>
-                          <p:cTn id="4" fill="hold">
-                            <p:stCondLst>
-                              <p:cond delay="0"/>
-                            </p:stCondLst>
-                            <p:childTnLst>
-                              <p:par>
-                                <p:cTn id="5" presetID="10" presetClass="entr" presetSubtype="0" fill="hold" grpId="0" nodeType="clickEffect">
-                                  <p:stCondLst>
-                                    <p:cond delay="0"/>
-                                  </p:stCondLst>
-                                  <p:childTnLst>
-                                    <p:set>
-                                      <p:cBhvr>
-                                        <p:cTn id="6" dur="1" fill="hold">
-                                          <p:stCondLst>
-                                            <p:cond delay="0"/>
-                                          </p:stCondLst>
-                                        </p:cTn>
-                                        <p:tgtEl>
-                                          <p:spTgt spid="94"/>
-                                        </p:tgtEl>
-                                        <p:attrNameLst>
-                                          <p:attrName>style.visibility</p:attrName>
-                                        </p:attrNameLst>
-                                      </p:cBhvr>
-                                      <p:to>
-                                        <p:strVal val="visible"/>
-                                      </p:to>
-                                    </p:set>
-                                    <p:animEffect transition="in" filter="fade">
-                                      <p:cBhvr>
-                                        <p:cTn id="7" dur="500"/>
-                                        <p:tgtEl>
-                                          <p:spTgt spid="94"/>
-                                        </p:tgtEl>
-                                      </p:cBhvr>
-                                    </p:animEffect>
-                                  </p:childTnLst>
-                                </p:cTn>
-                              </p:par>
-                              <p:par>
-                                <p:cTn id="8" presetID="10" presetClass="entr" presetSubtype="0" fill="hold" grpId="0" nodeType="withEffect">
-                                  <p:stCondLst>
-                                    <p:cond delay="0"/>
-                                  </p:stCondLst>
-                                  <p:childTnLst>
-                                    <p:set>
-                                      <p:cBhvr>
-                                        <p:cTn id="9" dur="1" fill="hold">
-                                          <p:stCondLst>
-                                            <p:cond delay="0"/>
-                                          </p:stCondLst>
-                                        </p:cTn>
-                                        <p:tgtEl>
-                                          <p:spTgt spid="95"/>
-                                        </p:tgtEl>
-                                        <p:attrNameLst>
-                                          <p:attrName>style.visibility</p:attrName>
-                                        </p:attrNameLst>
-                                      </p:cBhvr>
-                                      <p:to>
-                                        <p:strVal val="visible"/>
-                                      </p:to>
-                                    </p:set>
-                                    <p:animEffect transition="in" filter="fade">
-                                      <p:cBhvr>
-                                        <p:cTn id="10" dur="500"/>
-                                        <p:tgtEl>
-                                          <p:spTgt spid="95"/>
-                                        </p:tgtEl>
-                                      </p:cBhvr>
-                                    </p:animEffect>
-                                  </p:childTnLst>
-                                </p:cTn>
-                              </p:par>
-                              <p:par>
-                                <p:cTn id="11" presetID="10" presetClass="entr" presetSubtype="0" fill="hold" grpId="0" nodeType="withEffect">
-                                  <p:stCondLst>
-                                    <p:cond delay="0"/>
-                                  </p:stCondLst>
-                                  <p:childTnLst>
-                                    <p:set>
-                                      <p:cBhvr>
-                                        <p:cTn id="12" dur="1" fill="hold">
-                                          <p:stCondLst>
-                                            <p:cond delay="0"/>
-                                          </p:stCondLst>
-                                        </p:cTn>
-                                        <p:tgtEl>
-                                          <p:spTgt spid="96"/>
-                                        </p:tgtEl>
-                                        <p:attrNameLst>
-                                          <p:attrName>style.visibility</p:attrName>
-                                        </p:attrNameLst>
-                                      </p:cBhvr>
-                                      <p:to>
-                                        <p:strVal val="visible"/>
-                                      </p:to>
-                                    </p:set>
-                                    <p:animEffect transition="in" filter="fade">
-                                      <p:cBhvr>
-                                        <p:cTn id="13" dur="500"/>
-                                        <p:tgtEl>
-                                          <p:spTgt spid="96"/>
-                                        </p:tgtEl>
-                                      </p:cBhvr>
-                                    </p:animEffect>
-                                  </p:childTnLst>
-                                </p:cTn>
-                              </p:par>
-                              <p:par>
-                                <p:cTn id="14" presetID="10" presetClass="entr" presetSubtype="0" fill="hold" grpId="0" nodeType="withEffect">
-                                  <p:stCondLst>
-                                    <p:cond delay="0"/>
-                                  </p:stCondLst>
-                                  <p:childTnLst>
-                                    <p:set>
-                                      <p:cBhvr>
-                                        <p:cTn id="15" dur="1" fill="hold">
-                                          <p:stCondLst>
-                                            <p:cond delay="0"/>
-                                          </p:stCondLst>
-                                        </p:cTn>
-                                        <p:tgtEl>
-                                          <p:spTgt spid="97"/>
-                                        </p:tgtEl>
-                                        <p:attrNameLst>
-                                          <p:attrName>style.visibility</p:attrName>
-                                        </p:attrNameLst>
-                                      </p:cBhvr>
-                                      <p:to>
-                                        <p:strVal val="visible"/>
-                                      </p:to>
-                                    </p:set>
-                                    <p:animEffect transition="in" filter="fade">
-                                      <p:cBhvr>
-                                        <p:cTn id="16" dur="500"/>
-                                        <p:tgtEl>
-                                          <p:spTgt spid="97"/>
-                                        </p:tgtEl>
-                                      </p:cBhvr>
-                                    </p:animEffect>
-                                  </p:childTnLst>
-                                </p:cTn>
-                              </p:par>
-                              <p:par>
-                                <p:cTn id="17" presetID="10" presetClass="entr" presetSubtype="0" fill="hold" grpId="0" nodeType="withEffect">
-                                  <p:stCondLst>
-                                    <p:cond delay="0"/>
-                                  </p:stCondLst>
-                                  <p:childTnLst>
-                                    <p:set>
-                                      <p:cBhvr>
-                                        <p:cTn id="18" dur="1" fill="hold">
-                                          <p:stCondLst>
-                                            <p:cond delay="0"/>
-                                          </p:stCondLst>
-                                        </p:cTn>
-                                        <p:tgtEl>
-                                          <p:spTgt spid="98"/>
-                                        </p:tgtEl>
-                                        <p:attrNameLst>
-                                          <p:attrName>style.visibility</p:attrName>
-                                        </p:attrNameLst>
-                                      </p:cBhvr>
-                                      <p:to>
-                                        <p:strVal val="visible"/>
-                                      </p:to>
-                                    </p:set>
-                                    <p:animEffect transition="in" filter="fade">
-                                      <p:cBhvr>
-                                        <p:cTn id="19" dur="500"/>
-                                        <p:tgtEl>
-                                          <p:spTgt spid="98"/>
-                                        </p:tgtEl>
-                                      </p:cBhvr>
-                                    </p:animEffect>
-                                  </p:childTnLst>
-                                </p:cTn>
-                              </p:par>
-                              <p:par>
-                                <p:cTn id="20" presetID="10" presetClass="entr" presetSubtype="0" fill="hold" grpId="0" nodeType="withEffect">
-                                  <p:stCondLst>
-                                    <p:cond delay="0"/>
-                                  </p:stCondLst>
-                                  <p:childTnLst>
-                                    <p:set>
-                                      <p:cBhvr>
-                                        <p:cTn id="21" dur="1" fill="hold">
-                                          <p:stCondLst>
-                                            <p:cond delay="0"/>
-                                          </p:stCondLst>
-                                        </p:cTn>
-                                        <p:tgtEl>
-                                          <p:spTgt spid="99"/>
-                                        </p:tgtEl>
-                                        <p:attrNameLst>
-                                          <p:attrName>style.visibility</p:attrName>
-                                        </p:attrNameLst>
-                                      </p:cBhvr>
-                                      <p:to>
-                                        <p:strVal val="visible"/>
-                                      </p:to>
-                                    </p:set>
-                                    <p:animEffect transition="in" filter="fade">
-                                      <p:cBhvr>
-                                        <p:cTn id="22" dur="500"/>
-                                        <p:tgtEl>
-                                          <p:spTgt spid="99"/>
-                                        </p:tgtEl>
-                                      </p:cBhvr>
-                                    </p:animEffect>
-                                  </p:childTnLst>
-                                </p:cTn>
-                              </p:par>
-                              <p:par>
-                                <p:cTn id="23" presetID="10" presetClass="entr" presetSubtype="0" fill="hold" grpId="0" nodeType="withEffect">
-                                  <p:stCondLst>
-                                    <p:cond delay="0"/>
-                                  </p:stCondLst>
-                                  <p:childTnLst>
-                                    <p:set>
-                                      <p:cBhvr>
-                                        <p:cTn id="24" dur="1" fill="hold">
-                                          <p:stCondLst>
-                                            <p:cond delay="0"/>
-                                          </p:stCondLst>
-                                        </p:cTn>
-                                        <p:tgtEl>
-                                          <p:spTgt spid="100"/>
-                                        </p:tgtEl>
-                                        <p:attrNameLst>
-                                          <p:attrName>style.visibility</p:attrName>
-                                        </p:attrNameLst>
-                                      </p:cBhvr>
-                                      <p:to>
-                                        <p:strVal val="visible"/>
-                                      </p:to>
-                                    </p:set>
-                                    <p:animEffect transition="in" filter="fade">
-                                      <p:cBhvr>
-                                        <p:cTn id="25" dur="500"/>
-                                        <p:tgtEl>
-                                          <p:spTgt spid="100"/>
-                                        </p:tgtEl>
-                                      </p:cBhvr>
-                                    </p:animEffect>
-                                  </p:childTnLst>
-                                </p:cTn>
-                              </p:par>
-                              <p:par>
-                                <p:cTn id="26" presetID="10" presetClass="entr" presetSubtype="0" fill="hold" grpId="0" nodeType="withEffect">
-                                  <p:stCondLst>
-                                    <p:cond delay="0"/>
-                                  </p:stCondLst>
-                                  <p:childTnLst>
-                                    <p:set>
-                                      <p:cBhvr>
-                                        <p:cTn id="27" dur="1" fill="hold">
-                                          <p:stCondLst>
-                                            <p:cond delay="0"/>
-                                          </p:stCondLst>
-                                        </p:cTn>
-                                        <p:tgtEl>
-                                          <p:spTgt spid="101"/>
-                                        </p:tgtEl>
-                                        <p:attrNameLst>
-                                          <p:attrName>style.visibility</p:attrName>
-                                        </p:attrNameLst>
-                                      </p:cBhvr>
-                                      <p:to>
-                                        <p:strVal val="visible"/>
-                                      </p:to>
-                                    </p:set>
-                                    <p:animEffect transition="in" filter="fade">
-                                      <p:cBhvr>
-                                        <p:cTn id="28" dur="500"/>
-                                        <p:tgtEl>
-                                          <p:spTgt spid="101"/>
-                                        </p:tgtEl>
-                                      </p:cBhvr>
-                                    </p:animEffect>
-                                  </p:childTnLst>
-                                </p:cTn>
-                              </p:par>
-                              <p:par>
-                                <p:cTn id="29" presetID="10" presetClass="entr" presetSubtype="0" fill="hold" grpId="0" nodeType="withEffect">
-                                  <p:stCondLst>
-                                    <p:cond delay="0"/>
-                                  </p:stCondLst>
-                                  <p:childTnLst>
-                                    <p:set>
-                                      <p:cBhvr>
-                                        <p:cTn id="30" dur="1" fill="hold">
-                                          <p:stCondLst>
-                                            <p:cond delay="0"/>
-                                          </p:stCondLst>
-                                        </p:cTn>
-                                        <p:tgtEl>
-                                          <p:spTgt spid="102"/>
-                                        </p:tgtEl>
-                                        <p:attrNameLst>
-                                          <p:attrName>style.visibility</p:attrName>
-                                        </p:attrNameLst>
-                                      </p:cBhvr>
-                                      <p:to>
-                                        <p:strVal val="visible"/>
-                                      </p:to>
-                                    </p:set>
-                                    <p:animEffect transition="in" filter="fade">
-                                      <p:cBhvr>
-                                        <p:cTn id="31" dur="500"/>
-                                        <p:tgtEl>
-                                          <p:spTgt spid="102"/>
-                                        </p:tgtEl>
-                                      </p:cBhvr>
-                                    </p:animEffect>
-                                  </p:childTnLst>
-                                </p:cTn>
-                              </p:par>
-                              <p:par>
-                                <p:cTn id="32" presetID="10" presetClass="entr" presetSubtype="0" fill="hold" grpId="0" nodeType="withEffect">
-                                  <p:stCondLst>
-                                    <p:cond delay="0"/>
-                                  </p:stCondLst>
-                                  <p:childTnLst>
-                                    <p:set>
-                                      <p:cBhvr>
-                                        <p:cTn id="33" dur="1" fill="hold">
-                                          <p:stCondLst>
-                                            <p:cond delay="0"/>
-                                          </p:stCondLst>
-                                        </p:cTn>
-                                        <p:tgtEl>
-                                          <p:spTgt spid="103"/>
-                                        </p:tgtEl>
-                                        <p:attrNameLst>
-                                          <p:attrName>style.visibility</p:attrName>
-                                        </p:attrNameLst>
-                                      </p:cBhvr>
-                                      <p:to>
-                                        <p:strVal val="visible"/>
-                                      </p:to>
-                                    </p:set>
-                                    <p:animEffect transition="in" filter="fade">
-                                      <p:cBhvr>
-                                        <p:cTn id="34" dur="500"/>
-                                        <p:tgtEl>
-                                          <p:spTgt spid="103"/>
-                                        </p:tgtEl>
-                                      </p:cBhvr>
-                                    </p:animEffect>
-                                  </p:childTnLst>
-                                </p:cTn>
-                              </p:par>
-                              <p:par>
-                                <p:cTn id="35" presetID="10" presetClass="entr" presetSubtype="0" fill="hold" grpId="0" nodeType="withEffect">
-                                  <p:stCondLst>
-                                    <p:cond delay="0"/>
-                                  </p:stCondLst>
-                                  <p:childTnLst>
-                                    <p:set>
-                                      <p:cBhvr>
-                                        <p:cTn id="36" dur="1" fill="hold">
-                                          <p:stCondLst>
-                                            <p:cond delay="0"/>
-                                          </p:stCondLst>
-                                        </p:cTn>
-                                        <p:tgtEl>
-                                          <p:spTgt spid="104"/>
-                                        </p:tgtEl>
-                                        <p:attrNameLst>
-                                          <p:attrName>style.visibility</p:attrName>
-                                        </p:attrNameLst>
-                                      </p:cBhvr>
-                                      <p:to>
-                                        <p:strVal val="visible"/>
-                                      </p:to>
-                                    </p:set>
-                                    <p:animEffect transition="in" filter="fade">
-                                      <p:cBhvr>
-                                        <p:cTn id="37" dur="500"/>
-                                        <p:tgtEl>
-                                          <p:spTgt spid="104"/>
-                                        </p:tgtEl>
-                                      </p:cBhvr>
-                                    </p:animEffect>
-                                  </p:childTnLst>
-                                </p:cTn>
-                              </p:par>
-                            </p:childTnLst>
-                          </p:cTn>
-                        </p:par>
-                      </p:childTnLst>
-                    </p:cTn>
-                  </p:par>
-                  <p:par>
-                    <p:cTn id="38" fill="hold">
-                      <p:stCondLst>
-                        <p:cond delay="indefinite"/>
-                      </p:stCondLst>
-                      <p:childTnLst>
-                        <p:par>
-                          <p:cTn id="39" fill="hold">
-                            <p:stCondLst>
-                              <p:cond delay="0"/>
-                            </p:stCondLst>
-                            <p:childTnLst>
-                              <p:par>
-                                <p:cTn id="40" presetID="10" presetClass="entr" presetSubtype="0" fill="hold" grpId="0" nodeType="clickEffect">
-                                  <p:stCondLst>
-                                    <p:cond delay="0"/>
-                                  </p:stCondLst>
-                                  <p:childTnLst>
-                                    <p:set>
-                                      <p:cBhvr>
-                                        <p:cTn id="41" dur="1" fill="hold">
                                           <p:stCondLst>
                                             <p:cond delay="0"/>
                                           </p:stCondLst>
@@ -16450,7 +16663,7 @@
                                     </p:set>
                                     <p:animEffect transition="in" filter="fade">
                                       <p:cBhvr>
-                                        <p:cTn id="42" dur="500"/>
+                                        <p:cTn id="93" dur="500"/>
                                         <p:tgtEl>
                                           <p:spTgt spid="15"/>
                                         </p:tgtEl>
@@ -16561,7 +16774,7 @@
           <a:p>
             <a:fld id="{B7EB45DA-9A0D-DC49-8E02-F30A5DDC21C3}" type="slidenum">
               <a:rPr lang="en-US" smtClean="0"/>
-              <a:t>27</a:t>
+              <a:t>26</a:t>
             </a:fld>
             <a:endParaRPr lang="en-US"/>
           </a:p>
@@ -16611,7 +16824,7 @@
                   <a:srgbClr val="5C4826"/>
                 </a:solidFill>
               </a:rPr>
-              <a:t xml:space="preserve"> against a bound of </a:t>
+              <a:t> against a bound of </a:t>
             </a:r>
             <a:r>
               <a:rPr lang="en-US" sz="2000" b="1" i="0" dirty="0">
@@ -17011,7 +17224,7 @@
           <a:p>
             <a:fld id="{B7EB45DA-9A0D-DC49-8E02-F30A5DDC21C3}" type="slidenum">
               <a:rPr lang="en-US" smtClean="0"/>
-              <a:t>28</a:t>
+              <a:t>27</a:t>
             </a:fld>
             <a:endParaRPr lang="en-US"/>
           </a:p>
@@ -17130,7 +17343,7 @@
           </a:fontRef>
         </p:style>
         <p:txBody>
-          <a:bodyPr rtlCol="0" anchor="ctr" wrap="square" lIns="27432" tIns="22860" rIns="27432" bIns="22860"/>
+          <a:bodyPr wrap="square" lIns="27432" tIns="22860" rIns="27432" bIns="22860" rtlCol="0" anchor="ctr"/>
           <a:lstStyle/>
           <a:p>
             <a:pPr algn="ctr"/>
@@ -17184,7 +17397,7 @@
           </a:fontRef>
         </p:style>
         <p:txBody>
-          <a:bodyPr rtlCol="0" anchor="ctr" wrap="square" lIns="27432" tIns="22860" rIns="27432" bIns="22860"/>
+          <a:bodyPr wrap="square" lIns="27432" tIns="22860" rIns="27432" bIns="22860" rtlCol="0" anchor="ctr"/>
           <a:lstStyle/>
           <a:p>
             <a:pPr algn="ctr"/>
@@ -17249,7 +17462,7 @@
           </a:fontRef>
         </p:style>
         <p:txBody>
-          <a:bodyPr rtlCol="0" anchor="ctr" wrap="square" lIns="27432" tIns="22860" rIns="27432" bIns="22860"/>
+          <a:bodyPr wrap="square" lIns="27432" tIns="22860" rIns="27432" bIns="22860" rtlCol="0" anchor="ctr"/>
           <a:lstStyle/>
           <a:p>
             <a:pPr algn="ctr"/>
@@ -17314,7 +17527,7 @@
           </a:fontRef>
         </p:style>
         <p:txBody>
-          <a:bodyPr rtlCol="0" anchor="ctr" wrap="square" lIns="27432" tIns="22860" rIns="27432" bIns="22860"/>
+          <a:bodyPr wrap="square" lIns="27432" tIns="22860" rIns="27432" bIns="22860" rtlCol="0" anchor="ctr"/>
           <a:lstStyle/>
           <a:p>
             <a:pPr algn="ctr"/>
@@ -17390,7 +17603,7 @@
           </a:fontRef>
         </p:style>
         <p:txBody>
-          <a:bodyPr rtlCol="0" anchor="ctr" wrap="square" lIns="27432" tIns="22860" rIns="27432" bIns="22860"/>
+          <a:bodyPr wrap="square" lIns="27432" tIns="22860" rIns="27432" bIns="22860" rtlCol="0" anchor="ctr"/>
           <a:lstStyle/>
           <a:p>
             <a:pPr algn="ctr"/>
@@ -17466,7 +17679,7 @@
           </a:fontRef>
         </p:style>
         <p:txBody>
-          <a:bodyPr rtlCol="0" anchor="ctr" wrap="square" lIns="27432" tIns="22860" rIns="27432" bIns="22860"/>
+          <a:bodyPr wrap="square" lIns="27432" tIns="22860" rIns="27432" bIns="22860" rtlCol="0" anchor="ctr"/>
           <a:lstStyle/>
           <a:p>
             <a:pPr algn="ctr"/>
@@ -17560,7 +17773,7 @@
           <a:p>
             <a:fld id="{B7EB45DA-9A0D-DC49-8E02-F30A5DDC21C3}" type="slidenum">
               <a:rPr lang="en-US" smtClean="0"/>
-              <a:t>29</a:t>
+              <a:t>28</a:t>
             </a:fld>
             <a:endParaRPr lang="en-US"/>
           </a:p>
@@ -17788,7 +18001,7 @@
           </a:fontRef>
         </p:style>
         <p:txBody>
-          <a:bodyPr rtlCol="0" anchor="ctr" wrap="square" lIns="18288" tIns="18288" rIns="18288" bIns="18288"/>
+          <a:bodyPr wrap="square" lIns="18288" tIns="18288" rIns="18288" bIns="18288" rtlCol="0" anchor="ctr"/>
           <a:lstStyle/>
           <a:p>
             <a:pPr algn="ctr"/>
@@ -17879,7 +18092,7 @@
           </a:fontRef>
         </p:style>
         <p:txBody>
-          <a:bodyPr rtlCol="0" anchor="ctr" wrap="square" lIns="18288" tIns="18288" rIns="18288" bIns="18288"/>
+          <a:bodyPr wrap="square" lIns="18288" tIns="18288" rIns="18288" bIns="18288" rtlCol="0" anchor="ctr"/>
           <a:lstStyle/>
           <a:p>
             <a:pPr algn="ctr"/>
@@ -17970,7 +18183,7 @@
           </a:fontRef>
         </p:style>
         <p:txBody>
-          <a:bodyPr rtlCol="0" anchor="ctr" wrap="square" lIns="18288" tIns="18288" rIns="18288" bIns="18288"/>
+          <a:bodyPr wrap="square" lIns="18288" tIns="18288" rIns="18288" bIns="18288" rtlCol="0" anchor="ctr"/>
           <a:lstStyle/>
           <a:p>
             <a:pPr algn="ctr"/>
@@ -18061,7 +18274,7 @@
           </a:fontRef>
         </p:style>
         <p:txBody>
-          <a:bodyPr rtlCol="0" anchor="ctr" wrap="square" lIns="18288" tIns="18288" rIns="18288" bIns="18288"/>
+          <a:bodyPr wrap="square" lIns="18288" tIns="18288" rIns="18288" bIns="18288" rtlCol="0" anchor="ctr"/>
           <a:lstStyle/>
           <a:p>
             <a:pPr algn="ctr"/>
@@ -18152,7 +18365,7 @@
           </a:fontRef>
         </p:style>
         <p:txBody>
-          <a:bodyPr rtlCol="0" anchor="ctr" wrap="square" lIns="18288" tIns="18288" rIns="18288" bIns="18288"/>
+          <a:bodyPr wrap="square" lIns="18288" tIns="18288" rIns="18288" bIns="18288" rtlCol="0" anchor="ctr"/>
           <a:lstStyle/>
           <a:p>
             <a:pPr algn="ctr"/>
@@ -18243,7 +18456,7 @@
           </a:fontRef>
         </p:style>
         <p:txBody>
-          <a:bodyPr rtlCol="0" anchor="ctr" wrap="square" lIns="18288" tIns="18288" rIns="18288" bIns="18288"/>
+          <a:bodyPr wrap="square" lIns="18288" tIns="18288" rIns="18288" bIns="18288" rtlCol="0" anchor="ctr"/>
           <a:lstStyle/>
           <a:p>
             <a:pPr algn="ctr"/>
@@ -18334,7 +18547,7 @@
           </a:fontRef>
         </p:style>
         <p:txBody>
-          <a:bodyPr rtlCol="0" anchor="ctr" wrap="square" lIns="18288" tIns="18288" rIns="18288" bIns="18288"/>
+          <a:bodyPr wrap="square" lIns="18288" tIns="18288" rIns="18288" bIns="18288" rtlCol="0" anchor="ctr"/>
           <a:lstStyle/>
           <a:p>
             <a:pPr algn="ctr"/>
@@ -18582,7 +18795,7 @@
           <a:p>
             <a:fld id="{B7EB45DA-9A0D-DC49-8E02-F30A5DDC21C3}" type="slidenum">
               <a:rPr lang="en-US" smtClean="0"/>
-              <a:t>30</a:t>
+              <a:t>29</a:t>
             </a:fld>
             <a:endParaRPr lang="en-US"/>
           </a:p>
@@ -19484,7 +19697,7 @@
                   <a:srgbClr val="5C4826"/>
                 </a:solidFill>
               </a:rPr>
-              <a:t xml:space="preserve">A good engineering decision is the decision </a:t>
+              <a:t>A good engineering decision is the decision </a:t>
             </a:r>
             <a:r>
               <a:rPr lang="en-US" sz="2000" b="1" i="0" dirty="0">
@@ -19598,7 +19811,7 @@
                   <a:srgbClr val="9A9A9A"/>
                 </a:solidFill>
               </a:rPr>
-              <a:t xml:space="preserve">  ·  </a:t>
+              <a:t>  ·  </a:t>
             </a:r>
             <a:r>
               <a:rPr lang="en-US" sz="2000" b="1" i="0" dirty="0">
@@ -19614,7 +19827,7 @@
                   <a:srgbClr val="9A9A9A"/>
                 </a:solidFill>
               </a:rPr>
-              <a:t xml:space="preserve">  ·  </a:t>
+              <a:t>  ·  </a:t>
             </a:r>
             <a:r>
               <a:rPr lang="en-US" sz="2000" b="1" i="0" dirty="0">
@@ -19782,7 +19995,7 @@
                             </p:stCondLst>
                             <p:childTnLst>
                               <p:par>
-                                <p:cTn id="5" presetID="10" presetClass="entr" presetSubtype="0" fill="hold" grpId="0" nodeType="clickEffect">
+                                <p:cTn id="5" presetID="10" presetClass="entr" presetSubtype="0" fill="hold" nodeType="clickEffect">
                                   <p:stCondLst>
                                     <p:cond delay="0"/>
                                   </p:stCondLst>
@@ -19817,7 +20030,7 @@
                                 </p:cTn>
                               </p:par>
                               <p:par>
-                                <p:cTn id="8" presetID="10" presetClass="entr" presetSubtype="0" fill="hold" grpId="0" nodeType="withEffect">
+                                <p:cTn id="8" presetID="10" presetClass="entr" presetSubtype="0" fill="hold" nodeType="withEffect">
                                   <p:stCondLst>
                                     <p:cond delay="0"/>
                                   </p:stCondLst>
@@ -19852,7 +20065,7 @@
                                 </p:cTn>
                               </p:par>
                               <p:par>
-                                <p:cTn id="11" presetID="10" presetClass="entr" presetSubtype="0" fill="hold" grpId="0" nodeType="withEffect">
+                                <p:cTn id="11" presetID="10" presetClass="entr" presetSubtype="0" fill="hold" nodeType="withEffect">
                                   <p:stCondLst>
                                     <p:cond delay="0"/>
                                   </p:stCondLst>
@@ -20025,7 +20238,7 @@
           <a:p>
             <a:fld id="{B7EB45DA-9A0D-DC49-8E02-F30A5DDC21C3}" type="slidenum">
               <a:rPr lang="en-US" smtClean="0"/>
-              <a:t>6</a:t>
+              <a:t>5</a:t>
             </a:fld>
             <a:endParaRPr lang="en-US"/>
           </a:p>
@@ -20139,7 +20352,7 @@
           <a:p>
             <a:fld id="{B7EB45DA-9A0D-DC49-8E02-F30A5DDC21C3}" type="slidenum">
               <a:rPr lang="en-US" smtClean="0"/>
-              <a:t>7</a:t>
+              <a:t>6</a:t>
             </a:fld>
             <a:endParaRPr lang="en-US"/>
           </a:p>
@@ -20584,7 +20797,7 @@
           <a:p>
             <a:fld id="{B7EB45DA-9A0D-DC49-8E02-F30A5DDC21C3}" type="slidenum">
               <a:rPr lang="en-US" smtClean="0"/>
-              <a:t>8</a:t>
+              <a:t>7</a:t>
             </a:fld>
             <a:endParaRPr lang="en-US"/>
           </a:p>
@@ -20629,7 +20842,7 @@
           </a:fontRef>
         </p:style>
         <p:txBody>
-          <a:bodyPr rtlCol="0" anchor="ctr" wrap="square" lIns="45720" tIns="22860" rIns="45720" bIns="22860"/>
+          <a:bodyPr wrap="square" lIns="45720" tIns="22860" rIns="45720" bIns="22860" rtlCol="0" anchor="ctr"/>
           <a:lstStyle/>
           <a:p>
             <a:pPr algn="ctr"/>
@@ -20717,7 +20930,7 @@
           </a:fontRef>
         </p:style>
         <p:txBody>
-          <a:bodyPr rtlCol="0" anchor="ctr" wrap="square" lIns="45720" tIns="22860" rIns="45720" bIns="22860"/>
+          <a:bodyPr wrap="square" lIns="45720" tIns="22860" rIns="45720" bIns="22860" rtlCol="0" anchor="ctr"/>
           <a:lstStyle/>
           <a:p>
             <a:pPr algn="ctr"/>
@@ -20842,7 +21055,7 @@
           </a:fontRef>
         </p:style>
         <p:txBody>
-          <a:bodyPr rtlCol="0" anchor="ctr" wrap="square" lIns="45720" tIns="22860" rIns="45720" bIns="22860"/>
+          <a:bodyPr wrap="square" lIns="45720" tIns="22860" rIns="45720" bIns="22860" rtlCol="0" anchor="ctr"/>
           <a:lstStyle/>
           <a:p>
             <a:pPr algn="ctr"/>
@@ -20978,7 +21191,7 @@
           </a:fontRef>
         </p:style>
         <p:txBody>
-          <a:bodyPr rtlCol="0" anchor="ctr" wrap="square" lIns="45720" tIns="22860" rIns="45720" bIns="22860"/>
+          <a:bodyPr wrap="square" lIns="45720" tIns="22860" rIns="45720" bIns="22860" rtlCol="0" anchor="ctr"/>
           <a:lstStyle/>
           <a:p>
             <a:pPr algn="ctr"/>
@@ -21103,7 +21316,7 @@
           </a:fontRef>
         </p:style>
         <p:txBody>
-          <a:bodyPr rtlCol="0" anchor="ctr" wrap="square" lIns="45720" tIns="22860" rIns="45720" bIns="22860"/>
+          <a:bodyPr wrap="square" lIns="45720" tIns="22860" rIns="45720" bIns="22860" rtlCol="0" anchor="ctr"/>
           <a:lstStyle/>
           <a:p>
             <a:pPr algn="ctr"/>
@@ -21228,7 +21441,7 @@
           </a:fontRef>
         </p:style>
         <p:txBody>
-          <a:bodyPr rtlCol="0" anchor="ctr" wrap="square" lIns="45720" tIns="22860" rIns="45720" bIns="22860"/>
+          <a:bodyPr wrap="square" lIns="45720" tIns="22860" rIns="45720" bIns="22860" rtlCol="0" anchor="ctr"/>
           <a:lstStyle/>
           <a:p>
             <a:pPr algn="ctr"/>
@@ -21351,7 +21564,7 @@
                             </p:stCondLst>
                             <p:childTnLst>
                               <p:par>
-                                <p:cTn id="5" presetID="10" presetClass="entr" presetSubtype="0" fill="hold" grpId="0" nodeType="clickEffect">
+                                <p:cTn id="5" presetID="10" presetClass="entr" presetSubtype="0" fill="hold" nodeType="clickEffect">
                                   <p:stCondLst>
                                     <p:cond delay="0"/>
                                   </p:stCondLst>
@@ -21386,7 +21599,7 @@
                                 </p:cTn>
                               </p:par>
                               <p:par>
-                                <p:cTn id="8" presetID="10" presetClass="entr" presetSubtype="0" fill="hold" grpId="0" nodeType="withEffect">
+                                <p:cTn id="8" presetID="10" presetClass="entr" presetSubtype="0" fill="hold" nodeType="withEffect">
                                   <p:stCondLst>
                                     <p:cond delay="0"/>
                                   </p:stCondLst>
@@ -21439,7 +21652,7 @@
                             </p:stCondLst>
                             <p:childTnLst>
                               <p:par>
-                                <p:cTn id="13" presetID="10" presetClass="entr" presetSubtype="0" fill="hold" grpId="0" nodeType="clickEffect">
+                                <p:cTn id="13" presetID="10" presetClass="entr" presetSubtype="0" fill="hold" nodeType="clickEffect">
                                   <p:stCondLst>
                                     <p:cond delay="0"/>
                                   </p:stCondLst>
@@ -21474,7 +21687,7 @@
                                 </p:cTn>
                               </p:par>
                               <p:par>
-                                <p:cTn id="16" presetID="10" presetClass="entr" presetSubtype="0" fill="hold" grpId="0" nodeType="withEffect">
+                                <p:cTn id="16" presetID="10" presetClass="entr" presetSubtype="0" fill="hold" nodeType="withEffect">
                                   <p:stCondLst>
                                     <p:cond delay="0"/>
                                   </p:stCondLst>
@@ -21509,7 +21722,7 @@
                                 </p:cTn>
                               </p:par>
                               <p:par>
-                                <p:cTn id="19" presetID="10" presetClass="entr" presetSubtype="0" fill="hold" grpId="0" nodeType="withEffect">
+                                <p:cTn id="19" presetID="10" presetClass="entr" presetSubtype="0" fill="hold" nodeType="withEffect">
                                   <p:stCondLst>
                                     <p:cond delay="0"/>
                                   </p:stCondLst>
@@ -21562,7 +21775,7 @@
                             </p:stCondLst>
                             <p:childTnLst>
                               <p:par>
-                                <p:cTn id="24" presetID="10" presetClass="entr" presetSubtype="0" fill="hold" grpId="0" nodeType="clickEffect">
+                                <p:cTn id="24" presetID="10" presetClass="entr" presetSubtype="0" fill="hold" nodeType="clickEffect">
                                   <p:stCondLst>
                                     <p:cond delay="0"/>
                                   </p:stCondLst>
@@ -21597,7 +21810,7 @@
                                 </p:cTn>
                               </p:par>
                               <p:par>
-                                <p:cTn id="27" presetID="10" presetClass="entr" presetSubtype="0" fill="hold" grpId="0" nodeType="withEffect">
+                                <p:cTn id="27" presetID="10" presetClass="entr" presetSubtype="0" fill="hold" nodeType="withEffect">
                                   <p:stCondLst>
                                     <p:cond delay="0"/>
                                   </p:stCondLst>
@@ -21632,7 +21845,7 @@
                                 </p:cTn>
                               </p:par>
                               <p:par>
-                                <p:cTn id="30" presetID="10" presetClass="entr" presetSubtype="0" fill="hold" grpId="0" nodeType="withEffect">
+                                <p:cTn id="30" presetID="10" presetClass="entr" presetSubtype="0" fill="hold" nodeType="withEffect">
                                   <p:stCondLst>
                                     <p:cond delay="0"/>
                                   </p:stCondLst>
@@ -21685,7 +21898,7 @@
                             </p:stCondLst>
                             <p:childTnLst>
                               <p:par>
-                                <p:cTn id="35" presetID="10" presetClass="entr" presetSubtype="0" fill="hold" grpId="0" nodeType="clickEffect">
+                                <p:cTn id="35" presetID="10" presetClass="entr" presetSubtype="0" fill="hold" nodeType="clickEffect">
                                   <p:stCondLst>
                                     <p:cond delay="0"/>
                                   </p:stCondLst>
@@ -21720,7 +21933,7 @@
                                 </p:cTn>
                               </p:par>
                               <p:par>
-                                <p:cTn id="38" presetID="10" presetClass="entr" presetSubtype="0" fill="hold" grpId="0" nodeType="withEffect">
+                                <p:cTn id="38" presetID="10" presetClass="entr" presetSubtype="0" fill="hold" nodeType="withEffect">
                                   <p:stCondLst>
                                     <p:cond delay="0"/>
                                   </p:stCondLst>
@@ -21755,7 +21968,7 @@
                                 </p:cTn>
                               </p:par>
                               <p:par>
-                                <p:cTn id="41" presetID="10" presetClass="entr" presetSubtype="0" fill="hold" grpId="0" nodeType="withEffect">
+                                <p:cTn id="41" presetID="10" presetClass="entr" presetSubtype="0" fill="hold" nodeType="withEffect">
                                   <p:stCondLst>
                                     <p:cond delay="0"/>
                                   </p:stCondLst>
@@ -21808,7 +22021,7 @@
                             </p:stCondLst>
                             <p:childTnLst>
                               <p:par>
-                                <p:cTn id="46" presetID="10" presetClass="entr" presetSubtype="0" fill="hold" grpId="0" nodeType="clickEffect">
+                                <p:cTn id="46" presetID="10" presetClass="entr" presetSubtype="0" fill="hold" nodeType="clickEffect">
                                   <p:stCondLst>
                                     <p:cond delay="0"/>
                                   </p:stCondLst>
@@ -21843,7 +22056,7 @@
                                 </p:cTn>
                               </p:par>
                               <p:par>
-                                <p:cTn id="49" presetID="10" presetClass="entr" presetSubtype="0" fill="hold" grpId="0" nodeType="withEffect">
+                                <p:cTn id="49" presetID="10" presetClass="entr" presetSubtype="0" fill="hold" nodeType="withEffect">
                                   <p:stCondLst>
                                     <p:cond delay="0"/>
                                   </p:stCondLst>
@@ -21878,7 +22091,7 @@
                                 </p:cTn>
                               </p:par>
                               <p:par>
-                                <p:cTn id="52" presetID="10" presetClass="entr" presetSubtype="0" fill="hold" grpId="0" nodeType="withEffect">
+                                <p:cTn id="52" presetID="10" presetClass="entr" presetSubtype="0" fill="hold" nodeType="withEffect">
                                   <p:stCondLst>
                                     <p:cond delay="0"/>
                                   </p:stCondLst>
@@ -21931,7 +22144,7 @@
                             </p:stCondLst>
                             <p:childTnLst>
                               <p:par>
-                                <p:cTn id="57" presetID="10" presetClass="entr" presetSubtype="0" fill="hold" grpId="0" nodeType="clickEffect">
+                                <p:cTn id="57" presetID="10" presetClass="entr" presetSubtype="0" fill="hold" nodeType="clickEffect">
                                   <p:stCondLst>
                                     <p:cond delay="0"/>
                                   </p:stCondLst>
@@ -21966,7 +22179,7 @@
                                 </p:cTn>
                               </p:par>
                               <p:par>
-                                <p:cTn id="60" presetID="10" presetClass="entr" presetSubtype="0" fill="hold" grpId="0" nodeType="withEffect">
+                                <p:cTn id="60" presetID="10" presetClass="entr" presetSubtype="0" fill="hold" nodeType="withEffect">
                                   <p:stCondLst>
                                     <p:cond delay="0"/>
                                   </p:stCondLst>
@@ -22001,7 +22214,7 @@
                                 </p:cTn>
                               </p:par>
                               <p:par>
-                                <p:cTn id="63" presetID="10" presetClass="entr" presetSubtype="0" fill="hold" grpId="0" nodeType="withEffect">
+                                <p:cTn id="63" presetID="10" presetClass="entr" presetSubtype="0" fill="hold" nodeType="withEffect">
                                   <p:stCondLst>
                                     <p:cond delay="0"/>
                                   </p:stCondLst>
@@ -22137,7 +22350,7 @@
           <a:p>
             <a:fld id="{B7EB45DA-9A0D-DC49-8E02-F30A5DDC21C3}" type="slidenum">
               <a:rPr lang="en-US" smtClean="0"/>
-              <a:t>9</a:t>
+              <a:t>8</a:t>
             </a:fld>
             <a:endParaRPr lang="en-US"/>
           </a:p>
@@ -22180,7 +22393,7 @@
           </a:fontRef>
         </p:style>
         <p:txBody>
-          <a:bodyPr rtlCol="0" anchor="ctr" wrap="square"/>
+          <a:bodyPr wrap="square" rtlCol="0" anchor="ctr"/>
           <a:lstStyle/>
           <a:p>
             <a:pPr algn="ctr"/>
@@ -22232,7 +22445,7 @@
           </a:fontRef>
         </p:style>
         <p:txBody>
-          <a:bodyPr rtlCol="0" anchor="ctr" wrap="square"/>
+          <a:bodyPr wrap="square" rtlCol="0" anchor="ctr"/>
           <a:lstStyle/>
           <a:p>
             <a:pPr algn="ctr"/>
@@ -22286,7 +22499,7 @@
           </a:fontRef>
         </p:style>
         <p:txBody>
-          <a:bodyPr rtlCol="0" anchor="ctr" wrap="square" lIns="45720" tIns="22860" rIns="45720" bIns="22860"/>
+          <a:bodyPr wrap="square" lIns="45720" tIns="22860" rIns="45720" bIns="22860" rtlCol="0" anchor="ctr"/>
           <a:lstStyle/>
           <a:p>
             <a:pPr algn="ctr"/>
@@ -22376,7 +22589,7 @@
           </a:fontRef>
         </p:style>
         <p:txBody>
-          <a:bodyPr rtlCol="0" anchor="ctr" wrap="square" lIns="45720" tIns="22860" rIns="45720" bIns="22860"/>
+          <a:bodyPr wrap="square" lIns="45720" tIns="22860" rIns="45720" bIns="22860" rtlCol="0" anchor="ctr"/>
           <a:lstStyle/>
           <a:p>
             <a:pPr algn="ctr"/>
@@ -22466,7 +22679,7 @@
           </a:fontRef>
         </p:style>
         <p:txBody>
-          <a:bodyPr rtlCol="0" anchor="ctr" wrap="square" lIns="45720" tIns="22860" rIns="45720" bIns="22860"/>
+          <a:bodyPr wrap="square" lIns="45720" tIns="22860" rIns="45720" bIns="22860" rtlCol="0" anchor="ctr"/>
           <a:lstStyle/>
           <a:p>
             <a:pPr algn="ctr"/>
@@ -22556,7 +22769,7 @@
           </a:fontRef>
         </p:style>
         <p:txBody>
-          <a:bodyPr rtlCol="0" anchor="ctr" wrap="square" lIns="45720" tIns="22860" rIns="45720" bIns="22860"/>
+          <a:bodyPr wrap="square" lIns="45720" tIns="22860" rIns="45720" bIns="22860" rtlCol="0" anchor="ctr"/>
           <a:lstStyle/>
           <a:p>
             <a:pPr algn="ctr"/>
@@ -22646,7 +22859,7 @@
           </a:fontRef>
         </p:style>
         <p:txBody>
-          <a:bodyPr rtlCol="0" anchor="ctr" wrap="square" lIns="45720" tIns="22860" rIns="45720" bIns="22860"/>
+          <a:bodyPr wrap="square" lIns="45720" tIns="22860" rIns="45720" bIns="22860" rtlCol="0" anchor="ctr"/>
           <a:lstStyle/>
           <a:p>
             <a:pPr algn="ctr"/>
@@ -22736,7 +22949,7 @@
           </a:fontRef>
         </p:style>
         <p:txBody>
-          <a:bodyPr rtlCol="0" anchor="ctr" wrap="square" lIns="45720" tIns="22860" rIns="45720" bIns="22860"/>
+          <a:bodyPr wrap="square" lIns="45720" tIns="22860" rIns="45720" bIns="22860" rtlCol="0" anchor="ctr"/>
           <a:lstStyle/>
           <a:p>
             <a:pPr algn="ctr"/>
@@ -22826,7 +23039,7 @@
           </a:fontRef>
         </p:style>
         <p:txBody>
-          <a:bodyPr rtlCol="0" anchor="ctr" wrap="square" lIns="45720" tIns="22860" rIns="45720" bIns="22860"/>
+          <a:bodyPr wrap="square" lIns="45720" tIns="22860" rIns="45720" bIns="22860" rtlCol="0" anchor="ctr"/>
           <a:lstStyle/>
           <a:p>
             <a:pPr algn="ctr"/>
@@ -22956,7 +23169,7 @@
           <a:p>
             <a:fld id="{B7EB45DA-9A0D-DC49-8E02-F30A5DDC21C3}" type="slidenum">
               <a:rPr lang="en-US" smtClean="0"/>
-              <a:t>10</a:t>
+              <a:t>9</a:t>
             </a:fld>
             <a:endParaRPr lang="en-US"/>
           </a:p>
@@ -23001,7 +23214,7 @@
           </a:fontRef>
         </p:style>
         <p:txBody>
-          <a:bodyPr rtlCol="0" anchor="ctr" wrap="square"/>
+          <a:bodyPr wrap="square" rtlCol="0" anchor="ctr"/>
           <a:lstStyle/>
           <a:p>
             <a:pPr algn="l"/>
@@ -23097,7 +23310,7 @@
           </a:fontRef>
         </p:style>
         <p:txBody>
-          <a:bodyPr rtlCol="0" anchor="ctr" wrap="square"/>
+          <a:bodyPr wrap="square" rtlCol="0" anchor="ctr"/>
           <a:lstStyle/>
           <a:p>
             <a:pPr algn="l"/>
@@ -23173,7 +23386,7 @@
           </a:fontRef>
         </p:style>
         <p:txBody>
-          <a:bodyPr rtlCol="0" anchor="ctr" wrap="square"/>
+          <a:bodyPr wrap="square" rtlCol="0" anchor="ctr"/>
           <a:lstStyle/>
           <a:p>
             <a:pPr algn="l"/>
@@ -23333,7 +23546,7 @@
           </a:fontRef>
         </p:style>
         <p:txBody>
-          <a:bodyPr rtlCol="0" anchor="ctr" wrap="square"/>
+          <a:bodyPr wrap="square" rtlCol="0" anchor="ctr"/>
           <a:lstStyle/>
           <a:p>
             <a:pPr algn="ctr"/>
@@ -23387,7 +23600,7 @@
           </a:fontRef>
         </p:style>
         <p:txBody>
-          <a:bodyPr rtlCol="0" anchor="ctr" wrap="square"/>
+          <a:bodyPr wrap="square" rtlCol="0" anchor="ctr"/>
           <a:lstStyle/>
           <a:p>
             <a:pPr algn="ctr"/>
@@ -23428,7 +23641,7 @@
                             </p:stCondLst>
                             <p:childTnLst>
                               <p:par>
-                                <p:cTn id="5" presetID="10" presetClass="entr" presetSubtype="0" fill="hold" grpId="0" nodeType="clickEffect">
+                                <p:cTn id="5" presetID="10" presetClass="entr" presetSubtype="0" fill="hold" nodeType="clickEffect">
                                   <p:stCondLst>
                                     <p:cond delay="0"/>
                                   </p:stCondLst>

</xml_diff>

<commit_message>
book(5.1): make the process-design/tolerance tradeoff concrete
Both techniques are defined, then the section moves straight to Watt.
State the tradeoff they jointly solve before the figure: process design
governs how efficiently work moves through the factory, tolerance governs
whether the resulting work is fit for use, and a factory must do both —
make the parts efficiently, and make parts that fit.

This also sets up Chapter 6, which puts quantities on the same two
factory-engineering problems.

Co-Authored-By: Claude Opus 5 <noreply@anthropic.com>
</commit_message>
<xml_diff>
--- a/course/lectures/act-1-foundations/09-engineering-decision-making-and-metrics/1-9-Engineering-Decision-Making-and-Metrics.pptx
+++ b/course/lectures/act-1-foundations/09-engineering-decision-making-and-metrics/1-9-Engineering-Decision-Making-and-Metrics.pptx
@@ -741,7 +741,7 @@
           <a:p>
             <a:r>
               <a:rPr dirty="0"/>
-              <a:t>3 minutes — The canonical quantitative chain, unpacked carefully. Terminology must be exact.</a:t>
+              <a:t>2 minutes — The canonical quantitative chain, unpacked carefully. Terminology must be exact.</a:t>
             </a:r>
           </a:p>
           <a:p>
@@ -769,6 +769,12 @@
             <a:r>
               <a:rPr dirty="0"/>
               <a:t>- (from slide) You met this chain in Validation. Today we unpack each link.</a:t>
+            </a:r>
+          </a:p>
+          <a:p>
+            <a:r>
+              <a:rPr dirty="0"/>
+              <a:t>- Pace (2:00): the boxes do the work. Define each term once and move; later slides point back here rather than re-explaining the chain.</a:t>
             </a:r>
           </a:p>
         </p:txBody>
@@ -815,7 +821,7 @@
           <a:p>
             <a:r>
               <a:rPr dirty="0"/>
-              <a:t>3 minutes — Work one operationalization end to end; define the word once.</a:t>
+              <a:t>2 minutes — Work one operationalization end to end; define the word once.</a:t>
             </a:r>
           </a:p>
           <a:p>
@@ -845,6 +851,12 @@
             <a:r>
               <a:rPr dirty="0"/>
               <a:t>- (from slide) The metric chooses which aspect of the property becomes observable.</a:t>
+            </a:r>
+          </a:p>
+          <a:p>
+            <a:r>
+              <a:rPr dirty="0"/>
+              <a:t>- Pace (2:00): land “p99 latency is not responsiveness itself” and move on. Do not linger.</a:t>
             </a:r>
           </a:p>
         </p:txBody>
@@ -891,7 +903,7 @@
           <a:p>
             <a:r>
               <a:rPr dirty="0"/>
-              <a:t xml:space="preserve">3 minutes — </a:t>
+              <a:t xml:space="preserve">2 minutes — </a:t>
             </a:r>
             <a:r>
               <a:rPr i="1" dirty="0"/>
@@ -917,6 +929,12 @@
             <a:r>
               <a:rPr dirty="0"/>
               <a:t>- The footer corrects any older phrasing: the metric embodies the modeling choice; the measurement supplies observations. Do not soften it.</a:t>
+            </a:r>
+          </a:p>
+          <a:p>
+            <a:r>
+              <a:rPr dirty="0"/>
+              <a:t>- Pace (2:00): two clicks, two sentences, move on.</a:t>
             </a:r>
           </a:p>
         </p:txBody>
@@ -963,7 +981,7 @@
           <a:p>
             <a:r>
               <a:rPr dirty="0"/>
-              <a:t xml:space="preserve">3 minutes — TPS: students generate the conditions that give 420 </a:t>
+              <a:t xml:space="preserve">2 minutes — TPS: students generate the conditions that give 420 </a:t>
             </a:r>
             <a:r>
               <a:rPr dirty="0" err="1"/>
@@ -1031,6 +1049,12 @@
             <a:r>
               <a:rPr dirty="0"/>
               <a:t xml:space="preserve"> is an observation parameterized by conditions.'</a:t>
+            </a:r>
+          </a:p>
+          <a:p>
+            <a:r>
+              <a:rPr dirty="0"/>
+              <a:t>- Pace (2:00): keep the TPS brisk — about 45 seconds of pair discussion, two or three answers, then reveal.</a:t>
             </a:r>
           </a:p>
         </p:txBody>
@@ -1077,7 +1101,7 @@
           <a:p>
             <a:r>
               <a:rPr dirty="0"/>
-              <a:t>2.5 minutes — The scope principle, on a real industrial property, deliberately drawn like Validation's composition slide.</a:t>
+              <a:t>2 minutes — The scope principle, on a real industrial property, deliberately drawn like Validation's composition slide.</a:t>
             </a:r>
           </a:p>
           <a:p>
@@ -1141,6 +1165,12 @@
             <a:r>
               <a:rPr dirty="0"/>
               <a:t>Build (5 clicks): 1 the enclosing scope and sensing → computation → communication → rendering; 2 local numbers and green checks — each local measurement looks acceptable; 3 the heavy end-to-end arrow and the total; 4 the red X; 5 the two closing lines and the footer.</a:t>
+            </a:r>
+          </a:p>
+          <a:p>
+            <a:r>
+              <a:rPr dirty="0"/>
+              <a:t>- Pace (2:00): Validation callback, the arithmetic, the conclusion. The end-to-end caveat is one sentence, not a digression.</a:t>
             </a:r>
           </a:p>
         </p:txBody>
@@ -1187,7 +1217,7 @@
           <a:p>
             <a:r>
               <a:rPr dirty="0"/>
-              <a:t xml:space="preserve">2.5 minutes — </a:t>
+              <a:t xml:space="preserve">1.5 minutes — </a:t>
             </a:r>
             <a:r>
               <a:rPr i="1" dirty="0"/>
@@ -1207,6 +1237,12 @@
             <a:r>
               <a:rPr dirty="0"/>
               <a:t>- Usability needs several observables, none of which IS usability — the metric models how each bears on it.</a:t>
+            </a:r>
+          </a:p>
+          <a:p>
+            <a:r>
+              <a:rPr dirty="0"/>
+              <a:t>- Pace (1:30): straightforward once metric-as-model has landed. State the contrast and move.</a:t>
             </a:r>
           </a:p>
         </p:txBody>
@@ -1253,7 +1289,7 @@
           <a:p>
             <a:r>
               <a:rPr dirty="0"/>
-              <a:t>3 minutes — Every metric omits; the omission is the price of usability, not a scandal.</a:t>
+              <a:t>1.5 minutes — Every metric omits; the omission is the price of usability, not a scandal.</a:t>
             </a:r>
           </a:p>
           <a:p>
@@ -1275,6 +1311,12 @@
             <a:r>
               <a:rPr dirty="0"/>
               <a:t>- (from slide) Know what the metric represents — and what it leaves unresolved.</a:t>
+            </a:r>
+          </a:p>
+          <a:p>
+            <a:r>
+              <a:rPr dirty="0"/>
+              <a:t>- Pace (1:30): the examples are self-explanatory. Land the line and leave.</a:t>
             </a:r>
           </a:p>
         </p:txBody>
@@ -1321,7 +1363,7 @@
           <a:p>
             <a:r>
               <a:rPr dirty="0"/>
-              <a:t xml:space="preserve">2.5 minutes — </a:t>
+              <a:t xml:space="preserve">2 minutes — </a:t>
             </a:r>
             <a:r>
               <a:rPr i="1" dirty="0"/>
@@ -1359,6 +1401,12 @@
             <a:r>
               <a:rPr dirty="0"/>
               <a:t>- Ask the room which of the three could be wrong for the same reason. That is the blind-spot question.</a:t>
+            </a:r>
+          </a:p>
+          <a:p>
+            <a:r>
+              <a:rPr dirty="0"/>
+              <a:t>- Pace (2:00): substantive — preserve this one. It is not a compression target.</a:t>
             </a:r>
           </a:p>
         </p:txBody>
@@ -1620,7 +1668,7 @@
           <a:p>
             <a:r>
               <a:rPr dirty="0"/>
-              <a:t xml:space="preserve">4 minutes — </a:t>
+              <a:t xml:space="preserve">2.5 minutes — </a:t>
             </a:r>
             <a:r>
               <a:rPr i="1" dirty="0"/>
@@ -1640,6 +1688,12 @@
             <a:r>
               <a:rPr dirty="0"/>
               <a:t>- Reveal the metric, then do NOT immediately call it bad — ask what inference is being made. The next slide does the real work.</a:t>
+            </a:r>
+          </a:p>
+          <a:p>
+            <a:r>
+              <a:rPr dirty="0"/>
+              <a:t>- Pace (2:30): run it briskly. The team activity now does the serious application work.</a:t>
             </a:r>
           </a:p>
         </p:txBody>
@@ -1686,7 +1740,7 @@
           <a:p>
             <a:r>
               <a:rPr dirty="0"/>
-              <a:t xml:space="preserve">3 minutes — </a:t>
+              <a:t xml:space="preserve">2 minutes — </a:t>
             </a:r>
             <a:r>
               <a:rPr i="1" dirty="0"/>
@@ -1718,6 +1772,12 @@
             <a:r>
               <a:rPr dirty="0"/>
               <a:t>- Teamwork already warned about commits and tickets — use it as a callback, not a novel claim.</a:t>
+            </a:r>
+          </a:p>
+          <a:p>
+            <a:r>
+              <a:rPr dirty="0"/>
+              <a:t>- Pace (2:00): name one or two validity conditions; do not enumerate them exhaustively.</a:t>
             </a:r>
           </a:p>
         </p:txBody>
@@ -1764,7 +1824,7 @@
           <a:p>
             <a:r>
               <a:rPr dirty="0"/>
-              <a:t xml:space="preserve">3 minutes — </a:t>
+              <a:t xml:space="preserve">2.5 minutes — </a:t>
             </a:r>
             <a:r>
               <a:rPr i="1" dirty="0"/>
@@ -1796,6 +1856,12 @@
             <a:r>
               <a:rPr dirty="0"/>
               <a:t>- State the law once, briefly; do not build a slogan slide.</a:t>
+            </a:r>
+          </a:p>
+          <a:p>
+            <a:r>
+              <a:rPr dirty="0"/>
+              <a:t>- Pace (2:30): genuinely new vocabulary — keep the time this one needs.</a:t>
             </a:r>
           </a:p>
         </p:txBody>
@@ -1842,7 +1908,7 @@
           <a:p>
             <a:r>
               <a:rPr dirty="0"/>
-              <a:t>2 minutes — Context determines evidentiary weight; two quick examples, no new machinery.</a:t>
+              <a:t>1 minute — Context determines evidentiary weight; two quick examples, no new machinery.</a:t>
             </a:r>
           </a:p>
           <a:p>
@@ -1864,6 +1930,12 @@
             <a:r>
               <a:rPr dirty="0"/>
               <a:t>- (from slide) The same metric can be strong evidence in one context and weak in another.</a:t>
+            </a:r>
+          </a:p>
+          <a:p>
+            <a:r>
+              <a:rPr dirty="0"/>
+              <a:t>- Pace (1:00): these are essentially captions. Read them and move.</a:t>
             </a:r>
           </a:p>
         </p:txBody>
@@ -1910,7 +1982,7 @@
           <a:p>
             <a:r>
               <a:rPr dirty="0"/>
-              <a:t xml:space="preserve">1.5 minutes — </a:t>
+              <a:t xml:space="preserve">1 minute — </a:t>
             </a:r>
             <a:r>
               <a:rPr i="1" dirty="0"/>
@@ -1924,6 +1996,21 @@
             <a:r>
               <a:rPr dirty="0"/>
               <a:t>- Resist expansion; the value of this list is that students will actually remember it.</a:t>
+            </a:r>
+          </a:p>
+          <a:p>
+            <a:r>
+              <a:rPr dirty="0"/>
+              <a:t>- Pace (1:00): read the four as setup for the activity, not as a mini-lecture.</a:t>
+            </a:r>
+          </a:p>
+          <a:p>
+            <a:endParaRPr dirty="0"/>
+          </a:p>
+          <a:p>
+            <a:r>
+              <a:rPr dirty="0"/>
+              <a:t>Transition: “Those four questions are enough to criticize somebody else’s metric. Now you have to make an engineering decision with imperfect evidence.”</a:t>
             </a:r>
           </a:p>
         </p:txBody>
@@ -1970,7 +2057,7 @@
           <a:p>
             <a:r>
               <a:rPr dirty="0"/>
-              <a:t xml:space="preserve">0.3 minutes — </a:t>
+              <a:t xml:space="preserve">0.25 minutes — </a:t>
             </a:r>
             <a:r>
               <a:rPr i="1" dirty="0"/>
@@ -1979,6 +2066,12 @@
           </a:p>
           <a:p>
             <a:endParaRPr dirty="0"/>
+          </a:p>
+          <a:p>
+            <a:r>
+              <a:rPr dirty="0"/>
+              <a:t>- Pace (0:15): divider only. Name the section and go.</a:t>
+            </a:r>
           </a:p>
         </p:txBody>
       </p:sp>
@@ -2023,7 +2116,7 @@
           <a:lstStyle/>
           <a:p>
             <a:r>
-              <a:t>2.5 minutes — Extend the chain to judgment and action, then teach the Act I generalization fresh — do NOT present it as recall; the lectures did not make the per-unit measurement sections prominent.</a:t>
+              <a:t>1.5 minutes — Extend the chain to judgment and action, then teach the Act I generalization fresh — do NOT present it as recall; the lectures did not make the per-unit measurement sections prominent.</a:t>
             </a:r>
           </a:p>
           <a:p>
@@ -2047,6 +2140,12 @@
           <a:p>
             <a:r>
               <a:t>- This sets up the closing loop slide: outcomes produce new evidence that can update the models.</a:t>
+            </a:r>
+          </a:p>
+          <a:p>
+            <a:r>
+              <a:rPr dirty="0"/>
+              <a:t>- Pace (1:30): generalize across Act I; do not walk every row aloud.</a:t>
             </a:r>
           </a:p>
         </p:txBody>
@@ -2092,7 +2191,7 @@
           <a:lstStyle/>
           <a:p>
             <a:r>
-              <a:t>2 minutes — Same evidence, different rational actions; a Validation callback, not a re-teach.</a:t>
+              <a:t>1.5 minutes — Same evidence, different rational actions; a Validation callback, not a re-teach.</a:t>
             </a:r>
           </a:p>
           <a:p>
@@ -2111,6 +2210,12 @@
           <a:p>
             <a:r>
               <a:t>- (from slide) Validation asked when evidence is enough; this is that judgment, generalized.</a:t>
+            </a:r>
+          </a:p>
+          <a:p>
+            <a:r>
+              <a:rPr dirty="0"/>
+              <a:t>- Pace (1:30): this now names what the room just experienced in the activity, so it lands faster.</a:t>
             </a:r>
           </a:p>
         </p:txBody>

</xml_diff>

<commit_message>
course(metrics deck): author revisions to the 1-9 deck
Recap framing and a numbered list on the 'What do we need to know?' slide;
tighten slide 7 to 'not evidence'; add DECISION / KNOWN / UNCERTAIN labels to
the comparison slide. Saved from PowerPoint, so text runs are re-fragmented
throughout and package metadata is rewritten; slide count, media, and the
slide-27 QR are unchanged.

Co-Authored-By: Claude Opus 5 <noreply@anthropic.com>
</commit_message>
<xml_diff>
--- a/course/lectures/act-1-foundations/09-engineering-decision-making-and-metrics/1-9-Engineering-Decision-Making-and-Metrics.pptx
+++ b/course/lectures/act-1-foundations/09-engineering-decision-making-and-metrics/1-9-Engineering-Decision-Making-and-Metrics.pptx
@@ -531,7 +531,7 @@
           <a:p>
             <a:r>
               <a:rPr dirty="0"/>
-              <a:t xml:space="preserve">0.5 minutes — </a:t>
+              <a:t>0.5 minutes — </a:t>
             </a:r>
             <a:r>
               <a:rPr i="1" dirty="0"/>
@@ -597,7 +597,7 @@
           <a:p>
             <a:r>
               <a:rPr dirty="0"/>
-              <a:t xml:space="preserve">1.5 minutes — </a:t>
+              <a:t>1.5 minutes — </a:t>
             </a:r>
             <a:r>
               <a:rPr i="1" dirty="0"/>
@@ -681,7 +681,7 @@
           <a:p>
             <a:r>
               <a:rPr dirty="0"/>
-              <a:t xml:space="preserve">0.3 minutes — </a:t>
+              <a:t>0.3 minutes — </a:t>
             </a:r>
             <a:r>
               <a:rPr i="1" dirty="0"/>
@@ -830,7 +830,7 @@
           <a:p>
             <a:r>
               <a:rPr dirty="0"/>
-              <a:t xml:space="preserve">- Responsiveness is abstract; p99-under-workload-W is the chosen observable aspect; 420 </a:t>
+              <a:t>- Responsiveness is abstract; p99-under-workload-W is the chosen observable aspect; 420 </a:t>
             </a:r>
             <a:r>
               <a:rPr dirty="0" err="1"/>
@@ -838,7 +838,7 @@
             </a:r>
             <a:r>
               <a:rPr dirty="0"/>
-              <a:t xml:space="preserve"> is what applying it produced.</a:t>
+              <a:t> is what applying it produced.</a:t>
             </a:r>
           </a:p>
           <a:p>
@@ -903,7 +903,7 @@
           <a:p>
             <a:r>
               <a:rPr dirty="0"/>
-              <a:t xml:space="preserve">2 minutes — </a:t>
+              <a:t>2 minutes — </a:t>
             </a:r>
             <a:r>
               <a:rPr i="1" dirty="0"/>
@@ -981,7 +981,7 @@
           <a:p>
             <a:r>
               <a:rPr dirty="0"/>
-              <a:t xml:space="preserve">2 minutes — TPS: students generate the conditions that give 420 </a:t>
+              <a:t>2 minutes — TPS: students generate the conditions that give 420 </a:t>
             </a:r>
             <a:r>
               <a:rPr dirty="0" err="1"/>
@@ -989,7 +989,7 @@
             </a:r>
             <a:r>
               <a:rPr dirty="0"/>
-              <a:t xml:space="preserve"> meaning.</a:t>
+              <a:t> meaning.</a:t>
             </a:r>
           </a:p>
           <a:p>
@@ -998,7 +998,7 @@
           <a:p>
             <a:r>
               <a:rPr dirty="0"/>
-              <a:t xml:space="preserve">- Let '420 </a:t>
+              <a:t>- Let '420 </a:t>
             </a:r>
             <a:r>
               <a:rPr dirty="0" err="1"/>
@@ -1006,7 +1006,7 @@
             </a:r>
             <a:r>
               <a:rPr dirty="0"/>
-              <a:t xml:space="preserve"> sit alone for a beat; run the think-pair-share on the prompt before revealing anything.</a:t>
+              <a:t> sit alone for a beat; run the think-pair-share on the prompt before revealing anything.</a:t>
             </a:r>
           </a:p>
           <a:p>
@@ -1018,7 +1018,7 @@
           <a:p>
             <a:r>
               <a:rPr dirty="0"/>
-              <a:t xml:space="preserve">- The final click is the deliverable form: p99 = 420 </a:t>
+              <a:t>- The final click is the deliverable form: p99 = 420 </a:t>
             </a:r>
             <a:r>
               <a:rPr dirty="0" err="1"/>
@@ -1026,13 +1026,13 @@
             </a:r>
             <a:r>
               <a:rPr dirty="0"/>
-              <a:t xml:space="preserve"> · end-to-end · workload W · configuration C · interval T.</a:t>
+              <a:t> · end-to-end · workload W · configuration C · interval T.</a:t>
             </a:r>
           </a:p>
           <a:p>
             <a:r>
               <a:rPr dirty="0"/>
-              <a:t xml:space="preserve">- Then stop. The students should experience the move from '420 </a:t>
+              <a:t>- Then stop. The students should experience the move from '420 </a:t>
             </a:r>
             <a:r>
               <a:rPr dirty="0" err="1"/>
@@ -1040,7 +1040,7 @@
             </a:r>
             <a:r>
               <a:rPr dirty="0"/>
-              <a:t xml:space="preserve"> is a fact' to '420 </a:t>
+              <a:t> is a fact' to '420 </a:t>
             </a:r>
             <a:r>
               <a:rPr dirty="0" err="1"/>
@@ -1048,7 +1048,7 @@
             </a:r>
             <a:r>
               <a:rPr dirty="0"/>
-              <a:t xml:space="preserve"> is an observation parameterized by conditions.'</a:t>
+              <a:t> is an observation parameterized by conditions.'</a:t>
             </a:r>
           </a:p>
           <a:p>
@@ -1217,7 +1217,7 @@
           <a:p>
             <a:r>
               <a:rPr dirty="0"/>
-              <a:t xml:space="preserve">1.5 minutes — </a:t>
+              <a:t>1.5 minutes — </a:t>
             </a:r>
             <a:r>
               <a:rPr i="1" dirty="0"/>
@@ -1363,7 +1363,7 @@
           <a:p>
             <a:r>
               <a:rPr dirty="0"/>
-              <a:t xml:space="preserve">2 minutes — </a:t>
+              <a:t>2 minutes — </a:t>
             </a:r>
             <a:r>
               <a:rPr i="1" dirty="0"/>
@@ -1542,7 +1542,7 @@
           <a:p>
             <a:r>
               <a:rPr dirty="0"/>
-              <a:t xml:space="preserve">5 minutes — </a:t>
+              <a:t>5 minutes — </a:t>
             </a:r>
             <a:r>
               <a:rPr i="1" dirty="0"/>
@@ -1608,7 +1608,7 @@
           <a:p>
             <a:r>
               <a:rPr dirty="0"/>
-              <a:t xml:space="preserve">0.3 minutes — </a:t>
+              <a:t>0.3 minutes — </a:t>
             </a:r>
             <a:r>
               <a:rPr i="1" dirty="0"/>
@@ -1668,7 +1668,7 @@
           <a:p>
             <a:r>
               <a:rPr dirty="0"/>
-              <a:t xml:space="preserve">2.5 minutes — </a:t>
+              <a:t>2.5 minutes — </a:t>
             </a:r>
             <a:r>
               <a:rPr i="1" dirty="0"/>
@@ -1740,7 +1740,7 @@
           <a:p>
             <a:r>
               <a:rPr dirty="0"/>
-              <a:t xml:space="preserve">2 minutes — </a:t>
+              <a:t>2 minutes — </a:t>
             </a:r>
             <a:r>
               <a:rPr i="1" dirty="0"/>
@@ -1824,7 +1824,7 @@
           <a:p>
             <a:r>
               <a:rPr dirty="0"/>
-              <a:t xml:space="preserve">2.5 minutes — </a:t>
+              <a:t>2.5 minutes — </a:t>
             </a:r>
             <a:r>
               <a:rPr i="1" dirty="0"/>
@@ -1982,7 +1982,7 @@
           <a:p>
             <a:r>
               <a:rPr dirty="0"/>
-              <a:t xml:space="preserve">1 minute — </a:t>
+              <a:t>1 minute — </a:t>
             </a:r>
             <a:r>
               <a:rPr i="1" dirty="0"/>
@@ -2057,7 +2057,7 @@
           <a:p>
             <a:r>
               <a:rPr dirty="0"/>
-              <a:t xml:space="preserve">10 minutes — </a:t>
+              <a:t>10 minutes — </a:t>
             </a:r>
             <a:r>
               <a:rPr i="1" dirty="0"/>
@@ -2070,7 +2070,7 @@
           <a:p>
             <a:r>
               <a:rPr b="1" dirty="0"/>
-              <a:t xml:space="preserve">Purpose. </a:t>
+              <a:t>Purpose. </a:t>
             </a:r>
             <a:r>
               <a:rPr dirty="0"/>
@@ -2083,7 +2083,7 @@
           <a:p>
             <a:r>
               <a:rPr b="1" dirty="0"/>
-              <a:t xml:space="preserve">Set up the case. </a:t>
+              <a:t>Set up the case. </a:t>
             </a:r>
             <a:r>
               <a:rPr dirty="0"/>
@@ -2096,11 +2096,11 @@
           <a:p>
             <a:r>
               <a:rPr b="1" dirty="0"/>
-              <a:t xml:space="preserve">The deliverable is on the form, not the slide. </a:t>
+              <a:t>The deliverable is on the form, not the slide. </a:t>
             </a:r>
             <a:r>
               <a:rPr dirty="0"/>
-              <a:t xml:space="preserve">Every team completes three sentences: “We will ___ because ___.” “The most important unresolved uncertainty is ___.” “We would change our decision if we learned ___.” Require every blank to be filled — the sentences force evidence to bear on a claim rather than merely reporting a number. Note the wording: </a:t>
+              <a:t>Every team completes three sentences: “We will ___ because ___.” “The most important unresolved uncertainty is ___.” “We would change our decision if we learned ___.” Require every blank to be filled — the sentences force evidence to bear on a claim rather than merely reporting a number. Note the wording: </a:t>
             </a:r>
             <a:r>
               <a:rPr i="1" dirty="0"/>
@@ -2108,7 +2108,7 @@
             </a:r>
             <a:r>
               <a:rPr dirty="0"/>
-              <a:t xml:space="preserve">, not </a:t>
+              <a:t>, not </a:t>
             </a:r>
             <a:r>
               <a:rPr i="1" dirty="0"/>
@@ -2125,7 +2125,7 @@
           <a:p>
             <a:r>
               <a:rPr b="1" dirty="0"/>
-              <a:t xml:space="preserve">Emphasize what the table does not establish. </a:t>
+              <a:t>Emphasize what the table does not establish. </a:t>
             </a:r>
             <a:r>
               <a:rPr dirty="0"/>
@@ -2138,7 +2138,7 @@
           <a:p>
             <a:r>
               <a:rPr b="1" dirty="0"/>
-              <a:t xml:space="preserve">Make delay real. </a:t>
+              <a:t>Make delay real. </a:t>
             </a:r>
             <a:r>
               <a:rPr dirty="0"/>
@@ -2151,7 +2151,7 @@
           <a:p>
             <a:r>
               <a:rPr b="1" dirty="0"/>
-              <a:t xml:space="preserve">Do not force A or B. </a:t>
+              <a:t>Do not force A or B. </a:t>
             </a:r>
             <a:r>
               <a:rPr dirty="0"/>
@@ -2164,7 +2164,7 @@
           <a:p>
             <a:r>
               <a:rPr b="1" dirty="0"/>
-              <a:t xml:space="preserve">Push on vague requests for evidence. </a:t>
+              <a:t>Push on vague requests for evidence. </a:t>
             </a:r>
             <a:r>
               <a:rPr dirty="0"/>
@@ -2177,7 +2177,7 @@
           <a:p>
             <a:r>
               <a:rPr b="1" dirty="0"/>
-              <a:t xml:space="preserve">Push on properties. </a:t>
+              <a:t>Push on properties. </a:t>
             </a:r>
             <a:r>
               <a:rPr dirty="0"/>
@@ -2190,7 +2190,7 @@
           <a:p>
             <a:r>
               <a:rPr b="1" dirty="0"/>
-              <a:t xml:space="preserve">Push on metrics. </a:t>
+              <a:t>Push on metrics. </a:t>
             </a:r>
             <a:r>
               <a:rPr dirty="0"/>
@@ -2203,7 +2203,7 @@
           <a:p>
             <a:r>
               <a:rPr b="1" dirty="0"/>
-              <a:t xml:space="preserve">Look for the central tension. </a:t>
+              <a:t>Look for the central tension. </a:t>
             </a:r>
             <a:r>
               <a:rPr dirty="0"/>
@@ -2216,11 +2216,11 @@
           <a:p>
             <a:r>
               <a:rPr b="1" dirty="0"/>
-              <a:t xml:space="preserve">Debrief. </a:t>
+              <a:t>Debrief. </a:t>
             </a:r>
             <a:r>
               <a:rPr dirty="0"/>
-              <a:t xml:space="preserve">Ask two teams that made different decisions to defend them from the same evidence. Put their deliverables against each other. The interesting question is not </a:t>
+              <a:t>Ask two teams that made different decisions to defend them from the same evidence. Put their deliverables against each other. The interesting question is not </a:t>
             </a:r>
             <a:r>
               <a:rPr i="1" dirty="0"/>
@@ -2228,7 +2228,7 @@
             </a:r>
             <a:r>
               <a:rPr dirty="0"/>
-              <a:t xml:space="preserve"> but </a:t>
+              <a:t> but </a:t>
             </a:r>
             <a:r>
               <a:rPr i="1" dirty="0"/>
@@ -2236,7 +2236,7 @@
             </a:r>
             <a:r>
               <a:rPr dirty="0"/>
-              <a:t xml:space="preserve"> Transition: “You all received exactly the same observations. Why did you make different decisions?” Use the disagreement to introduce the next section: evidence does not mechanically determine action. Consequence, uncertainty, reversibility, and the cost of further information affect what action is justified.</a:t>
+              <a:t> Transition: “You all received exactly the same observations. Why did you make different decisions?” Use the disagreement to introduce the next section: evidence does not mechanically determine action. Consequence, uncertainty, reversibility, and the cost of further information affect what action is justified.</a:t>
             </a:r>
           </a:p>
           <a:p>
@@ -2310,7 +2310,7 @@
           <a:p>
             <a:r>
               <a:rPr dirty="0"/>
-              <a:t xml:space="preserve">0.25 minutes — </a:t>
+              <a:t>0.25 minutes — </a:t>
             </a:r>
             <a:r>
               <a:rPr i="1" dirty="0"/>
@@ -2445,7 +2445,7 @@
           <a:p>
             <a:r>
               <a:rPr dirty="0"/>
-              <a:t xml:space="preserve">1 minute — </a:t>
+              <a:t>1 minute — </a:t>
             </a:r>
             <a:r>
               <a:rPr i="1" dirty="0"/>
@@ -2651,7 +2651,7 @@
           <a:p>
             <a:r>
               <a:rPr dirty="0"/>
-              <a:t xml:space="preserve">2 minutes — </a:t>
+              <a:t>2 minutes — </a:t>
             </a:r>
             <a:r>
               <a:rPr i="1" dirty="0"/>
@@ -2717,7 +2717,7 @@
           <a:p>
             <a:r>
               <a:rPr dirty="0"/>
-              <a:t xml:space="preserve">1.5 minutes — </a:t>
+              <a:t>1.5 minutes — </a:t>
             </a:r>
             <a:r>
               <a:rPr i="1" dirty="0"/>
@@ -2783,7 +2783,7 @@
           <a:p>
             <a:r>
               <a:rPr dirty="0"/>
-              <a:t xml:space="preserve">2 minutes — </a:t>
+              <a:t>2 minutes — </a:t>
             </a:r>
             <a:r>
               <a:rPr i="1" dirty="0"/>
@@ -2867,7 +2867,7 @@
           <a:p>
             <a:r>
               <a:rPr dirty="0"/>
-              <a:t xml:space="preserve">0.3 minutes — </a:t>
+              <a:t>0.3 minutes — </a:t>
             </a:r>
             <a:r>
               <a:rPr i="1" dirty="0"/>
@@ -2927,7 +2927,7 @@
           <a:p>
             <a:r>
               <a:rPr dirty="0"/>
-              <a:t xml:space="preserve">1.5 minutes — </a:t>
+              <a:t>1.5 minutes — </a:t>
             </a:r>
             <a:r>
               <a:rPr i="1" dirty="0"/>
@@ -5770,7 +5770,7 @@
             </a:r>
             <a:r>
               <a:rPr lang="en-US" b="1" u="none" dirty="0"/>
-              <a:t xml:space="preserve">		Details</a:t>
+              <a:t>		Details</a:t>
             </a:r>
           </a:p>
           <a:p>
@@ -5947,7 +5947,7 @@
             </a:r>
             <a:r>
               <a:rPr lang="en-US" b="1" u="none" dirty="0"/>
-              <a:t xml:space="preserve">		Details</a:t>
+              <a:t>		Details</a:t>
             </a:r>
           </a:p>
           <a:p>
@@ -7358,7 +7358,7 @@
                   <a:srgbClr val="000000"/>
                 </a:solidFill>
               </a:rPr>
-              <a:t>What do we need to know?</a:t>
+              <a:t>Recap: What do we need to know?</a:t>
             </a:r>
           </a:p>
         </p:txBody>
@@ -7459,7 +7459,7 @@
                   <a:srgbClr val="8E6F3E"/>
                 </a:solidFill>
               </a:rPr>
-              <a:t xml:space="preserve">1   </a:t>
+              <a:t>1   </a:t>
             </a:r>
             <a:r>
               <a:rPr lang="en-US" sz="2000" b="1" i="0" dirty="0">
@@ -7475,7 +7475,7 @@
                   <a:srgbClr val="9A9A9A"/>
                 </a:solidFill>
               </a:rPr>
-              <a:t xml:space="preserve"> — </a:t>
+              <a:t> — </a:t>
             </a:r>
             <a:r>
               <a:rPr lang="en-US" sz="2000" b="0" i="0" dirty="0">
@@ -7524,7 +7524,7 @@
                   <a:srgbClr val="8E6F3E"/>
                 </a:solidFill>
               </a:rPr>
-              <a:t xml:space="preserve">2   </a:t>
+              <a:t>2   </a:t>
             </a:r>
             <a:r>
               <a:rPr lang="en-US" sz="2000" b="1" i="0" dirty="0">
@@ -7540,7 +7540,7 @@
                   <a:srgbClr val="9A9A9A"/>
                 </a:solidFill>
               </a:rPr>
-              <a:t xml:space="preserve"> — </a:t>
+              <a:t> — </a:t>
             </a:r>
             <a:r>
               <a:rPr lang="en-US" sz="2000" b="0" i="0" dirty="0">
@@ -7589,7 +7589,7 @@
                   <a:srgbClr val="8E6F3E"/>
                 </a:solidFill>
               </a:rPr>
-              <a:t xml:space="preserve">3   </a:t>
+              <a:t>3   </a:t>
             </a:r>
             <a:r>
               <a:rPr lang="en-US" sz="2000" b="1" i="0" dirty="0">
@@ -7605,7 +7605,7 @@
                   <a:srgbClr val="9A9A9A"/>
                 </a:solidFill>
               </a:rPr>
-              <a:t xml:space="preserve"> — </a:t>
+              <a:t> — </a:t>
             </a:r>
             <a:r>
               <a:rPr lang="en-US" sz="2000" b="0" i="0" dirty="0">
@@ -7654,7 +7654,7 @@
                   <a:srgbClr val="8E6F3E"/>
                 </a:solidFill>
               </a:rPr>
-              <a:t xml:space="preserve">4   </a:t>
+              <a:t>4   </a:t>
             </a:r>
             <a:r>
               <a:rPr lang="en-US" sz="2000" b="1" i="0" dirty="0">
@@ -7670,7 +7670,7 @@
                   <a:srgbClr val="9A9A9A"/>
                 </a:solidFill>
               </a:rPr>
-              <a:t xml:space="preserve"> — </a:t>
+              <a:t> — </a:t>
             </a:r>
             <a:r>
               <a:rPr lang="en-US" sz="2000" b="0" i="0" dirty="0">
@@ -7719,7 +7719,7 @@
                   <a:srgbClr val="8E6F3E"/>
                 </a:solidFill>
               </a:rPr>
-              <a:t xml:space="preserve">5   </a:t>
+              <a:t>5   </a:t>
             </a:r>
             <a:r>
               <a:rPr lang="en-US" sz="2000" b="1" i="0" dirty="0">
@@ -7735,7 +7735,7 @@
                   <a:srgbClr val="9A9A9A"/>
                 </a:solidFill>
               </a:rPr>
-              <a:t xml:space="preserve"> — </a:t>
+              <a:t> — </a:t>
             </a:r>
             <a:r>
               <a:rPr lang="en-US" sz="2000" b="0" i="0" dirty="0">
@@ -8438,7 +8438,23 @@
                   <a:srgbClr val="5C4826"/>
                 </a:solidFill>
               </a:rPr>
-              <a:t>A metric specifies how observations bear on some aspect of a property.</a:t>
+              <a:t>A </a:t>
+            </a:r>
+            <a:r>
+              <a:rPr lang="en-US" sz="2800" b="1" i="1" u="sng" dirty="0">
+                <a:solidFill>
+                  <a:srgbClr val="5C4826"/>
+                </a:solidFill>
+              </a:rPr>
+              <a:t>metric</a:t>
+            </a:r>
+            <a:r>
+              <a:rPr lang="en-US" sz="2000" b="0" i="0" dirty="0">
+                <a:solidFill>
+                  <a:srgbClr val="5C4826"/>
+                </a:solidFill>
+              </a:rPr>
+              <a:t> specifies how observations bear on some aspect of a property.</a:t>
             </a:r>
           </a:p>
         </p:txBody>
@@ -8477,7 +8493,23 @@
                   <a:srgbClr val="FFFFFF"/>
                 </a:solidFill>
               </a:rPr>
-              <a:t>The metric holds the modeling choice. The measurement supplies values.</a:t>
+              <a:t>The metric holds the modeling choice. The </a:t>
+            </a:r>
+            <a:r>
+              <a:rPr lang="en-US" sz="2800" i="1" dirty="0">
+                <a:solidFill>
+                  <a:srgbClr val="FFFFFF"/>
+                </a:solidFill>
+              </a:rPr>
+              <a:t>measurement</a:t>
+            </a:r>
+            <a:r>
+              <a:rPr lang="en-US" sz="2000" b="1" i="0" dirty="0">
+                <a:solidFill>
+                  <a:srgbClr val="FFFFFF"/>
+                </a:solidFill>
+              </a:rPr>
+              <a:t> supplies values.</a:t>
             </a:r>
           </a:p>
         </p:txBody>
@@ -9153,6 +9185,88 @@
           </a:p>
         </p:txBody>
       </p:sp>
+      <p:cxnSp>
+        <p:nvCxnSpPr>
+          <p:cNvPr id="5" name="Straight Arrow Connector 4">
+            <a:extLst>
+              <a:ext uri="{FF2B5EF4-FFF2-40B4-BE49-F238E27FC236}">
+                <a16:creationId xmlns:a16="http://schemas.microsoft.com/office/drawing/2014/main" id="{8A498575-94F6-0398-0B77-252F532EEB5C}"/>
+              </a:ext>
+            </a:extLst>
+          </p:cNvPr>
+          <p:cNvCxnSpPr/>
+          <p:nvPr/>
+        </p:nvCxnSpPr>
+        <p:spPr>
+          <a:xfrm flipV="1">
+            <a:off x="1538100" y="1874520"/>
+            <a:ext cx="1366020" cy="1865377"/>
+          </a:xfrm>
+          <a:prstGeom prst="straightConnector1">
+            <a:avLst/>
+          </a:prstGeom>
+          <a:ln w="76200">
+            <a:headEnd type="triangle" w="med" len="med"/>
+            <a:tailEnd type="none" w="med" len="med"/>
+          </a:ln>
+        </p:spPr>
+        <p:style>
+          <a:lnRef idx="1">
+            <a:schemeClr val="accent1"/>
+          </a:lnRef>
+          <a:fillRef idx="0">
+            <a:schemeClr val="accent1"/>
+          </a:fillRef>
+          <a:effectRef idx="0">
+            <a:schemeClr val="accent1"/>
+          </a:effectRef>
+          <a:fontRef idx="minor">
+            <a:schemeClr val="tx1"/>
+          </a:fontRef>
+        </p:style>
+      </p:cxnSp>
+      <p:cxnSp>
+        <p:nvCxnSpPr>
+          <p:cNvPr id="6" name="Straight Arrow Connector 5">
+            <a:extLst>
+              <a:ext uri="{FF2B5EF4-FFF2-40B4-BE49-F238E27FC236}">
+                <a16:creationId xmlns:a16="http://schemas.microsoft.com/office/drawing/2014/main" id="{91BF9832-74DE-440A-0EFC-FED2CE059935}"/>
+              </a:ext>
+            </a:extLst>
+          </p:cNvPr>
+          <p:cNvCxnSpPr>
+            <a:cxnSpLocks/>
+          </p:cNvCxnSpPr>
+          <p:nvPr/>
+        </p:nvCxnSpPr>
+        <p:spPr>
+          <a:xfrm flipH="1" flipV="1">
+            <a:off x="4694520" y="1874520"/>
+            <a:ext cx="825747" cy="3977640"/>
+          </a:xfrm>
+          <a:prstGeom prst="straightConnector1">
+            <a:avLst/>
+          </a:prstGeom>
+          <a:ln w="76200">
+            <a:headEnd type="triangle" w="med" len="med"/>
+            <a:tailEnd type="none" w="med" len="med"/>
+          </a:ln>
+        </p:spPr>
+        <p:style>
+          <a:lnRef idx="1">
+            <a:schemeClr val="accent1"/>
+          </a:lnRef>
+          <a:fillRef idx="0">
+            <a:schemeClr val="accent1"/>
+          </a:fillRef>
+          <a:effectRef idx="0">
+            <a:schemeClr val="accent1"/>
+          </a:effectRef>
+          <a:fontRef idx="minor">
+            <a:schemeClr val="tx1"/>
+          </a:fontRef>
+        </p:style>
+      </p:cxnSp>
     </p:spTree>
   </p:cSld>
   <p:clrMapOvr>
@@ -9179,7 +9293,7 @@
                             </p:stCondLst>
                             <p:childTnLst>
                               <p:par>
-                                <p:cTn id="5" presetID="1" presetClass="entr" presetSubtype="0" fill="hold" grpId="0" nodeType="clickEffect">
+                                <p:cTn id="5" presetID="1" presetClass="entr" presetSubtype="0" fill="hold" nodeType="clickEffect">
                                   <p:stCondLst>
                                     <p:cond delay="0"/>
                                   </p:stCondLst>
@@ -9192,7 +9306,106 @@
                                           </p:stCondLst>
                                         </p:cTn>
                                         <p:tgtEl>
+                                          <p:spTgt spid="5"/>
+                                        </p:tgtEl>
+                                        <p:attrNameLst>
+                                          <p:attrName>style.visibility</p:attrName>
+                                        </p:attrNameLst>
+                                      </p:cBhvr>
+                                      <p:to>
+                                        <p:strVal val="visible"/>
+                                      </p:to>
+                                    </p:set>
+                                  </p:childTnLst>
+                                </p:cTn>
+                              </p:par>
+                              <p:par>
+                                <p:cTn id="7" presetID="1" presetClass="entr" presetSubtype="0" fill="hold" grpId="0" nodeType="withEffect">
+                                  <p:stCondLst>
+                                    <p:cond delay="0"/>
+                                  </p:stCondLst>
+                                  <p:childTnLst>
+                                    <p:set>
+                                      <p:cBhvr>
+                                        <p:cTn id="8" dur="1" fill="hold">
+                                          <p:stCondLst>
+                                            <p:cond delay="0"/>
+                                          </p:stCondLst>
+                                        </p:cTn>
+                                        <p:tgtEl>
+                                          <p:spTgt spid="114"/>
+                                        </p:tgtEl>
+                                        <p:attrNameLst>
+                                          <p:attrName>style.visibility</p:attrName>
+                                        </p:attrNameLst>
+                                      </p:cBhvr>
+                                      <p:to>
+                                        <p:strVal val="visible"/>
+                                      </p:to>
+                                    </p:set>
+                                  </p:childTnLst>
+                                </p:cTn>
+                              </p:par>
+                            </p:childTnLst>
+                          </p:cTn>
+                        </p:par>
+                      </p:childTnLst>
+                    </p:cTn>
+                  </p:par>
+                  <p:par>
+                    <p:cTn id="9" fill="hold">
+                      <p:stCondLst>
+                        <p:cond delay="indefinite"/>
+                      </p:stCondLst>
+                      <p:childTnLst>
+                        <p:par>
+                          <p:cTn id="10" fill="hold">
+                            <p:stCondLst>
+                              <p:cond delay="0"/>
+                            </p:stCondLst>
+                            <p:childTnLst>
+                              <p:par>
+                                <p:cTn id="11" presetID="1" presetClass="entr" presetSubtype="0" fill="hold" grpId="0" nodeType="clickEffect">
+                                  <p:stCondLst>
+                                    <p:cond delay="0"/>
+                                  </p:stCondLst>
+                                  <p:childTnLst>
+                                    <p:set>
+                                      <p:cBhvr>
+                                        <p:cTn id="12" dur="1" fill="hold">
+                                          <p:stCondLst>
+                                            <p:cond delay="0"/>
+                                          </p:stCondLst>
+                                        </p:cTn>
+                                        <p:tgtEl>
                                           <p:spTgt spid="116"/>
+                                        </p:tgtEl>
+                                        <p:attrNameLst>
+                                          <p:attrName>style.visibility</p:attrName>
+                                        </p:attrNameLst>
+                                      </p:cBhvr>
+                                      <p:to>
+                                        <p:strVal val="visible"/>
+                                      </p:to>
+                                    </p:set>
+                                  </p:childTnLst>
+                                </p:cTn>
+                              </p:par>
+                              <p:par>
+                                <p:cTn id="13" presetID="1" presetClass="entr" presetSubtype="0" fill="hold" nodeType="withEffect">
+                                  <p:stCondLst>
+                                    <p:cond delay="0"/>
+                                  </p:stCondLst>
+                                  <p:childTnLst>
+                                    <p:set>
+                                      <p:cBhvr>
+                                        <p:cTn id="14" dur="1" fill="hold">
+                                          <p:stCondLst>
+                                            <p:cond delay="0"/>
+                                          </p:stCondLst>
+                                        </p:cTn>
+                                        <p:tgtEl>
+                                          <p:spTgt spid="6"/>
                                         </p:tgtEl>
                                         <p:attrNameLst>
                                           <p:attrName>style.visibility</p:attrName>
@@ -9233,6 +9446,7 @@
       </p:par>
     </p:tnLst>
     <p:bldLst>
+      <p:bldP spid="114" grpId="0" animBg="1"/>
       <p:bldP spid="116" grpId="0" animBg="1"/>
     </p:bldLst>
   </p:timing>
@@ -9972,7 +10186,7 @@
                   <a:srgbClr val="5C4826"/>
                 </a:solidFill>
               </a:rPr>
-              <a:t xml:space="preserve">service = 180 ms </a:t>
+              <a:t>service = 180 ms </a:t>
             </a:r>
             <a:r>
               <a:rPr lang="en-US" sz="2000" b="0" i="1" dirty="0">
@@ -9996,7 +10210,7 @@
                   <a:srgbClr val="5C4826"/>
                 </a:solidFill>
               </a:rPr>
-              <a:t xml:space="preserve">queueing = 130 ms </a:t>
+              <a:t>queueing = 130 ms </a:t>
             </a:r>
             <a:r>
               <a:rPr lang="en-US" sz="2000" b="0" i="1" dirty="0">
@@ -10020,7 +10234,7 @@
                   <a:srgbClr val="5C4826"/>
                 </a:solidFill>
               </a:rPr>
-              <a:t xml:space="preserve">communication = 90 ms </a:t>
+              <a:t>communication = 90 ms </a:t>
             </a:r>
             <a:r>
               <a:rPr lang="en-US" sz="2000" b="0" i="1" dirty="0">
@@ -10522,7 +10736,7 @@
                   <a:srgbClr val="9A9A9A"/>
                 </a:solidFill>
               </a:rPr>
-              <a:t xml:space="preserve">  ·  </a:t>
+              <a:t>  ·  </a:t>
             </a:r>
             <a:r>
               <a:rPr sz="2000" b="1" i="0">
@@ -10538,7 +10752,7 @@
                   <a:srgbClr val="9A9A9A"/>
                 </a:solidFill>
               </a:rPr>
-              <a:t xml:space="preserve">  ·  </a:t>
+              <a:t>  ·  </a:t>
             </a:r>
             <a:r>
               <a:rPr sz="2000" b="1" i="0">
@@ -13594,7 +13808,7 @@
                   <a:srgbClr val="8E6F3E"/>
                 </a:solidFill>
               </a:rPr>
-              <a:t xml:space="preserve">INDIRECT </a:t>
+              <a:t>INDIRECT </a:t>
             </a:r>
             <a:r>
               <a:rPr lang="en-US" sz="2000" b="1" dirty="0">
@@ -14479,7 +14693,7 @@
                   <a:srgbClr val="9A9A9A"/>
                 </a:solidFill>
               </a:rPr>
-              <a:t xml:space="preserve">  →  </a:t>
+              <a:t>  →  </a:t>
             </a:r>
             <a:r>
               <a:rPr lang="en-US" sz="2000" b="0" i="0" dirty="0">
@@ -14536,7 +14750,7 @@
                   <a:srgbClr val="9A9A9A"/>
                 </a:solidFill>
               </a:rPr>
-              <a:t xml:space="preserve">  →  </a:t>
+              <a:t>  →  </a:t>
             </a:r>
             <a:r>
               <a:rPr lang="en-US" sz="2000" b="0" i="0" dirty="0">
@@ -14593,7 +14807,7 @@
                   <a:srgbClr val="9A9A9A"/>
                 </a:solidFill>
               </a:rPr>
-              <a:t xml:space="preserve">  →  </a:t>
+              <a:t>  →  </a:t>
             </a:r>
             <a:r>
               <a:rPr lang="en-US" sz="2000" b="0" i="0" dirty="0">
@@ -17039,7 +17253,7 @@
                   <a:srgbClr val="9A9A9A"/>
                 </a:solidFill>
               </a:rPr>
-              <a:t xml:space="preserve">  ·  </a:t>
+              <a:t>  ·  </a:t>
             </a:r>
             <a:r>
               <a:rPr lang="en-US" sz="2000" b="1" i="0" dirty="0">
@@ -17055,7 +17269,7 @@
                   <a:srgbClr val="9A9A9A"/>
                 </a:solidFill>
               </a:rPr>
-              <a:t xml:space="preserve">  ·  </a:t>
+              <a:t>  ·  </a:t>
             </a:r>
             <a:r>
               <a:rPr lang="en-US" sz="2000" b="1" i="0" dirty="0">
@@ -17737,7 +17951,7 @@
                   <a:srgbClr val="5C4826"/>
                 </a:solidFill>
               </a:rPr>
-              <a:t xml:space="preserve">commits </a:t>
+              <a:t>commits </a:t>
             </a:r>
             <a:r>
               <a:rPr lang="en-US" sz="2000" dirty="0">
@@ -17746,7 +17960,7 @@
                 </a:solidFill>
                 <a:sym typeface="Wingdings" pitchFamily="2" charset="2"/>
               </a:rPr>
-              <a:t xml:space="preserve"> </a:t>
+              <a:t> </a:t>
             </a:r>
             <a:r>
               <a:rPr lang="en-US" sz="2000" b="0" i="0" dirty="0">
@@ -17799,7 +18013,7 @@
                   <a:srgbClr val="555960"/>
                 </a:solidFill>
               </a:rPr>
-              <a:t xml:space="preserve">Surrogation: </a:t>
+              <a:t>Surrogation: </a:t>
             </a:r>
             <a:r>
               <a:rPr lang="en-US" sz="2000" b="0" i="1" dirty="0">
@@ -17807,7 +18021,7 @@
                   <a:srgbClr val="555960"/>
                 </a:solidFill>
               </a:rPr>
-              <a:t xml:space="preserve">we begin treating commits as though they </a:t>
+              <a:t>we begin treating commits as though they </a:t>
             </a:r>
           </a:p>
           <a:p>
@@ -17831,7 +18045,7 @@
                   <a:srgbClr val="555960"/>
                 </a:solidFill>
               </a:rPr>
-              <a:t xml:space="preserve"> useful output</a:t>
+              <a:t> useful output</a:t>
             </a:r>
           </a:p>
         </p:txBody>
@@ -17907,7 +18121,7 @@
                   <a:srgbClr val="5C4826"/>
                 </a:solidFill>
               </a:rPr>
-              <a:t xml:space="preserve">Target: increase </a:t>
+              <a:t>Target: increase </a:t>
             </a:r>
             <a:endParaRPr lang="en-US" sz="2000" b="1" dirty="0">
               <a:solidFill>
@@ -17942,7 +18156,7 @@
                   <a:srgbClr val="5C4826"/>
                 </a:solidFill>
               </a:rPr>
-              <a:t xml:space="preserve">; </a:t>
+              <a:t>; </a:t>
             </a:r>
             <a:r>
               <a:rPr sz="2000" b="0" i="0" dirty="0">
@@ -17976,7 +18190,7 @@
                   <a:srgbClr val="555960"/>
                 </a:solidFill>
               </a:rPr>
-              <a:t xml:space="preserve">Goodhart: </a:t>
+              <a:t>Goodhart: </a:t>
             </a:r>
             <a:r>
               <a:rPr lang="en-US" sz="2000" b="0" i="1" dirty="0">
@@ -17984,7 +18198,7 @@
                   <a:srgbClr val="555960"/>
                 </a:solidFill>
               </a:rPr>
-              <a:t xml:space="preserve">once commits become </a:t>
+              <a:t>once commits become </a:t>
             </a:r>
           </a:p>
           <a:p>
@@ -17997,7 +18211,7 @@
                   <a:srgbClr val="555960"/>
                 </a:solidFill>
               </a:rPr>
-              <a:t xml:space="preserve">the target, the empirical </a:t>
+              <a:t>the target, the empirical </a:t>
             </a:r>
           </a:p>
           <a:p>
@@ -18654,7 +18868,7 @@
                   <a:srgbClr val="5C4826"/>
                 </a:solidFill>
               </a:rPr>
-              <a:t xml:space="preserve">A metric acquires meaning through the property, </a:t>
+              <a:t>A metric acquires meaning through the property, </a:t>
             </a:r>
           </a:p>
           <a:p>
@@ -18793,7 +19007,7 @@
                   <a:srgbClr val="8E6F3E"/>
                 </a:solidFill>
               </a:rPr>
-              <a:t xml:space="preserve">1    </a:t>
+              <a:t>1    </a:t>
             </a:r>
             <a:r>
               <a:rPr lang="en-US" sz="2400" b="0" i="0" dirty="0">
@@ -18842,7 +19056,7 @@
                   <a:srgbClr val="8E6F3E"/>
                 </a:solidFill>
               </a:rPr>
-              <a:t xml:space="preserve">2    </a:t>
+              <a:t>2    </a:t>
             </a:r>
             <a:r>
               <a:rPr lang="en-US" sz="2400" b="0" i="0" dirty="0">
@@ -18891,7 +19105,7 @@
                   <a:srgbClr val="8E6F3E"/>
                 </a:solidFill>
               </a:rPr>
-              <a:t xml:space="preserve">3    </a:t>
+              <a:t>3    </a:t>
             </a:r>
             <a:r>
               <a:rPr lang="en-US" sz="2400" b="0" i="0" dirty="0">
@@ -18940,7 +19154,7 @@
                   <a:srgbClr val="8E6F3E"/>
                 </a:solidFill>
               </a:rPr>
-              <a:t xml:space="preserve">4    </a:t>
+              <a:t>4    </a:t>
             </a:r>
             <a:r>
               <a:rPr lang="en-US" sz="2400" b="0" i="0" dirty="0">
@@ -20089,7 +20303,7 @@
                   <a:srgbClr val="8E6F3E"/>
                 </a:solidFill>
               </a:rPr>
-              <a:t xml:space="preserve">1  </a:t>
+              <a:t>1  </a:t>
             </a:r>
             <a:r>
               <a:rPr lang="en-US" sz="1300" b="0" i="0" dirty="0">
@@ -20116,7 +20330,7 @@
                   <a:srgbClr val="8E6F3E"/>
                 </a:solidFill>
               </a:rPr>
-              <a:t xml:space="preserve">2  </a:t>
+              <a:t>2  </a:t>
             </a:r>
             <a:r>
               <a:rPr lang="en-US" sz="1300" b="0" i="0" dirty="0">
@@ -20143,7 +20357,7 @@
                   <a:srgbClr val="8E6F3E"/>
                 </a:solidFill>
               </a:rPr>
-              <a:t xml:space="preserve">3  </a:t>
+              <a:t>3  </a:t>
             </a:r>
             <a:r>
               <a:rPr lang="en-US" sz="1300" b="0" i="0" dirty="0">
@@ -20170,7 +20384,7 @@
                   <a:srgbClr val="8E6F3E"/>
                 </a:solidFill>
               </a:rPr>
-              <a:t xml:space="preserve">4  </a:t>
+              <a:t>4  </a:t>
             </a:r>
             <a:r>
               <a:rPr lang="en-US" sz="1300" b="0" i="0" dirty="0">
@@ -20197,7 +20411,7 @@
                   <a:srgbClr val="8E6F3E"/>
                 </a:solidFill>
               </a:rPr>
-              <a:t xml:space="preserve">5  </a:t>
+              <a:t>5  </a:t>
             </a:r>
             <a:r>
               <a:rPr lang="en-US" sz="1300" b="0" i="0" dirty="0">
@@ -20224,7 +20438,7 @@
                   <a:srgbClr val="8E6F3E"/>
                 </a:solidFill>
               </a:rPr>
-              <a:t xml:space="preserve">6  </a:t>
+              <a:t>6  </a:t>
             </a:r>
             <a:r>
               <a:rPr lang="en-US" sz="1300" b="1" i="0" dirty="0">
@@ -23268,7 +23482,7 @@
                   <a:srgbClr val="555960"/>
                 </a:solidFill>
               </a:rPr>
-              <a:t xml:space="preserve">outcomes </a:t>
+              <a:t>outcomes </a:t>
             </a:r>
             <a:r>
               <a:rPr lang="en-US" sz="2000" dirty="0">
@@ -23276,7 +23490,7 @@
                   <a:srgbClr val="555960"/>
                 </a:solidFill>
               </a:rPr>
-              <a:t xml:space="preserve">are a </a:t>
+              <a:t>are a </a:t>
             </a:r>
             <a:r>
               <a:rPr lang="en-US" sz="2000" b="0" i="0" dirty="0">
@@ -23457,7 +23671,7 @@
                   <a:srgbClr val="5C4826"/>
                 </a:solidFill>
               </a:rPr>
-              <a:t xml:space="preserve"> against a bound of </a:t>
+              <a:t> against a bound of </a:t>
             </a:r>
             <a:r>
               <a:rPr lang="en-US" sz="2000" b="1" i="0" dirty="0">
@@ -23543,7 +23757,7 @@
                   <a:srgbClr val="5C4826"/>
                 </a:solidFill>
               </a:rPr>
-              <a:t xml:space="preserve">What happens if </a:t>
+              <a:t>What happens if </a:t>
             </a:r>
             <a:endParaRPr lang="en-US" sz="2000" dirty="0">
               <a:solidFill>
@@ -23717,7 +23931,7 @@
                   <a:srgbClr val="5C4826"/>
                 </a:solidFill>
               </a:rPr>
-              <a:t xml:space="preserve">Can consequences </a:t>
+              <a:t>Can consequences </a:t>
             </a:r>
           </a:p>
           <a:p>
@@ -23765,7 +23979,7 @@
                   <a:srgbClr val="555960"/>
                 </a:solidFill>
               </a:rPr>
-              <a:t xml:space="preserve">The same margin may be comfortable in a game </a:t>
+              <a:t>The same margin may be comfortable in a game </a:t>
             </a:r>
             <a:endParaRPr lang="en-US" sz="2000" b="0" i="1" dirty="0">
               <a:solidFill>
@@ -25573,7 +25787,7 @@
                   <a:srgbClr val="5C4826"/>
                 </a:solidFill>
               </a:rPr>
-              <a:t xml:space="preserve">Engineering is the discipline of exercising </a:t>
+              <a:t>Engineering is the discipline of exercising </a:t>
             </a:r>
           </a:p>
           <a:p>
@@ -25639,7 +25853,7 @@
                   <a:srgbClr val="555960"/>
                 </a:solidFill>
               </a:rPr>
-              <a:t xml:space="preserve">Engineering judgment determines what </a:t>
+              <a:t>Engineering judgment determines what </a:t>
             </a:r>
           </a:p>
           <a:p>
@@ -26074,7 +26288,7 @@
                   <a:srgbClr val="5C4826"/>
                 </a:solidFill>
               </a:rPr>
-              <a:t xml:space="preserve">A good engineering decision is the decision </a:t>
+              <a:t>A good engineering decision is the decision </a:t>
             </a:r>
             <a:r>
               <a:rPr lang="en-US" sz="2000" b="1" i="0" dirty="0">
@@ -26082,7 +26296,7 @@
                   <a:srgbClr val="5C4826"/>
                 </a:solidFill>
               </a:rPr>
-              <a:t xml:space="preserve">best justified </a:t>
+              <a:t>best justified </a:t>
             </a:r>
           </a:p>
           <a:p>
@@ -26201,7 +26415,7 @@
                   <a:srgbClr val="9A9A9A"/>
                 </a:solidFill>
               </a:rPr>
-              <a:t xml:space="preserve">  ·  </a:t>
+              <a:t>  ·  </a:t>
             </a:r>
             <a:r>
               <a:rPr lang="en-US" sz="2000" b="1" i="0" dirty="0">
@@ -26217,7 +26431,7 @@
                   <a:srgbClr val="9A9A9A"/>
                 </a:solidFill>
               </a:rPr>
-              <a:t xml:space="preserve">  ·  </a:t>
+              <a:t>  ·  </a:t>
             </a:r>
             <a:r>
               <a:rPr lang="en-US" sz="2000" b="1" i="0" dirty="0">
@@ -26299,7 +26513,7 @@
                   <a:srgbClr val="000000"/>
                 </a:solidFill>
               </a:rPr>
-              <a:t xml:space="preserve">No. </a:t>
+              <a:t>No. </a:t>
             </a:r>
             <a:r>
               <a:rPr lang="en-US" sz="2000" i="1" dirty="0">
@@ -26574,15 +26788,87 @@
                                   </p:childTnLst>
                                 </p:cTn>
                               </p:par>
+                            </p:childTnLst>
+                          </p:cTn>
+                        </p:par>
+                      </p:childTnLst>
+                    </p:cTn>
+                  </p:par>
+                  <p:par>
+                    <p:cTn id="11" fill="hold">
+                      <p:stCondLst>
+                        <p:cond delay="indefinite"/>
+                      </p:stCondLst>
+                      <p:childTnLst>
+                        <p:par>
+                          <p:cTn id="12" fill="hold">
+                            <p:stCondLst>
+                              <p:cond delay="0"/>
+                            </p:stCondLst>
+                            <p:childTnLst>
                               <p:par>
-                                <p:cTn id="11" presetID="10" presetClass="entr" presetSubtype="0" fill="hold" nodeType="withEffect">
+                                <p:cTn id="13" presetID="1" presetClass="entr" presetSubtype="0" fill="hold" grpId="0" nodeType="clickEffect">
                                   <p:stCondLst>
                                     <p:cond delay="0"/>
                                   </p:stCondLst>
                                   <p:childTnLst>
                                     <p:set>
                                       <p:cBhvr>
-                                        <p:cTn id="12" dur="1" fill="hold">
+                                        <p:cTn id="14" dur="1" fill="hold">
+                                          <p:stCondLst>
+                                            <p:cond delay="0"/>
+                                          </p:stCondLst>
+                                        </p:cTn>
+                                        <p:tgtEl>
+                                          <p:spTgt spid="107"/>
+                                        </p:tgtEl>
+                                        <p:attrNameLst>
+                                          <p:attrName>style.visibility</p:attrName>
+                                        </p:attrNameLst>
+                                      </p:cBhvr>
+                                      <p:to>
+                                        <p:strVal val="visible"/>
+                                      </p:to>
+                                    </p:set>
+                                  </p:childTnLst>
+                                </p:cTn>
+                              </p:par>
+                              <p:par>
+                                <p:cTn id="15" presetID="1" presetClass="entr" presetSubtype="0" fill="hold" grpId="0" nodeType="withEffect">
+                                  <p:stCondLst>
+                                    <p:cond delay="0"/>
+                                  </p:stCondLst>
+                                  <p:childTnLst>
+                                    <p:set>
+                                      <p:cBhvr>
+                                        <p:cTn id="16" dur="1" fill="hold">
+                                          <p:stCondLst>
+                                            <p:cond delay="0"/>
+                                          </p:stCondLst>
+                                        </p:cTn>
+                                        <p:tgtEl>
+                                          <p:spTgt spid="106"/>
+                                        </p:tgtEl>
+                                        <p:attrNameLst>
+                                          <p:attrName>style.visibility</p:attrName>
+                                        </p:attrNameLst>
+                                      </p:cBhvr>
+                                      <p:to>
+                                        <p:strVal val="visible"/>
+                                      </p:to>
+                                    </p:set>
+                                  </p:childTnLst>
+                                </p:cTn>
+                              </p:par>
+                              <p:par>
+                                <p:cTn id="17" presetID="1" presetClass="entr" presetSubtype="0" fill="hold" grpId="0" nodeType="withEffect">
+                                  <p:stCondLst>
+                                    <p:cond delay="0"/>
+                                  </p:stCondLst>
+                                  <p:childTnLst>
+                                    <p:set>
+                                      <p:cBhvr>
+                                        <p:cTn id="18" dur="1" fill="hold">
                                           <p:stCondLst>
                                             <p:cond delay="0"/>
                                           </p:stCondLst>
@@ -26598,84 +26884,6 @@
                                         <p:strVal val="visible"/>
                                       </p:to>
                                     </p:set>
-                                    <p:animEffect transition="in" filter="fade">
-                                      <p:cBhvr>
-                                        <p:cTn id="13" dur="500"/>
-                                        <p:tgtEl>
-                                          <p:spTgt spid="105"/>
-                                        </p:tgtEl>
-                                      </p:cBhvr>
-                                    </p:animEffect>
-                                  </p:childTnLst>
-                                </p:cTn>
-                              </p:par>
-                              <p:par>
-                                <p:cTn id="14" presetID="10" presetClass="entr" presetSubtype="0" fill="hold" nodeType="withEffect">
-                                  <p:stCondLst>
-                                    <p:cond delay="0"/>
-                                  </p:stCondLst>
-                                  <p:childTnLst>
-                                    <p:set>
-                                      <p:cBhvr>
-                                        <p:cTn id="15" dur="1" fill="hold">
-                                          <p:stCondLst>
-                                            <p:cond delay="0"/>
-                                          </p:stCondLst>
-                                        </p:cTn>
-                                        <p:tgtEl>
-                                          <p:spTgt spid="106"/>
-                                        </p:tgtEl>
-                                        <p:attrNameLst>
-                                          <p:attrName>style.visibility</p:attrName>
-                                        </p:attrNameLst>
-                                      </p:cBhvr>
-                                      <p:to>
-                                        <p:strVal val="visible"/>
-                                      </p:to>
-                                    </p:set>
-                                    <p:animEffect transition="in" filter="fade">
-                                      <p:cBhvr>
-                                        <p:cTn id="16" dur="500"/>
-                                        <p:tgtEl>
-                                          <p:spTgt spid="106"/>
-                                        </p:tgtEl>
-                                      </p:cBhvr>
-                                    </p:animEffect>
-                                  </p:childTnLst>
-                                </p:cTn>
-                              </p:par>
-                              <p:par>
-                                <p:cTn id="17" presetID="10" presetClass="entr" presetSubtype="0" fill="hold" nodeType="withEffect">
-                                  <p:stCondLst>
-                                    <p:cond delay="0"/>
-                                  </p:stCondLst>
-                                  <p:childTnLst>
-                                    <p:set>
-                                      <p:cBhvr>
-                                        <p:cTn id="18" dur="1" fill="hold">
-                                          <p:stCondLst>
-                                            <p:cond delay="0"/>
-                                          </p:stCondLst>
-                                        </p:cTn>
-                                        <p:tgtEl>
-                                          <p:spTgt spid="107"/>
-                                        </p:tgtEl>
-                                        <p:attrNameLst>
-                                          <p:attrName>style.visibility</p:attrName>
-                                        </p:attrNameLst>
-                                      </p:cBhvr>
-                                      <p:to>
-                                        <p:strVal val="visible"/>
-                                      </p:to>
-                                    </p:set>
-                                    <p:animEffect transition="in" filter="fade">
-                                      <p:cBhvr>
-                                        <p:cTn id="19" dur="500"/>
-                                        <p:tgtEl>
-                                          <p:spTgt spid="107"/>
-                                        </p:tgtEl>
-                                      </p:cBhvr>
-                                    </p:animEffect>
                                   </p:childTnLst>
                                 </p:cTn>
                               </p:par>
@@ -26706,6 +26914,11 @@
         </p:cTn>
       </p:par>
     </p:tnLst>
+    <p:bldLst>
+      <p:bldP spid="106" grpId="0" animBg="1"/>
+      <p:bldP spid="107" grpId="0"/>
+      <p:bldP spid="105" grpId="0" animBg="1"/>
+    </p:bldLst>
   </p:timing>
 </p:sld>
 </file>
@@ -27256,7 +27469,7 @@
                   <a:srgbClr val="5C4826"/>
                 </a:solidFill>
               </a:rPr>
-              <a:t xml:space="preserve">A model identifies relationships we believe matter, </a:t>
+              <a:t>A model identifies relationships we believe matter, </a:t>
             </a:r>
           </a:p>
           <a:p>
@@ -27277,7 +27490,7 @@
                   <a:srgbClr val="5C4826"/>
                 </a:solidFill>
               </a:rPr>
-              <a:t xml:space="preserve"> their consequences can be fully observed.</a:t>
+              <a:t> their consequences can be fully observed.</a:t>
             </a:r>
           </a:p>
         </p:txBody>
@@ -27410,9 +27623,6 @@
                     <p:cTn id="3" fill="hold">
                       <p:stCondLst>
                         <p:cond delay="indefinite"/>
-                        <p:cond evt="onBegin" delay="0">
-                          <p:tn val="2"/>
-                        </p:cond>
                       </p:stCondLst>
                       <p:childTnLst>
                         <p:par>
@@ -27422,7 +27632,7 @@
                             </p:stCondLst>
                             <p:childTnLst>
                               <p:par>
-                                <p:cTn id="5" presetID="10" presetClass="entr" presetSubtype="0" fill="hold" nodeType="withEffect">
+                                <p:cTn id="5" presetID="1" presetClass="entr" presetSubtype="0" fill="hold" grpId="0" nodeType="clickEffect">
                                   <p:stCondLst>
                                     <p:cond delay="0"/>
                                   </p:stCondLst>
@@ -27430,6 +27640,33 @@
                                     <p:set>
                                       <p:cBhvr>
                                         <p:cTn id="6" dur="1" fill="hold">
+                                          <p:stCondLst>
+                                            <p:cond delay="0"/>
+                                          </p:stCondLst>
+                                        </p:cTn>
+                                        <p:tgtEl>
+                                          <p:spTgt spid="107"/>
+                                        </p:tgtEl>
+                                        <p:attrNameLst>
+                                          <p:attrName>style.visibility</p:attrName>
+                                        </p:attrNameLst>
+                                      </p:cBhvr>
+                                      <p:to>
+                                        <p:strVal val="visible"/>
+                                      </p:to>
+                                    </p:set>
+                                  </p:childTnLst>
+                                </p:cTn>
+                              </p:par>
+                              <p:par>
+                                <p:cTn id="7" presetID="1" presetClass="entr" presetSubtype="0" fill="hold" grpId="0" nodeType="withEffect">
+                                  <p:stCondLst>
+                                    <p:cond delay="0"/>
+                                  </p:stCondLst>
+                                  <p:childTnLst>
+                                    <p:set>
+                                      <p:cBhvr>
+                                        <p:cTn id="8" dur="1" fill="hold">
                                           <p:stCondLst>
                                             <p:cond delay="0"/>
                                           </p:stCondLst>
@@ -27445,14 +27682,6 @@
                                         <p:strVal val="visible"/>
                                       </p:to>
                                     </p:set>
-                                    <p:animEffect transition="in" filter="fade">
-                                      <p:cBhvr>
-                                        <p:cTn id="7" dur="500"/>
-                                        <p:tgtEl>
-                                          <p:spTgt spid="4"/>
-                                        </p:tgtEl>
-                                      </p:cBhvr>
-                                    </p:animEffect>
                                   </p:childTnLst>
                                 </p:cTn>
                               </p:par>
@@ -27483,6 +27712,10 @@
         </p:cTn>
       </p:par>
     </p:tnLst>
+    <p:bldLst>
+      <p:bldP spid="107" grpId="0"/>
+      <p:bldP spid="4" grpId="0" animBg="1"/>
+    </p:bldLst>
   </p:timing>
 </p:sld>
 </file>
@@ -28225,8 +28458,8 @@
         </p:nvSpPr>
         <p:spPr>
           <a:xfrm>
-            <a:off x="3474720" y="5852160"/>
-            <a:ext cx="5394960" cy="640080"/>
+            <a:off x="3474720" y="6018311"/>
+            <a:ext cx="5394960" cy="307777"/>
           </a:xfrm>
           <a:prstGeom prst="rect">
             <a:avLst/>
@@ -28256,21 +28489,21 @@
               </a:rPr>
               <a:t>,</a:t>
             </a:r>
-            <a:endParaRPr sz="2000" b="0" i="0" dirty="0">
-              <a:solidFill>
-                <a:srgbClr val="555960"/>
-              </a:solidFill>
-            </a:endParaRPr>
-          </a:p>
-          <a:p>
-            <a:pPr algn="l"/>
+            <a:r>
+              <a:rPr lang="en-US" sz="2000" dirty="0">
+                <a:solidFill>
+                  <a:srgbClr val="555960"/>
+                </a:solidFill>
+              </a:rPr>
+              <a:t> </a:t>
+            </a:r>
             <a:r>
               <a:rPr sz="2000" b="0" i="0" dirty="0">
                 <a:solidFill>
                   <a:srgbClr val="555960"/>
                 </a:solidFill>
               </a:rPr>
-              <a:t>not from the evidence alone</a:t>
+              <a:t>not evidence</a:t>
             </a:r>
           </a:p>
         </p:txBody>
@@ -30619,7 +30852,7 @@
                                           </p:stCondLst>
                                         </p:cTn>
                                         <p:tgtEl>
-                                          <p:spTgt spid="19"/>
+                                          <p:spTgt spid="40"/>
                                         </p:tgtEl>
                                         <p:attrNameLst>
                                           <p:attrName>style.visibility</p:attrName>
@@ -30633,59 +30866,6 @@
                                       <p:cBhvr>
                                         <p:cTn id="53" dur="500"/>
                                         <p:tgtEl>
-                                          <p:spTgt spid="19"/>
-                                        </p:tgtEl>
-                                      </p:cBhvr>
-                                    </p:animEffect>
-                                  </p:childTnLst>
-                                </p:cTn>
-                              </p:par>
-                            </p:childTnLst>
-                          </p:cTn>
-                        </p:par>
-                      </p:childTnLst>
-                    </p:cTn>
-                  </p:par>
-                  <p:par>
-                    <p:cTn id="54" fill="hold">
-                      <p:stCondLst>
-                        <p:cond delay="indefinite"/>
-                      </p:stCondLst>
-                      <p:childTnLst>
-                        <p:par>
-                          <p:cTn id="55" fill="hold">
-                            <p:stCondLst>
-                              <p:cond delay="0"/>
-                            </p:stCondLst>
-                            <p:childTnLst>
-                              <p:par>
-                                <p:cTn id="56" presetID="10" presetClass="entr" presetSubtype="0" fill="hold" nodeType="clickEffect">
-                                  <p:stCondLst>
-                                    <p:cond delay="0"/>
-                                  </p:stCondLst>
-                                  <p:childTnLst>
-                                    <p:set>
-                                      <p:cBhvr>
-                                        <p:cTn id="57" dur="1" fill="hold">
-                                          <p:stCondLst>
-                                            <p:cond delay="0"/>
-                                          </p:stCondLst>
-                                        </p:cTn>
-                                        <p:tgtEl>
-                                          <p:spTgt spid="40"/>
-                                        </p:tgtEl>
-                                        <p:attrNameLst>
-                                          <p:attrName>style.visibility</p:attrName>
-                                        </p:attrNameLst>
-                                      </p:cBhvr>
-                                      <p:to>
-                                        <p:strVal val="visible"/>
-                                      </p:to>
-                                    </p:set>
-                                    <p:animEffect transition="in" filter="fade">
-                                      <p:cBhvr>
-                                        <p:cTn id="58" dur="500"/>
-                                        <p:tgtEl>
                                           <p:spTgt spid="40"/>
                                         </p:tgtEl>
                                       </p:cBhvr>
@@ -30694,14 +30874,14 @@
                                 </p:cTn>
                               </p:par>
                               <p:par>
-                                <p:cTn id="59" presetID="10" presetClass="entr" presetSubtype="0" fill="hold" nodeType="withEffect">
+                                <p:cTn id="54" presetID="10" presetClass="entr" presetSubtype="0" fill="hold" nodeType="withEffect">
                                   <p:stCondLst>
                                     <p:cond delay="0"/>
                                   </p:stCondLst>
                                   <p:childTnLst>
                                     <p:set>
                                       <p:cBhvr>
-                                        <p:cTn id="60" dur="1" fill="hold">
+                                        <p:cTn id="55" dur="1" fill="hold">
                                           <p:stCondLst>
                                             <p:cond delay="0"/>
                                           </p:stCondLst>
@@ -30719,7 +30899,7 @@
                                     </p:set>
                                     <p:animEffect transition="in" filter="fade">
                                       <p:cBhvr>
-                                        <p:cTn id="61" dur="500"/>
+                                        <p:cTn id="56" dur="500"/>
                                         <p:tgtEl>
                                           <p:spTgt spid="43"/>
                                         </p:tgtEl>
@@ -30729,14 +30909,14 @@
                                 </p:cTn>
                               </p:par>
                               <p:par>
-                                <p:cTn id="62" presetID="10" presetClass="entr" presetSubtype="0" fill="hold" nodeType="withEffect">
+                                <p:cTn id="57" presetID="10" presetClass="entr" presetSubtype="0" fill="hold" nodeType="withEffect">
                                   <p:stCondLst>
                                     <p:cond delay="0"/>
                                   </p:stCondLst>
                                   <p:childTnLst>
                                     <p:set>
                                       <p:cBhvr>
-                                        <p:cTn id="63" dur="1" fill="hold">
+                                        <p:cTn id="58" dur="1" fill="hold">
                                           <p:stCondLst>
                                             <p:cond delay="0"/>
                                           </p:stCondLst>
@@ -30754,7 +30934,7 @@
                                     </p:set>
                                     <p:animEffect transition="in" filter="fade">
                                       <p:cBhvr>
-                                        <p:cTn id="64" dur="500"/>
+                                        <p:cTn id="59" dur="500"/>
                                         <p:tgtEl>
                                           <p:spTgt spid="42"/>
                                         </p:tgtEl>
@@ -30764,14 +30944,14 @@
                                 </p:cTn>
                               </p:par>
                               <p:par>
-                                <p:cTn id="65" presetID="10" presetClass="entr" presetSubtype="0" fill="hold" nodeType="withEffect">
+                                <p:cTn id="60" presetID="10" presetClass="entr" presetSubtype="0" fill="hold" nodeType="withEffect">
                                   <p:stCondLst>
                                     <p:cond delay="0"/>
                                   </p:stCondLst>
                                   <p:childTnLst>
                                     <p:set>
                                       <p:cBhvr>
-                                        <p:cTn id="66" dur="1" fill="hold">
+                                        <p:cTn id="61" dur="1" fill="hold">
                                           <p:stCondLst>
                                             <p:cond delay="0"/>
                                           </p:stCondLst>
@@ -30789,9 +30969,44 @@
                                     </p:set>
                                     <p:animEffect transition="in" filter="fade">
                                       <p:cBhvr>
-                                        <p:cTn id="67" dur="500"/>
+                                        <p:cTn id="62" dur="500"/>
                                         <p:tgtEl>
                                           <p:spTgt spid="41"/>
+                                        </p:tgtEl>
+                                      </p:cBhvr>
+                                    </p:animEffect>
+                                  </p:childTnLst>
+                                </p:cTn>
+                              </p:par>
+                              <p:par>
+                                <p:cTn id="63" presetID="10" presetClass="entr" presetSubtype="0" fill="hold" nodeType="withEffect">
+                                  <p:stCondLst>
+                                    <p:cond delay="0"/>
+                                  </p:stCondLst>
+                                  <p:childTnLst>
+                                    <p:set>
+                                      <p:cBhvr>
+                                        <p:cTn id="64" dur="1" fill="hold">
+                                          <p:stCondLst>
+                                            <p:cond delay="0"/>
+                                          </p:stCondLst>
+                                        </p:cTn>
+                                        <p:tgtEl>
+                                          <p:spTgt spid="19"/>
+                                        </p:tgtEl>
+                                        <p:attrNameLst>
+                                          <p:attrName>style.visibility</p:attrName>
+                                        </p:attrNameLst>
+                                      </p:cBhvr>
+                                      <p:to>
+                                        <p:strVal val="visible"/>
+                                      </p:to>
+                                    </p:set>
+                                    <p:animEffect transition="in" filter="fade">
+                                      <p:cBhvr>
+                                        <p:cTn id="65" dur="500"/>
+                                        <p:tgtEl>
+                                          <p:spTgt spid="19"/>
                                         </p:tgtEl>
                                       </p:cBhvr>
                                     </p:animEffect>
@@ -30955,7 +31170,7 @@
                   <a:srgbClr val="8E6F3E"/>
                 </a:solidFill>
               </a:rPr>
-              <a:t xml:space="preserve">DECISION      </a:t>
+              <a:t>DECISION      </a:t>
             </a:r>
             <a:r>
               <a:rPr sz="2000" b="0" i="0">
@@ -31046,7 +31261,7 @@
           <a:p>
             <a:pPr algn="l"/>
             <a:r>
-              <a:rPr sz="2000" b="1" i="0">
+              <a:rPr sz="2000" b="1" i="0" dirty="0">
                 <a:solidFill>
                   <a:srgbClr val="5C4826"/>
                 </a:solidFill>
@@ -31055,9 +31270,12 @@
             </a:r>
           </a:p>
           <a:p>
-            <a:pPr algn="l"/>
-            <a:r>
-              <a:rPr sz="2000" b="0" i="0">
+            <a:pPr marL="342900" indent="-225425" algn="l">
+              <a:buFont typeface="Arial" panose="020B0604020202020204" pitchFamily="34" charset="0"/>
+              <a:buChar char="•"/>
+            </a:pPr>
+            <a:r>
+              <a:rPr sz="2000" b="0" i="0" dirty="0">
                 <a:solidFill>
                   <a:srgbClr val="5C4826"/>
                 </a:solidFill>
@@ -31066,9 +31284,12 @@
             </a:r>
           </a:p>
           <a:p>
-            <a:pPr algn="l"/>
-            <a:r>
-              <a:rPr sz="2000" b="0" i="0">
+            <a:pPr marL="342900" indent="-225425" algn="l">
+              <a:buFont typeface="Arial" panose="020B0604020202020204" pitchFamily="34" charset="0"/>
+              <a:buChar char="•"/>
+            </a:pPr>
+            <a:r>
+              <a:rPr sz="2000" b="0" i="0" dirty="0">
                 <a:solidFill>
                   <a:srgbClr val="5C4826"/>
                 </a:solidFill>
@@ -31122,7 +31343,7 @@
           <a:p>
             <a:pPr algn="l"/>
             <a:r>
-              <a:rPr sz="2000" b="1" i="0">
+              <a:rPr sz="2000" b="1" i="0" dirty="0">
                 <a:solidFill>
                   <a:srgbClr val="5C4826"/>
                 </a:solidFill>
@@ -31131,9 +31352,12 @@
             </a:r>
           </a:p>
           <a:p>
-            <a:pPr algn="l"/>
-            <a:r>
-              <a:rPr sz="2000" b="0" i="0">
+            <a:pPr marL="342900" indent="-157163" algn="l">
+              <a:buFont typeface="Arial" panose="020B0604020202020204" pitchFamily="34" charset="0"/>
+              <a:buChar char="•"/>
+            </a:pPr>
+            <a:r>
+              <a:rPr sz="2000" b="0" i="0" dirty="0">
                 <a:solidFill>
                   <a:srgbClr val="5C4826"/>
                 </a:solidFill>
@@ -31142,9 +31366,12 @@
             </a:r>
           </a:p>
           <a:p>
-            <a:pPr algn="l"/>
-            <a:r>
-              <a:rPr sz="2000" b="0" i="0">
+            <a:pPr marL="342900" indent="-157163" algn="l">
+              <a:buFont typeface="Arial" panose="020B0604020202020204" pitchFamily="34" charset="0"/>
+              <a:buChar char="•"/>
+            </a:pPr>
+            <a:r>
+              <a:rPr sz="2000" b="0" i="0" dirty="0">
                 <a:solidFill>
                   <a:srgbClr val="5C4826"/>
                 </a:solidFill>
@@ -31183,7 +31410,7 @@
                   <a:srgbClr val="8E6F3E"/>
                 </a:solidFill>
               </a:rPr>
-              <a:t xml:space="preserve">KNOWN      </a:t>
+              <a:t>KNOWN      </a:t>
             </a:r>
             <a:r>
               <a:rPr sz="2000" b="0" i="0">
@@ -31225,7 +31452,7 @@
                   <a:srgbClr val="8E6F3E"/>
                 </a:solidFill>
               </a:rPr>
-              <a:t xml:space="preserve">UNCERTAIN      </a:t>
+              <a:t>UNCERTAIN      </a:t>
             </a:r>
             <a:r>
               <a:rPr sz="2000" b="0" i="0">
@@ -31336,13 +31563,26 @@
           <a:p>
             <a:pPr algn="ctr"/>
             <a:r>
-              <a:rPr sz="2000" b="0" i="0">
+              <a:rPr sz="2000" b="0" i="0" dirty="0">
                 <a:solidFill>
                   <a:srgbClr val="5C4826"/>
                 </a:solidFill>
               </a:rPr>
-              <a:t>Run both under a representative workload; compare the latency distributions.</a:t>
-            </a:r>
+              <a:t>Run both under a representative workload; compare the latency distributions</a:t>
+            </a:r>
+            <a:r>
+              <a:rPr lang="en-US" sz="2000" b="0" i="0" dirty="0">
+                <a:solidFill>
+                  <a:srgbClr val="5C4826"/>
+                </a:solidFill>
+              </a:rPr>
+              <a:t>?</a:t>
+            </a:r>
+            <a:endParaRPr sz="2000" b="0" i="0" dirty="0">
+              <a:solidFill>
+                <a:srgbClr val="5C4826"/>
+              </a:solidFill>
+            </a:endParaRPr>
           </a:p>
         </p:txBody>
       </p:sp>

</xml_diff>